<commit_message>
feta: added python type
</commit_message>
<xml_diff>
--- a/assets/images.pptx
+++ b/assets/images.pptx
@@ -193,31 +193,6 @@
 3️⃣ package: Helps you understand where your module lives in a project.
 🇺🇸 Level up your Python skills! 🇩🇪 Python-Variablen einfach erklärt!
 #Python #CodingTips #Backend #SoftwareEngineering #Germany #USA #Deutschland #Programming #CodeWithEbrahim</a:t>
-        </a:r>
-      </a:p>
-    </p188:txBody>
-  </p188:cm>
-</p188:cmLst>
-</file>
-
-<file path=ppt/comments/modernComment_117_532A238D.xml><?xml version="1.0" encoding="utf-8"?>
-<p188:cmLst xmlns:a="http://schemas.openxmlformats.org/drawingml/2006/main" xmlns:r="http://schemas.openxmlformats.org/officeDocument/2006/relationships" xmlns:p188="http://schemas.microsoft.com/office/powerpoint/2018/8/main">
-  <p188:cm id="{C2077823-D24A-8947-B4FE-B579AFEE0A3A}" authorId="{8860045D-B334-310D-0A4E-9E20AA0B149E}" created="2026-01-03T21:47:30.016">
-    <pc:sldMkLst xmlns:pc="http://schemas.microsoft.com/office/powerpoint/2013/main/command">
-      <pc:docMk/>
-      <pc:sldMk cId="1395270541" sldId="279"/>
-    </pc:sldMkLst>
-    <p188:txBody>
-      <a:bodyPr/>
-      <a:lstStyle/>
-      <a:p>
-        <a:r>
-          <a:rPr lang="en-DE"/>
-          <a:t>Youtube
-Title: Why you should switch to Pathlib! 🐍
-Working with file paths doesn't have to be ugly. pathlib makes your code readable and object-oriented. No more messy strings!
-🚀 Pro Tip: Use the / operator to join paths easily.
-#Python #CleanCode #Pathlib #SoftwareEngineering #ProgrammingTips #CodingLife #Backend #CodeWithEbrahim</a:t>
         </a:r>
       </a:p>
     </p188:txBody>
@@ -7679,7 +7654,7 @@
     <p:bg>
       <p:bgPr>
         <a:blipFill>
-          <a:blip r:embed="rId4"/>
+          <a:blip r:embed="rId3"/>
           <a:tile tx="0" ty="0" sx="100000" sy="100000" flip="none" algn="tl"/>
         </a:blipFill>
         <a:effectLst/>
@@ -7755,6 +7730,26 @@
           <a:p>
             <a:pPr algn="ctr"/>
             <a:r>
+              <a:rPr lang="en-GB" sz="7200" b="1" dirty="0">
+                <a:ln w="6600">
+                  <a:solidFill>
+                    <a:schemeClr val="accent2"/>
+                  </a:solidFill>
+                  <a:prstDash val="solid"/>
+                </a:ln>
+                <a:solidFill>
+                  <a:srgbClr val="FFFFFF"/>
+                </a:solidFill>
+                <a:effectLst>
+                  <a:outerShdw dist="38100" dir="2700000" algn="tl" rotWithShape="0">
+                    <a:schemeClr val="accent2"/>
+                  </a:outerShdw>
+                </a:effectLst>
+                <a:latin typeface="+mj-lt"/>
+              </a:rPr>
+              <a:t>t</a:t>
+            </a:r>
+            <a:r>
               <a:rPr lang="en-DE" sz="7200" b="1" dirty="0">
                 <a:ln w="6600">
                   <a:solidFill>
@@ -7772,7 +7767,7 @@
                 </a:effectLst>
                 <a:latin typeface="+mj-lt"/>
               </a:rPr>
-              <a:t>pathlib</a:t>
+              <a:t>ype()</a:t>
             </a:r>
             <a:endParaRPr lang="en-DE" sz="7200" dirty="0">
               <a:ln w="0"/>
@@ -7803,7 +7798,7 @@
           <p:nvPr/>
         </p:nvPicPr>
         <p:blipFill>
-          <a:blip r:embed="rId5"/>
+          <a:blip r:embed="rId4"/>
           <a:stretch>
             <a:fillRect/>
           </a:stretch>
@@ -7818,57 +7813,12 @@
           </a:prstGeom>
         </p:spPr>
       </p:pic>
-      <p:cxnSp>
-        <p:nvCxnSpPr>
-          <p:cNvPr id="16" name="Straight Connector 15">
-            <a:extLst>
-              <a:ext uri="{FF2B5EF4-FFF2-40B4-BE49-F238E27FC236}">
-                <a16:creationId xmlns:a16="http://schemas.microsoft.com/office/drawing/2014/main" id="{F3E6C352-2A47-650A-9234-C3DF3F810C43}"/>
-              </a:ext>
-            </a:extLst>
-          </p:cNvPr>
-          <p:cNvCxnSpPr>
-            <a:cxnSpLocks/>
-          </p:cNvCxnSpPr>
-          <p:nvPr/>
-        </p:nvCxnSpPr>
-        <p:spPr>
-          <a:xfrm>
-            <a:off x="223579" y="10334423"/>
-            <a:ext cx="9838255" cy="0"/>
-          </a:xfrm>
-          <a:prstGeom prst="line">
-            <a:avLst/>
-          </a:prstGeom>
-          <a:ln w="38100">
-            <a:solidFill>
-              <a:schemeClr val="bg1"/>
-            </a:solidFill>
-            <a:headEnd type="none"/>
-            <a:tailEnd type="none" w="lg" len="lg"/>
-          </a:ln>
-        </p:spPr>
-        <p:style>
-          <a:lnRef idx="1">
-            <a:schemeClr val="accent1"/>
-          </a:lnRef>
-          <a:fillRef idx="0">
-            <a:schemeClr val="accent1"/>
-          </a:fillRef>
-          <a:effectRef idx="0">
-            <a:schemeClr val="accent1"/>
-          </a:effectRef>
-          <a:fontRef idx="minor">
-            <a:schemeClr val="tx1"/>
-          </a:fontRef>
-        </p:style>
-      </p:cxnSp>
       <p:pic>
         <p:nvPicPr>
-          <p:cNvPr id="18" name="Graphic 17" descr="Shield Tick with solid fill">
-            <a:extLst>
-              <a:ext uri="{FF2B5EF4-FFF2-40B4-BE49-F238E27FC236}">
-                <a16:creationId xmlns:a16="http://schemas.microsoft.com/office/drawing/2014/main" id="{2D6D7F89-C47E-56C4-9355-13A359543B8D}"/>
+          <p:cNvPr id="3" name="Picture 2">
+            <a:extLst>
+              <a:ext uri="{FF2B5EF4-FFF2-40B4-BE49-F238E27FC236}">
+                <a16:creationId xmlns:a16="http://schemas.microsoft.com/office/drawing/2014/main" id="{5AEC6DC4-7CE8-6BA0-8C15-EC7F128FBAD8}"/>
               </a:ext>
             </a:extLst>
           </p:cNvPr>
@@ -7877,316 +7827,23 @@
           </p:cNvPicPr>
           <p:nvPr/>
         </p:nvPicPr>
-        <p:blipFill>
-          <a:blip r:embed="rId6">
-            <a:extLst>
-              <a:ext uri="{96DAC541-7B7A-43D3-8B79-37D633B846F1}">
-                <asvg:svgBlip xmlns:asvg="http://schemas.microsoft.com/office/drawing/2016/SVG/main" r:embed="rId7"/>
-              </a:ext>
-            </a:extLst>
-          </a:blip>
+        <p:blipFill rotWithShape="1">
+          <a:blip r:embed="rId5"/>
+          <a:srcRect l="16861" t="20373" r="23923" b="14691"/>
           <a:stretch>
             <a:fillRect/>
           </a:stretch>
         </p:blipFill>
         <p:spPr>
           <a:xfrm>
-            <a:off x="7668075" y="12764125"/>
-            <a:ext cx="914400" cy="914400"/>
+            <a:off x="223306" y="6135709"/>
+            <a:ext cx="9838800" cy="8549356"/>
           </a:xfrm>
           <a:prstGeom prst="rect">
             <a:avLst/>
           </a:prstGeom>
         </p:spPr>
       </p:pic>
-      <p:pic>
-        <p:nvPicPr>
-          <p:cNvPr id="19" name="Graphic 18" descr="Close with solid fill">
-            <a:extLst>
-              <a:ext uri="{FF2B5EF4-FFF2-40B4-BE49-F238E27FC236}">
-                <a16:creationId xmlns:a16="http://schemas.microsoft.com/office/drawing/2014/main" id="{ADFF07AD-5C5D-EBE3-F7F1-7D805603E5BE}"/>
-              </a:ext>
-            </a:extLst>
-          </p:cNvPr>
-          <p:cNvPicPr>
-            <a:picLocks noChangeAspect="1"/>
-          </p:cNvPicPr>
-          <p:nvPr/>
-        </p:nvPicPr>
-        <p:blipFill>
-          <a:blip r:embed="rId8">
-            <a:extLst>
-              <a:ext uri="{96DAC541-7B7A-43D3-8B79-37D633B846F1}">
-                <asvg:svgBlip xmlns:asvg="http://schemas.microsoft.com/office/drawing/2016/SVG/main" r:embed="rId9"/>
-              </a:ext>
-            </a:extLst>
-          </a:blip>
-          <a:stretch>
-            <a:fillRect/>
-          </a:stretch>
-        </p:blipFill>
-        <p:spPr>
-          <a:xfrm>
-            <a:off x="7668075" y="7980445"/>
-            <a:ext cx="914400" cy="914400"/>
-          </a:xfrm>
-          <a:prstGeom prst="rect">
-            <a:avLst/>
-          </a:prstGeom>
-        </p:spPr>
-      </p:pic>
-      <p:sp>
-        <p:nvSpPr>
-          <p:cNvPr id="20" name="TextBox 19">
-            <a:extLst>
-              <a:ext uri="{FF2B5EF4-FFF2-40B4-BE49-F238E27FC236}">
-                <a16:creationId xmlns:a16="http://schemas.microsoft.com/office/drawing/2014/main" id="{DD1EF262-28AB-179A-F611-B5A8CFF9D9DB}"/>
-              </a:ext>
-            </a:extLst>
-          </p:cNvPr>
-          <p:cNvSpPr txBox="1"/>
-          <p:nvPr/>
-        </p:nvSpPr>
-        <p:spPr>
-          <a:xfrm>
-            <a:off x="213487" y="14792806"/>
-            <a:ext cx="2040815" cy="646331"/>
-          </a:xfrm>
-          <a:prstGeom prst="rect">
-            <a:avLst/>
-          </a:prstGeom>
-          <a:noFill/>
-        </p:spPr>
-        <p:txBody>
-          <a:bodyPr wrap="none" rtlCol="0">
-            <a:spAutoFit/>
-          </a:bodyPr>
-          <a:lstStyle/>
-          <a:p>
-            <a:r>
-              <a:rPr lang="en-GB" sz="3600" dirty="0">
-                <a:solidFill>
-                  <a:schemeClr val="bg1"/>
-                </a:solidFill>
-              </a:rPr>
-              <a:t>Readable:</a:t>
-            </a:r>
-            <a:endParaRPr lang="en-DE" sz="3600" dirty="0">
-              <a:solidFill>
-                <a:schemeClr val="bg1"/>
-              </a:solidFill>
-            </a:endParaRPr>
-          </a:p>
-        </p:txBody>
-      </p:sp>
-      <p:sp>
-        <p:nvSpPr>
-          <p:cNvPr id="21" name="TextBox 20">
-            <a:extLst>
-              <a:ext uri="{FF2B5EF4-FFF2-40B4-BE49-F238E27FC236}">
-                <a16:creationId xmlns:a16="http://schemas.microsoft.com/office/drawing/2014/main" id="{DEA5BC88-F15A-3738-DE5E-7E3E6AF2D763}"/>
-              </a:ext>
-            </a:extLst>
-          </p:cNvPr>
-          <p:cNvSpPr txBox="1"/>
-          <p:nvPr/>
-        </p:nvSpPr>
-        <p:spPr>
-          <a:xfrm>
-            <a:off x="2365380" y="14792806"/>
-            <a:ext cx="7706546" cy="707886"/>
-          </a:xfrm>
-          <a:prstGeom prst="rect">
-            <a:avLst/>
-          </a:prstGeom>
-          <a:noFill/>
-        </p:spPr>
-        <p:txBody>
-          <a:bodyPr wrap="square" rtlCol="0">
-            <a:spAutoFit/>
-          </a:bodyPr>
-          <a:lstStyle/>
-          <a:p>
-            <a:r>
-              <a:rPr lang="en-GB" sz="4000" dirty="0">
-                <a:latin typeface="Patrick Hand" pitchFamily="2" charset="77"/>
-              </a:rPr>
-              <a:t>Use the / operator to join paths easily.</a:t>
-            </a:r>
-            <a:endParaRPr lang="en-DE" sz="4000" dirty="0">
-              <a:latin typeface="Patrick Hand" pitchFamily="2" charset="77"/>
-            </a:endParaRPr>
-          </a:p>
-        </p:txBody>
-      </p:sp>
-      <p:sp>
-        <p:nvSpPr>
-          <p:cNvPr id="23" name="TextBox 22">
-            <a:extLst>
-              <a:ext uri="{FF2B5EF4-FFF2-40B4-BE49-F238E27FC236}">
-                <a16:creationId xmlns:a16="http://schemas.microsoft.com/office/drawing/2014/main" id="{F691A230-89C2-97BC-EA0B-5A1547026FC2}"/>
-              </a:ext>
-            </a:extLst>
-          </p:cNvPr>
-          <p:cNvSpPr txBox="1"/>
-          <p:nvPr/>
-        </p:nvSpPr>
-        <p:spPr>
-          <a:xfrm>
-            <a:off x="2365380" y="15612948"/>
-            <a:ext cx="6327171" cy="707886"/>
-          </a:xfrm>
-          <a:prstGeom prst="rect">
-            <a:avLst/>
-          </a:prstGeom>
-          <a:noFill/>
-        </p:spPr>
-        <p:txBody>
-          <a:bodyPr wrap="square" rtlCol="0">
-            <a:spAutoFit/>
-          </a:bodyPr>
-          <a:lstStyle/>
-          <a:p>
-            <a:r>
-              <a:rPr lang="en-GB" sz="4000" dirty="0">
-                <a:latin typeface="Patrick Hand" pitchFamily="2" charset="77"/>
-              </a:rPr>
-              <a:t>Auto-handles Windows vs. Linux</a:t>
-            </a:r>
-            <a:endParaRPr lang="en-DE" sz="4000" dirty="0">
-              <a:latin typeface="Patrick Hand" pitchFamily="2" charset="77"/>
-            </a:endParaRPr>
-          </a:p>
-        </p:txBody>
-      </p:sp>
-      <p:sp>
-        <p:nvSpPr>
-          <p:cNvPr id="24" name="TextBox 23">
-            <a:extLst>
-              <a:ext uri="{FF2B5EF4-FFF2-40B4-BE49-F238E27FC236}">
-                <a16:creationId xmlns:a16="http://schemas.microsoft.com/office/drawing/2014/main" id="{88EEEC48-48C2-1866-EF77-F57F21472377}"/>
-              </a:ext>
-            </a:extLst>
-          </p:cNvPr>
-          <p:cNvSpPr txBox="1"/>
-          <p:nvPr/>
-        </p:nvSpPr>
-        <p:spPr>
-          <a:xfrm>
-            <a:off x="2365379" y="16433090"/>
-            <a:ext cx="7706545" cy="707886"/>
-          </a:xfrm>
-          <a:prstGeom prst="rect">
-            <a:avLst/>
-          </a:prstGeom>
-          <a:noFill/>
-        </p:spPr>
-        <p:txBody>
-          <a:bodyPr wrap="square" rtlCol="0">
-            <a:spAutoFit/>
-          </a:bodyPr>
-          <a:lstStyle/>
-          <a:p>
-            <a:r>
-              <a:rPr lang="en-GB" sz="4000" dirty="0">
-                <a:latin typeface="Patrick Hand" pitchFamily="2" charset="77"/>
-              </a:rPr>
-              <a:t>Everything is an object, not just a string.</a:t>
-            </a:r>
-            <a:endParaRPr lang="en-DE" sz="4000" dirty="0">
-              <a:latin typeface="Patrick Hand" pitchFamily="2" charset="77"/>
-            </a:endParaRPr>
-          </a:p>
-        </p:txBody>
-      </p:sp>
-      <p:sp>
-        <p:nvSpPr>
-          <p:cNvPr id="25" name="TextBox 24">
-            <a:extLst>
-              <a:ext uri="{FF2B5EF4-FFF2-40B4-BE49-F238E27FC236}">
-                <a16:creationId xmlns:a16="http://schemas.microsoft.com/office/drawing/2014/main" id="{358B2339-07F2-9A25-79CD-9BB6EA178151}"/>
-              </a:ext>
-            </a:extLst>
-          </p:cNvPr>
-          <p:cNvSpPr txBox="1"/>
-          <p:nvPr/>
-        </p:nvSpPr>
-        <p:spPr>
-          <a:xfrm>
-            <a:off x="213487" y="15612948"/>
-            <a:ext cx="1423788" cy="646331"/>
-          </a:xfrm>
-          <a:prstGeom prst="rect">
-            <a:avLst/>
-          </a:prstGeom>
-          <a:noFill/>
-        </p:spPr>
-        <p:txBody>
-          <a:bodyPr wrap="none" rtlCol="0">
-            <a:spAutoFit/>
-          </a:bodyPr>
-          <a:lstStyle/>
-          <a:p>
-            <a:r>
-              <a:rPr lang="en-GB" sz="3600" dirty="0">
-                <a:solidFill>
-                  <a:schemeClr val="bg1"/>
-                </a:solidFill>
-              </a:rPr>
-              <a:t>Smart:</a:t>
-            </a:r>
-            <a:endParaRPr lang="en-DE" sz="3600" dirty="0">
-              <a:solidFill>
-                <a:schemeClr val="bg1"/>
-              </a:solidFill>
-            </a:endParaRPr>
-          </a:p>
-        </p:txBody>
-      </p:sp>
-      <p:sp>
-        <p:nvSpPr>
-          <p:cNvPr id="26" name="TextBox 25">
-            <a:extLst>
-              <a:ext uri="{FF2B5EF4-FFF2-40B4-BE49-F238E27FC236}">
-                <a16:creationId xmlns:a16="http://schemas.microsoft.com/office/drawing/2014/main" id="{B16A6396-DD35-DF1E-72A6-426DA90CEC4D}"/>
-              </a:ext>
-            </a:extLst>
-          </p:cNvPr>
-          <p:cNvSpPr txBox="1"/>
-          <p:nvPr/>
-        </p:nvSpPr>
-        <p:spPr>
-          <a:xfrm>
-            <a:off x="213487" y="16433090"/>
-            <a:ext cx="1984198" cy="646331"/>
-          </a:xfrm>
-          <a:prstGeom prst="rect">
-            <a:avLst/>
-          </a:prstGeom>
-          <a:noFill/>
-        </p:spPr>
-        <p:txBody>
-          <a:bodyPr wrap="none" rtlCol="0">
-            <a:spAutoFit/>
-          </a:bodyPr>
-          <a:lstStyle/>
-          <a:p>
-            <a:r>
-              <a:rPr lang="en-GB" sz="3600" dirty="0">
-                <a:solidFill>
-                  <a:schemeClr val="bg1"/>
-                </a:solidFill>
-              </a:rPr>
-              <a:t>Powerful:</a:t>
-            </a:r>
-            <a:endParaRPr lang="en-DE" sz="3600" dirty="0">
-              <a:solidFill>
-                <a:schemeClr val="bg1"/>
-              </a:solidFill>
-            </a:endParaRPr>
-          </a:p>
-        </p:txBody>
-      </p:sp>
     </p:spTree>
     <p:extLst>
       <p:ext uri="{BB962C8B-B14F-4D97-AF65-F5344CB8AC3E}">
@@ -8197,11 +7854,6 @@
   <p:clrMapOvr>
     <a:masterClrMapping/>
   </p:clrMapOvr>
-  <p:extLst>
-    <p:ext uri="{6950BFC3-D8DA-4A85-94F7-54DA5524770B}">
-      <p188:commentRel xmlns:p188="http://schemas.microsoft.com/office/powerpoint/2018/8/main" r:id="rId3"/>
-    </p:ext>
-  </p:extLst>
 </p:sld>
 </file>
 

</xml_diff>

<commit_message>
feat: changed react and add a pyhton code
</commit_message>
<xml_diff>
--- a/assets/images.pptx
+++ b/assets/images.pptx
@@ -9412,6 +9412,42 @@
           <a:chExt cx="0" cy="0"/>
         </a:xfrm>
       </p:grpSpPr>
+      <p:pic>
+        <p:nvPicPr>
+          <p:cNvPr id="2" name="Picture 1">
+            <a:extLst>
+              <a:ext uri="{FF2B5EF4-FFF2-40B4-BE49-F238E27FC236}">
+                <a16:creationId xmlns:a16="http://schemas.microsoft.com/office/drawing/2014/main" id="{A18CD963-890F-C0FB-2CEA-0581E4029033}"/>
+              </a:ext>
+            </a:extLst>
+          </p:cNvPr>
+          <p:cNvPicPr>
+            <a:picLocks noChangeAspect="1"/>
+          </p:cNvPicPr>
+          <p:nvPr/>
+        </p:nvPicPr>
+        <p:blipFill rotWithShape="1">
+          <a:blip r:embed="rId4"/>
+          <a:srcRect l="13860" t="15730" r="9843" b="9716"/>
+          <a:stretch>
+            <a:fillRect/>
+          </a:stretch>
+        </p:blipFill>
+        <p:spPr>
+          <a:xfrm>
+            <a:off x="223306" y="6012973"/>
+            <a:ext cx="9838800" cy="8340750"/>
+          </a:xfrm>
+          <a:prstGeom prst="rect">
+            <a:avLst/>
+          </a:prstGeom>
+          <a:ln w="25400">
+            <a:solidFill>
+              <a:schemeClr val="bg1"/>
+            </a:solidFill>
+          </a:ln>
+        </p:spPr>
+      </p:pic>
       <p:sp>
         <p:nvSpPr>
           <p:cNvPr id="38" name="TextBox 37">
@@ -9432,7 +9468,11 @@
           <a:prstGeom prst="rect">
             <a:avLst/>
           </a:prstGeom>
-          <a:ln/>
+          <a:ln w="25400">
+            <a:solidFill>
+              <a:schemeClr val="bg1"/>
+            </a:solidFill>
+          </a:ln>
         </p:spPr>
         <p:style>
           <a:lnRef idx="0">
@@ -9482,7 +9522,7 @@
                 </a:effectLst>
                 <a:latin typeface="Patrick Hand" pitchFamily="2" charset="77"/>
               </a:rPr>
-              <a:t>Truthiness</a:t>
+              <a:t>Palindrome Hack</a:t>
             </a:r>
             <a:endParaRPr lang="en-GB" b="1" dirty="0">
               <a:ln w="0"/>
@@ -9516,7 +9556,7 @@
           <p:nvPr/>
         </p:nvPicPr>
         <p:blipFill>
-          <a:blip r:embed="rId4"/>
+          <a:blip r:embed="rId5"/>
           <a:stretch>
             <a:fillRect/>
           </a:stretch>
@@ -9547,7 +9587,7 @@
         </p:nvCxnSpPr>
         <p:spPr>
           <a:xfrm>
-            <a:off x="223579" y="12343974"/>
+            <a:off x="223579" y="11751310"/>
             <a:ext cx="9838255" cy="0"/>
           </a:xfrm>
           <a:prstGeom prst="line">
@@ -9591,10 +9631,10 @@
           <p:nvPr/>
         </p:nvPicPr>
         <p:blipFill>
-          <a:blip r:embed="rId5">
+          <a:blip r:embed="rId6">
             <a:extLst>
               <a:ext uri="{96DAC541-7B7A-43D3-8B79-37D633B846F1}">
-                <asvg:svgBlip xmlns:asvg="http://schemas.microsoft.com/office/drawing/2016/SVG/main" r:embed="rId6"/>
+                <asvg:svgBlip xmlns:asvg="http://schemas.microsoft.com/office/drawing/2016/SVG/main" r:embed="rId7"/>
               </a:ext>
             </a:extLst>
           </a:blip>
@@ -9627,10 +9667,10 @@
           <p:nvPr/>
         </p:nvPicPr>
         <p:blipFill>
-          <a:blip r:embed="rId7">
+          <a:blip r:embed="rId8">
             <a:extLst>
               <a:ext uri="{96DAC541-7B7A-43D3-8B79-37D633B846F1}">
-                <asvg:svgBlip xmlns:asvg="http://schemas.microsoft.com/office/drawing/2016/SVG/main" r:embed="rId8"/>
+                <asvg:svgBlip xmlns:asvg="http://schemas.microsoft.com/office/drawing/2016/SVG/main" r:embed="rId9"/>
               </a:ext>
             </a:extLst>
           </a:blip>
@@ -9640,7 +9680,7 @@
         </p:blipFill>
         <p:spPr>
           <a:xfrm>
-            <a:off x="7668075" y="8352587"/>
+            <a:off x="7668075" y="9114585"/>
             <a:ext cx="914400" cy="914400"/>
           </a:xfrm>
           <a:prstGeom prst="rect">

</xml_diff>

<commit_message>
feat: added img:py_005-008 shorts:py_022
</commit_message>
<xml_diff>
--- a/assets/images.pptx
+++ b/assets/images.pptx
@@ -551,7 +551,7 @@
           <a:p>
             <a:fld id="{CEF57384-5D6E-7E42-90C4-560B39EF53DD}" type="datetimeFigureOut">
               <a:rPr lang="en-DE" smtClean="0"/>
-              <a:t>18.01.26</a:t>
+              <a:t>26.01.26</a:t>
             </a:fld>
             <a:endParaRPr lang="en-DE"/>
           </a:p>
@@ -1181,7 +1181,7 @@
             <a:fld id="{48A87A34-81AB-432B-8DAE-1953F412C126}" type="datetimeFigureOut">
               <a:rPr lang="en-US" smtClean="0"/>
               <a:pPr/>
-              <a:t>1/18/26</a:t>
+              <a:t>1/26/26</a:t>
             </a:fld>
             <a:endParaRPr lang="en-US" dirty="0"/>
           </a:p>
@@ -1351,7 +1351,7 @@
           <a:p>
             <a:fld id="{48A87A34-81AB-432B-8DAE-1953F412C126}" type="datetimeFigureOut">
               <a:rPr lang="en-US" smtClean="0"/>
-              <a:t>1/18/26</a:t>
+              <a:t>1/26/26</a:t>
             </a:fld>
             <a:endParaRPr lang="en-US" dirty="0"/>
           </a:p>
@@ -1531,7 +1531,7 @@
           <a:p>
             <a:fld id="{48A87A34-81AB-432B-8DAE-1953F412C126}" type="datetimeFigureOut">
               <a:rPr lang="en-US" smtClean="0"/>
-              <a:t>1/18/26</a:t>
+              <a:t>1/26/26</a:t>
             </a:fld>
             <a:endParaRPr lang="en-US" dirty="0"/>
           </a:p>
@@ -1764,7 +1764,7 @@
             <a:fld id="{48A87A34-81AB-432B-8DAE-1953F412C126}" type="datetimeFigureOut">
               <a:rPr lang="en-US" smtClean="0"/>
               <a:pPr/>
-              <a:t>1/18/26</a:t>
+              <a:t>1/26/26</a:t>
             </a:fld>
             <a:endParaRPr lang="en-US" dirty="0"/>
           </a:p>
@@ -2037,7 +2037,7 @@
           <a:p>
             <a:fld id="{48A87A34-81AB-432B-8DAE-1953F412C126}" type="datetimeFigureOut">
               <a:rPr lang="en-US" smtClean="0"/>
-              <a:t>1/18/26</a:t>
+              <a:t>1/26/26</a:t>
             </a:fld>
             <a:endParaRPr lang="en-US" dirty="0"/>
           </a:p>
@@ -2269,7 +2269,7 @@
           <a:p>
             <a:fld id="{48A87A34-81AB-432B-8DAE-1953F412C126}" type="datetimeFigureOut">
               <a:rPr lang="en-US" smtClean="0"/>
-              <a:t>1/18/26</a:t>
+              <a:t>1/26/26</a:t>
             </a:fld>
             <a:endParaRPr lang="en-US" dirty="0"/>
           </a:p>
@@ -2636,7 +2636,7 @@
           <a:p>
             <a:fld id="{48A87A34-81AB-432B-8DAE-1953F412C126}" type="datetimeFigureOut">
               <a:rPr lang="en-US" smtClean="0"/>
-              <a:t>1/18/26</a:t>
+              <a:t>1/26/26</a:t>
             </a:fld>
             <a:endParaRPr lang="en-US" dirty="0"/>
           </a:p>
@@ -2754,7 +2754,7 @@
           <a:p>
             <a:fld id="{48A87A34-81AB-432B-8DAE-1953F412C126}" type="datetimeFigureOut">
               <a:rPr lang="en-US" smtClean="0"/>
-              <a:t>1/18/26</a:t>
+              <a:t>1/26/26</a:t>
             </a:fld>
             <a:endParaRPr lang="en-US" dirty="0"/>
           </a:p>
@@ -2849,7 +2849,7 @@
           <a:p>
             <a:fld id="{48A87A34-81AB-432B-8DAE-1953F412C126}" type="datetimeFigureOut">
               <a:rPr lang="en-US" smtClean="0"/>
-              <a:t>1/18/26</a:t>
+              <a:t>1/26/26</a:t>
             </a:fld>
             <a:endParaRPr lang="en-US" dirty="0"/>
           </a:p>
@@ -3126,7 +3126,7 @@
           <a:p>
             <a:fld id="{48A87A34-81AB-432B-8DAE-1953F412C126}" type="datetimeFigureOut">
               <a:rPr lang="en-US" smtClean="0"/>
-              <a:t>1/18/26</a:t>
+              <a:t>1/26/26</a:t>
             </a:fld>
             <a:endParaRPr lang="en-US" dirty="0"/>
           </a:p>
@@ -3383,7 +3383,7 @@
           <a:p>
             <a:fld id="{48A87A34-81AB-432B-8DAE-1953F412C126}" type="datetimeFigureOut">
               <a:rPr lang="en-US" smtClean="0"/>
-              <a:t>1/18/26</a:t>
+              <a:t>1/26/26</a:t>
             </a:fld>
             <a:endParaRPr lang="en-US" dirty="0"/>
           </a:p>
@@ -3597,7 +3597,7 @@
             <a:fld id="{48A87A34-81AB-432B-8DAE-1953F412C126}" type="datetimeFigureOut">
               <a:rPr lang="en-US" smtClean="0"/>
               <a:pPr/>
-              <a:t>1/18/26</a:t>
+              <a:t>1/26/26</a:t>
             </a:fld>
             <a:endParaRPr lang="en-US" dirty="0"/>
           </a:p>
@@ -9813,25 +9813,7 @@
               <a:pPr algn="ctr"/>
               <a:r>
                 <a:rPr lang="en-GB" sz="6600" dirty="0"/>
-                <a:t>is None </a:t>
-              </a:r>
-              <a:r>
-                <a:rPr lang="en-GB" sz="6600" b="1" dirty="0">
-                  <a:ln w="22225">
-                    <a:solidFill>
-                      <a:schemeClr val="accent2"/>
-                    </a:solidFill>
-                    <a:prstDash val="solid"/>
-                  </a:ln>
-                  <a:solidFill>
-                    <a:srgbClr val="00B0F0"/>
-                  </a:solidFill>
-                </a:rPr>
-                <a:t>vs</a:t>
-              </a:r>
-              <a:r>
-                <a:rPr lang="en-GB" sz="6600" dirty="0"/>
-                <a:t> == None</a:t>
+                <a:t>String Slicing Basics</a:t>
               </a:r>
               <a:endParaRPr lang="en-GB" b="1" dirty="0">
                 <a:ln w="0"/>
@@ -9881,250 +9863,6 @@
           </p:spPr>
         </p:pic>
       </p:grpSp>
-      <p:sp>
-        <p:nvSpPr>
-          <p:cNvPr id="7" name="TextBox 6">
-            <a:extLst>
-              <a:ext uri="{FF2B5EF4-FFF2-40B4-BE49-F238E27FC236}">
-                <a16:creationId xmlns:a16="http://schemas.microsoft.com/office/drawing/2014/main" id="{4726C78F-5842-BADA-97BD-2A58BA5E5C84}"/>
-              </a:ext>
-            </a:extLst>
-          </p:cNvPr>
-          <p:cNvSpPr txBox="1"/>
-          <p:nvPr/>
-        </p:nvSpPr>
-        <p:spPr>
-          <a:xfrm>
-            <a:off x="223306" y="13997209"/>
-            <a:ext cx="1727909" cy="707886"/>
-          </a:xfrm>
-          <a:prstGeom prst="rect">
-            <a:avLst/>
-          </a:prstGeom>
-          <a:noFill/>
-        </p:spPr>
-        <p:txBody>
-          <a:bodyPr wrap="none" rtlCol="0">
-            <a:spAutoFit/>
-          </a:bodyPr>
-          <a:lstStyle/>
-          <a:p>
-            <a:r>
-              <a:rPr lang="en-GB" sz="4000" b="1" dirty="0"/>
-              <a:t>Faster:</a:t>
-            </a:r>
-            <a:r>
-              <a:rPr lang="en-GB" sz="4000" dirty="0"/>
-              <a:t> </a:t>
-            </a:r>
-            <a:endParaRPr lang="en-DE" sz="4000" dirty="0"/>
-          </a:p>
-        </p:txBody>
-      </p:sp>
-      <p:sp>
-        <p:nvSpPr>
-          <p:cNvPr id="11" name="TextBox 10">
-            <a:extLst>
-              <a:ext uri="{FF2B5EF4-FFF2-40B4-BE49-F238E27FC236}">
-                <a16:creationId xmlns:a16="http://schemas.microsoft.com/office/drawing/2014/main" id="{3B956DD6-0D86-8B09-E89A-759DDDD3D6BC}"/>
-              </a:ext>
-            </a:extLst>
-          </p:cNvPr>
-          <p:cNvSpPr txBox="1"/>
-          <p:nvPr/>
-        </p:nvSpPr>
-        <p:spPr>
-          <a:xfrm>
-            <a:off x="2609831" y="13997209"/>
-            <a:ext cx="7315200" cy="707886"/>
-          </a:xfrm>
-          <a:prstGeom prst="rect">
-            <a:avLst/>
-          </a:prstGeom>
-          <a:noFill/>
-        </p:spPr>
-        <p:txBody>
-          <a:bodyPr wrap="square" rtlCol="0">
-            <a:spAutoFit/>
-          </a:bodyPr>
-          <a:lstStyle/>
-          <a:p>
-            <a:r>
-              <a:rPr lang="en-GB" sz="4000" dirty="0">
-                <a:latin typeface="Patrick Hand" pitchFamily="2" charset="77"/>
-              </a:rPr>
-              <a:t>Uses memory address comparison</a:t>
-            </a:r>
-            <a:endParaRPr lang="en-DE" sz="4000" dirty="0">
-              <a:latin typeface="Patrick Hand" pitchFamily="2" charset="77"/>
-            </a:endParaRPr>
-          </a:p>
-        </p:txBody>
-      </p:sp>
-      <p:sp>
-        <p:nvSpPr>
-          <p:cNvPr id="8" name="TextBox 7">
-            <a:extLst>
-              <a:ext uri="{FF2B5EF4-FFF2-40B4-BE49-F238E27FC236}">
-                <a16:creationId xmlns:a16="http://schemas.microsoft.com/office/drawing/2014/main" id="{46D9AEC7-81A8-D8FA-9B3F-D7975BB39742}"/>
-              </a:ext>
-            </a:extLst>
-          </p:cNvPr>
-          <p:cNvSpPr txBox="1"/>
-          <p:nvPr/>
-        </p:nvSpPr>
-        <p:spPr>
-          <a:xfrm>
-            <a:off x="223306" y="15080308"/>
-            <a:ext cx="1527406" cy="707886"/>
-          </a:xfrm>
-          <a:prstGeom prst="rect">
-            <a:avLst/>
-          </a:prstGeom>
-          <a:noFill/>
-        </p:spPr>
-        <p:txBody>
-          <a:bodyPr wrap="none" rtlCol="0">
-            <a:spAutoFit/>
-          </a:bodyPr>
-          <a:lstStyle/>
-          <a:p>
-            <a:r>
-              <a:rPr lang="en-GB" sz="4000" b="1" dirty="0"/>
-              <a:t>Safer: </a:t>
-            </a:r>
-            <a:endParaRPr lang="en-DE" sz="4000" b="1" dirty="0"/>
-          </a:p>
-        </p:txBody>
-      </p:sp>
-      <p:sp>
-        <p:nvSpPr>
-          <p:cNvPr id="12" name="TextBox 11">
-            <a:extLst>
-              <a:ext uri="{FF2B5EF4-FFF2-40B4-BE49-F238E27FC236}">
-                <a16:creationId xmlns:a16="http://schemas.microsoft.com/office/drawing/2014/main" id="{A2A4893F-4945-B7EB-1C1A-4AFCB0335910}"/>
-              </a:ext>
-            </a:extLst>
-          </p:cNvPr>
-          <p:cNvSpPr txBox="1"/>
-          <p:nvPr/>
-        </p:nvSpPr>
-        <p:spPr>
-          <a:xfrm>
-            <a:off x="2609831" y="15070832"/>
-            <a:ext cx="7315200" cy="707886"/>
-          </a:xfrm>
-          <a:prstGeom prst="rect">
-            <a:avLst/>
-          </a:prstGeom>
-          <a:noFill/>
-        </p:spPr>
-        <p:txBody>
-          <a:bodyPr wrap="square" rtlCol="0">
-            <a:spAutoFit/>
-          </a:bodyPr>
-          <a:lstStyle/>
-          <a:p>
-            <a:r>
-              <a:rPr lang="en-GB" sz="4000" dirty="0">
-                <a:latin typeface="Patrick Hand" pitchFamily="2" charset="77"/>
-              </a:rPr>
-              <a:t>Avoids custom --</a:t>
-            </a:r>
-            <a:r>
-              <a:rPr lang="en-GB" sz="4000" dirty="0" err="1">
-                <a:latin typeface="Patrick Hand" pitchFamily="2" charset="77"/>
-              </a:rPr>
-              <a:t>eq</a:t>
-            </a:r>
-            <a:r>
-              <a:rPr lang="en-GB" sz="4000" dirty="0">
-                <a:latin typeface="Patrick Hand" pitchFamily="2" charset="77"/>
-              </a:rPr>
-              <a:t>-- method bugs</a:t>
-            </a:r>
-            <a:endParaRPr lang="en-DE" sz="4000" dirty="0">
-              <a:latin typeface="Patrick Hand" pitchFamily="2" charset="77"/>
-            </a:endParaRPr>
-          </a:p>
-        </p:txBody>
-      </p:sp>
-      <p:sp>
-        <p:nvSpPr>
-          <p:cNvPr id="9" name="TextBox 8">
-            <a:extLst>
-              <a:ext uri="{FF2B5EF4-FFF2-40B4-BE49-F238E27FC236}">
-                <a16:creationId xmlns:a16="http://schemas.microsoft.com/office/drawing/2014/main" id="{B266C270-8250-9E8C-0C34-1C95D283B5CB}"/>
-              </a:ext>
-            </a:extLst>
-          </p:cNvPr>
-          <p:cNvSpPr txBox="1"/>
-          <p:nvPr/>
-        </p:nvSpPr>
-        <p:spPr>
-          <a:xfrm>
-            <a:off x="223306" y="16163407"/>
-            <a:ext cx="2310120" cy="707886"/>
-          </a:xfrm>
-          <a:prstGeom prst="rect">
-            <a:avLst/>
-          </a:prstGeom>
-          <a:noFill/>
-        </p:spPr>
-        <p:txBody>
-          <a:bodyPr wrap="none" rtlCol="0">
-            <a:spAutoFit/>
-          </a:bodyPr>
-          <a:lstStyle/>
-          <a:p>
-            <a:r>
-              <a:rPr lang="en-GB" sz="4000" b="1" dirty="0"/>
-              <a:t>Pythonic: </a:t>
-            </a:r>
-            <a:endParaRPr lang="en-DE" sz="4000" b="1" dirty="0"/>
-          </a:p>
-        </p:txBody>
-      </p:sp>
-      <p:sp>
-        <p:nvSpPr>
-          <p:cNvPr id="13" name="TextBox 12">
-            <a:extLst>
-              <a:ext uri="{FF2B5EF4-FFF2-40B4-BE49-F238E27FC236}">
-                <a16:creationId xmlns:a16="http://schemas.microsoft.com/office/drawing/2014/main" id="{AD66807C-E3C5-9589-B831-282432DEFF7E}"/>
-              </a:ext>
-            </a:extLst>
-          </p:cNvPr>
-          <p:cNvSpPr txBox="1"/>
-          <p:nvPr/>
-        </p:nvSpPr>
-        <p:spPr>
-          <a:xfrm>
-            <a:off x="2609831" y="16144456"/>
-            <a:ext cx="7314747" cy="707886"/>
-          </a:xfrm>
-          <a:prstGeom prst="rect">
-            <a:avLst/>
-          </a:prstGeom>
-          <a:noFill/>
-        </p:spPr>
-        <p:txBody>
-          <a:bodyPr wrap="square" rtlCol="0">
-            <a:spAutoFit/>
-          </a:bodyPr>
-          <a:lstStyle/>
-          <a:p>
-            <a:r>
-              <a:rPr lang="en-GB" sz="4000" dirty="0">
-                <a:latin typeface="Patrick Hand" pitchFamily="2" charset="77"/>
-              </a:rPr>
-              <a:t>Follows the official PEP 8 standard</a:t>
-            </a:r>
-            <a:endParaRPr lang="en-DE" sz="4000" dirty="0">
-              <a:latin typeface="Patrick Hand" pitchFamily="2" charset="77"/>
-            </a:endParaRPr>
-          </a:p>
-        </p:txBody>
-      </p:sp>
       <p:cxnSp>
         <p:nvCxnSpPr>
           <p:cNvPr id="17" name="Straight Connector 16">
@@ -10170,78 +9908,1552 @@
           </a:fontRef>
         </p:style>
       </p:cxnSp>
-      <p:pic>
-        <p:nvPicPr>
-          <p:cNvPr id="18" name="Graphic 17" descr="Shield Tick with solid fill">
-            <a:extLst>
-              <a:ext uri="{FF2B5EF4-FFF2-40B4-BE49-F238E27FC236}">
-                <a16:creationId xmlns:a16="http://schemas.microsoft.com/office/drawing/2014/main" id="{C66AB981-805B-D3EA-B666-79A9BBF3F4F9}"/>
-              </a:ext>
-            </a:extLst>
-          </p:cNvPr>
-          <p:cNvPicPr>
-            <a:picLocks noChangeAspect="1"/>
-          </p:cNvPicPr>
+      <p:graphicFrame>
+        <p:nvGraphicFramePr>
+          <p:cNvPr id="2" name="Table 1">
+            <a:extLst>
+              <a:ext uri="{FF2B5EF4-FFF2-40B4-BE49-F238E27FC236}">
+                <a16:creationId xmlns:a16="http://schemas.microsoft.com/office/drawing/2014/main" id="{AFFCB3D2-5FF9-D262-2045-1017C7DFA743}"/>
+              </a:ext>
+            </a:extLst>
+          </p:cNvPr>
+          <p:cNvGraphicFramePr>
+            <a:graphicFrameLocks noGrp="1"/>
+          </p:cNvGraphicFramePr>
+          <p:nvPr>
+            <p:extLst>
+              <p:ext uri="{D42A27DB-BD31-4B8C-83A1-F6EECF244321}">
+                <p14:modId xmlns:p14="http://schemas.microsoft.com/office/powerpoint/2010/main" val="1187538916"/>
+              </p:ext>
+            </p:extLst>
+          </p:nvPr>
+        </p:nvGraphicFramePr>
+        <p:xfrm>
+          <a:off x="1845733" y="6385692"/>
+          <a:ext cx="7707580" cy="914400"/>
+        </p:xfrm>
+        <a:graphic>
+          <a:graphicData uri="http://schemas.openxmlformats.org/drawingml/2006/table">
+            <a:tbl>
+              <a:tblPr firstRow="1" bandRow="1">
+                <a:tableStyleId>{5C22544A-7EE6-4342-B048-85BDC9FD1C3A}</a:tableStyleId>
+              </a:tblPr>
+              <a:tblGrid>
+                <a:gridCol w="1926895">
+                  <a:extLst>
+                    <a:ext uri="{9D8B030D-6E8A-4147-A177-3AD203B41FA5}">
+                      <a16:colId xmlns:a16="http://schemas.microsoft.com/office/drawing/2014/main" val="2355591543"/>
+                    </a:ext>
+                  </a:extLst>
+                </a:gridCol>
+                <a:gridCol w="1926895">
+                  <a:extLst>
+                    <a:ext uri="{9D8B030D-6E8A-4147-A177-3AD203B41FA5}">
+                      <a16:colId xmlns:a16="http://schemas.microsoft.com/office/drawing/2014/main" val="1690173566"/>
+                    </a:ext>
+                  </a:extLst>
+                </a:gridCol>
+                <a:gridCol w="1926895">
+                  <a:extLst>
+                    <a:ext uri="{9D8B030D-6E8A-4147-A177-3AD203B41FA5}">
+                      <a16:colId xmlns:a16="http://schemas.microsoft.com/office/drawing/2014/main" val="434348016"/>
+                    </a:ext>
+                  </a:extLst>
+                </a:gridCol>
+                <a:gridCol w="1926895">
+                  <a:extLst>
+                    <a:ext uri="{9D8B030D-6E8A-4147-A177-3AD203B41FA5}">
+                      <a16:colId xmlns:a16="http://schemas.microsoft.com/office/drawing/2014/main" val="1805346127"/>
+                    </a:ext>
+                  </a:extLst>
+                </a:gridCol>
+              </a:tblGrid>
+              <a:tr h="370840">
+                <a:tc>
+                  <a:txBody>
+                    <a:bodyPr/>
+                    <a:lstStyle/>
+                    <a:p>
+                      <a:pPr algn="ctr"/>
+                      <a:r>
+                        <a:rPr lang="en-DE" sz="2400" b="1" i="0" dirty="0">
+                          <a:latin typeface="Arial Narrow" panose="020B0604020202020204" pitchFamily="34" charset="0"/>
+                          <a:cs typeface="Arial Narrow" panose="020B0604020202020204" pitchFamily="34" charset="0"/>
+                        </a:rPr>
+                        <a:t>0</a:t>
+                      </a:r>
+                    </a:p>
+                  </a:txBody>
+                  <a:tcPr/>
+                </a:tc>
+                <a:tc>
+                  <a:txBody>
+                    <a:bodyPr/>
+                    <a:lstStyle/>
+                    <a:p>
+                      <a:pPr algn="ctr"/>
+                      <a:r>
+                        <a:rPr lang="en-DE" sz="2400" b="1" i="0" dirty="0">
+                          <a:latin typeface="Arial Narrow" panose="020B0604020202020204" pitchFamily="34" charset="0"/>
+                          <a:cs typeface="Arial Narrow" panose="020B0604020202020204" pitchFamily="34" charset="0"/>
+                        </a:rPr>
+                        <a:t>1</a:t>
+                      </a:r>
+                    </a:p>
+                  </a:txBody>
+                  <a:tcPr/>
+                </a:tc>
+                <a:tc>
+                  <a:txBody>
+                    <a:bodyPr/>
+                    <a:lstStyle/>
+                    <a:p>
+                      <a:pPr algn="ctr"/>
+                      <a:r>
+                        <a:rPr lang="en-DE" sz="2400" b="1" i="0" dirty="0">
+                          <a:latin typeface="Arial Narrow" panose="020B0604020202020204" pitchFamily="34" charset="0"/>
+                          <a:cs typeface="Arial Narrow" panose="020B0604020202020204" pitchFamily="34" charset="0"/>
+                        </a:rPr>
+                        <a:t>2</a:t>
+                      </a:r>
+                    </a:p>
+                  </a:txBody>
+                  <a:tcPr/>
+                </a:tc>
+                <a:tc>
+                  <a:txBody>
+                    <a:bodyPr/>
+                    <a:lstStyle/>
+                    <a:p>
+                      <a:pPr algn="ctr"/>
+                      <a:r>
+                        <a:rPr lang="en-DE" sz="2400" b="1" i="0" dirty="0">
+                          <a:latin typeface="Arial Narrow" panose="020B0604020202020204" pitchFamily="34" charset="0"/>
+                          <a:cs typeface="Arial Narrow" panose="020B0604020202020204" pitchFamily="34" charset="0"/>
+                        </a:rPr>
+                        <a:t>3</a:t>
+                      </a:r>
+                    </a:p>
+                  </a:txBody>
+                  <a:tcPr/>
+                </a:tc>
+                <a:extLst>
+                  <a:ext uri="{0D108BD9-81ED-4DB2-BD59-A6C34878D82A}">
+                    <a16:rowId xmlns:a16="http://schemas.microsoft.com/office/drawing/2014/main" val="3813841085"/>
+                  </a:ext>
+                </a:extLst>
+              </a:tr>
+              <a:tr h="370840">
+                <a:tc>
+                  <a:txBody>
+                    <a:bodyPr/>
+                    <a:lstStyle/>
+                    <a:p>
+                      <a:pPr algn="ctr"/>
+                      <a:r>
+                        <a:rPr lang="en-DE" sz="2400" b="1" i="0" dirty="0">
+                          <a:latin typeface="Arial Narrow" panose="020B0604020202020204" pitchFamily="34" charset="0"/>
+                          <a:cs typeface="Arial Narrow" panose="020B0604020202020204" pitchFamily="34" charset="0"/>
+                        </a:rPr>
+                        <a:t>a</a:t>
+                      </a:r>
+                    </a:p>
+                  </a:txBody>
+                  <a:tcPr>
+                    <a:solidFill>
+                      <a:schemeClr val="accent6"/>
+                    </a:solidFill>
+                  </a:tcPr>
+                </a:tc>
+                <a:tc>
+                  <a:txBody>
+                    <a:bodyPr/>
+                    <a:lstStyle/>
+                    <a:p>
+                      <a:pPr algn="ctr"/>
+                      <a:r>
+                        <a:rPr lang="en-DE" sz="2400" b="1" i="0" dirty="0">
+                          <a:latin typeface="Arial Narrow" panose="020B0604020202020204" pitchFamily="34" charset="0"/>
+                          <a:cs typeface="Arial Narrow" panose="020B0604020202020204" pitchFamily="34" charset="0"/>
+                        </a:rPr>
+                        <a:t>b</a:t>
+                      </a:r>
+                    </a:p>
+                  </a:txBody>
+                  <a:tcPr>
+                    <a:solidFill>
+                      <a:schemeClr val="accent6"/>
+                    </a:solidFill>
+                  </a:tcPr>
+                </a:tc>
+                <a:tc>
+                  <a:txBody>
+                    <a:bodyPr/>
+                    <a:lstStyle/>
+                    <a:p>
+                      <a:pPr algn="ctr"/>
+                      <a:r>
+                        <a:rPr lang="en-DE" sz="2400" b="1" i="0" dirty="0">
+                          <a:latin typeface="Arial Narrow" panose="020B0604020202020204" pitchFamily="34" charset="0"/>
+                          <a:cs typeface="Arial Narrow" panose="020B0604020202020204" pitchFamily="34" charset="0"/>
+                        </a:rPr>
+                        <a:t>c</a:t>
+                      </a:r>
+                    </a:p>
+                  </a:txBody>
+                  <a:tcPr>
+                    <a:solidFill>
+                      <a:schemeClr val="accent6"/>
+                    </a:solidFill>
+                  </a:tcPr>
+                </a:tc>
+                <a:tc>
+                  <a:txBody>
+                    <a:bodyPr/>
+                    <a:lstStyle/>
+                    <a:p>
+                      <a:pPr algn="ctr"/>
+                      <a:r>
+                        <a:rPr lang="en-DE" sz="2400" b="1" i="0" dirty="0">
+                          <a:latin typeface="Arial Narrow" panose="020B0604020202020204" pitchFamily="34" charset="0"/>
+                          <a:cs typeface="Arial Narrow" panose="020B0604020202020204" pitchFamily="34" charset="0"/>
+                        </a:rPr>
+                        <a:t>d</a:t>
+                      </a:r>
+                    </a:p>
+                  </a:txBody>
+                  <a:tcPr>
+                    <a:solidFill>
+                      <a:schemeClr val="accent6"/>
+                    </a:solidFill>
+                  </a:tcPr>
+                </a:tc>
+                <a:extLst>
+                  <a:ext uri="{0D108BD9-81ED-4DB2-BD59-A6C34878D82A}">
+                    <a16:rowId xmlns:a16="http://schemas.microsoft.com/office/drawing/2014/main" val="2392955628"/>
+                  </a:ext>
+                </a:extLst>
+              </a:tr>
+            </a:tbl>
+          </a:graphicData>
+        </a:graphic>
+      </p:graphicFrame>
+      <p:sp>
+        <p:nvSpPr>
+          <p:cNvPr id="3" name="TextBox 2">
+            <a:extLst>
+              <a:ext uri="{FF2B5EF4-FFF2-40B4-BE49-F238E27FC236}">
+                <a16:creationId xmlns:a16="http://schemas.microsoft.com/office/drawing/2014/main" id="{9EC7C18B-40B8-CB03-83D0-6EF76086C752}"/>
+              </a:ext>
+            </a:extLst>
+          </p:cNvPr>
+          <p:cNvSpPr txBox="1"/>
           <p:nvPr/>
-        </p:nvPicPr>
-        <p:blipFill>
-          <a:blip r:embed="rId3">
-            <a:extLst>
-              <a:ext uri="{96DAC541-7B7A-43D3-8B79-37D633B846F1}">
-                <asvg:svgBlip xmlns:asvg="http://schemas.microsoft.com/office/drawing/2016/SVG/main" r:embed="rId4"/>
-              </a:ext>
-            </a:extLst>
-          </a:blip>
-          <a:stretch>
-            <a:fillRect/>
-          </a:stretch>
-        </p:blipFill>
-        <p:spPr>
-          <a:xfrm>
-            <a:off x="7668075" y="10904066"/>
-            <a:ext cx="914400" cy="914400"/>
+        </p:nvSpPr>
+        <p:spPr>
+          <a:xfrm>
+            <a:off x="264001" y="6385692"/>
+            <a:ext cx="385042" cy="707886"/>
           </a:xfrm>
           <a:prstGeom prst="rect">
             <a:avLst/>
           </a:prstGeom>
-        </p:spPr>
-      </p:pic>
-      <p:pic>
-        <p:nvPicPr>
-          <p:cNvPr id="19" name="Graphic 18" descr="Close with solid fill">
-            <a:extLst>
-              <a:ext uri="{FF2B5EF4-FFF2-40B4-BE49-F238E27FC236}">
-                <a16:creationId xmlns:a16="http://schemas.microsoft.com/office/drawing/2014/main" id="{A5EA347C-65F5-100D-F091-6637F8AA15E0}"/>
-              </a:ext>
-            </a:extLst>
-          </p:cNvPr>
-          <p:cNvPicPr>
-            <a:picLocks noChangeAspect="1"/>
-          </p:cNvPicPr>
+          <a:noFill/>
+        </p:spPr>
+        <p:txBody>
+          <a:bodyPr wrap="none" rtlCol="0">
+            <a:spAutoFit/>
+          </a:bodyPr>
+          <a:lstStyle>
+            <a:defPPr>
+              <a:defRPr lang="en-US"/>
+            </a:defPPr>
+            <a:lvl1pPr>
+              <a:defRPr sz="4000"/>
+            </a:lvl1pPr>
+          </a:lstStyle>
+          <a:p>
+            <a:r>
+              <a:rPr lang="en-DE" dirty="0"/>
+              <a:t>s</a:t>
+            </a:r>
+          </a:p>
+        </p:txBody>
+      </p:sp>
+      <p:graphicFrame>
+        <p:nvGraphicFramePr>
+          <p:cNvPr id="6" name="Table 5">
+            <a:extLst>
+              <a:ext uri="{FF2B5EF4-FFF2-40B4-BE49-F238E27FC236}">
+                <a16:creationId xmlns:a16="http://schemas.microsoft.com/office/drawing/2014/main" id="{5EA12227-B0D3-4EAD-2455-E46D187DE5F0}"/>
+              </a:ext>
+            </a:extLst>
+          </p:cNvPr>
+          <p:cNvGraphicFramePr>
+            <a:graphicFrameLocks noGrp="1"/>
+          </p:cNvGraphicFramePr>
+          <p:nvPr>
+            <p:extLst>
+              <p:ext uri="{D42A27DB-BD31-4B8C-83A1-F6EECF244321}">
+                <p14:modId xmlns:p14="http://schemas.microsoft.com/office/powerpoint/2010/main" val="673093885"/>
+              </p:ext>
+            </p:extLst>
+          </p:nvPr>
+        </p:nvGraphicFramePr>
+        <p:xfrm>
+          <a:off x="1811867" y="8293877"/>
+          <a:ext cx="7707580" cy="914400"/>
+        </p:xfrm>
+        <a:graphic>
+          <a:graphicData uri="http://schemas.openxmlformats.org/drawingml/2006/table">
+            <a:tbl>
+              <a:tblPr firstRow="1" bandRow="1">
+                <a:tableStyleId>{5C22544A-7EE6-4342-B048-85BDC9FD1C3A}</a:tableStyleId>
+              </a:tblPr>
+              <a:tblGrid>
+                <a:gridCol w="1926895">
+                  <a:extLst>
+                    <a:ext uri="{9D8B030D-6E8A-4147-A177-3AD203B41FA5}">
+                      <a16:colId xmlns:a16="http://schemas.microsoft.com/office/drawing/2014/main" val="2355591543"/>
+                    </a:ext>
+                  </a:extLst>
+                </a:gridCol>
+                <a:gridCol w="1926895">
+                  <a:extLst>
+                    <a:ext uri="{9D8B030D-6E8A-4147-A177-3AD203B41FA5}">
+                      <a16:colId xmlns:a16="http://schemas.microsoft.com/office/drawing/2014/main" val="1690173566"/>
+                    </a:ext>
+                  </a:extLst>
+                </a:gridCol>
+                <a:gridCol w="1926895">
+                  <a:extLst>
+                    <a:ext uri="{9D8B030D-6E8A-4147-A177-3AD203B41FA5}">
+                      <a16:colId xmlns:a16="http://schemas.microsoft.com/office/drawing/2014/main" val="434348016"/>
+                    </a:ext>
+                  </a:extLst>
+                </a:gridCol>
+                <a:gridCol w="1926895">
+                  <a:extLst>
+                    <a:ext uri="{9D8B030D-6E8A-4147-A177-3AD203B41FA5}">
+                      <a16:colId xmlns:a16="http://schemas.microsoft.com/office/drawing/2014/main" val="1805346127"/>
+                    </a:ext>
+                  </a:extLst>
+                </a:gridCol>
+              </a:tblGrid>
+              <a:tr h="370840">
+                <a:tc>
+                  <a:txBody>
+                    <a:bodyPr/>
+                    <a:lstStyle/>
+                    <a:p>
+                      <a:pPr algn="ctr"/>
+                      <a:r>
+                        <a:rPr lang="en-DE" sz="2400" b="1" i="0" dirty="0">
+                          <a:latin typeface="Arial Narrow" panose="020B0604020202020204" pitchFamily="34" charset="0"/>
+                          <a:cs typeface="Arial Narrow" panose="020B0604020202020204" pitchFamily="34" charset="0"/>
+                        </a:rPr>
+                        <a:t>0</a:t>
+                      </a:r>
+                    </a:p>
+                  </a:txBody>
+                  <a:tcPr/>
+                </a:tc>
+                <a:tc>
+                  <a:txBody>
+                    <a:bodyPr/>
+                    <a:lstStyle/>
+                    <a:p>
+                      <a:pPr algn="ctr"/>
+                      <a:r>
+                        <a:rPr lang="en-DE" sz="2400" b="1" i="0" dirty="0">
+                          <a:latin typeface="Arial Narrow" panose="020B0604020202020204" pitchFamily="34" charset="0"/>
+                          <a:cs typeface="Arial Narrow" panose="020B0604020202020204" pitchFamily="34" charset="0"/>
+                        </a:rPr>
+                        <a:t>1</a:t>
+                      </a:r>
+                    </a:p>
+                  </a:txBody>
+                  <a:tcPr/>
+                </a:tc>
+                <a:tc>
+                  <a:txBody>
+                    <a:bodyPr/>
+                    <a:lstStyle/>
+                    <a:p>
+                      <a:pPr algn="ctr"/>
+                      <a:r>
+                        <a:rPr lang="en-DE" sz="2400" b="1" i="0" dirty="0">
+                          <a:latin typeface="Arial Narrow" panose="020B0604020202020204" pitchFamily="34" charset="0"/>
+                          <a:cs typeface="Arial Narrow" panose="020B0604020202020204" pitchFamily="34" charset="0"/>
+                        </a:rPr>
+                        <a:t>2</a:t>
+                      </a:r>
+                    </a:p>
+                  </a:txBody>
+                  <a:tcPr/>
+                </a:tc>
+                <a:tc>
+                  <a:txBody>
+                    <a:bodyPr/>
+                    <a:lstStyle/>
+                    <a:p>
+                      <a:pPr algn="ctr"/>
+                      <a:r>
+                        <a:rPr lang="en-DE" sz="2400" b="1" i="0" dirty="0">
+                          <a:latin typeface="Arial Narrow" panose="020B0604020202020204" pitchFamily="34" charset="0"/>
+                          <a:cs typeface="Arial Narrow" panose="020B0604020202020204" pitchFamily="34" charset="0"/>
+                        </a:rPr>
+                        <a:t>3</a:t>
+                      </a:r>
+                    </a:p>
+                  </a:txBody>
+                  <a:tcPr/>
+                </a:tc>
+                <a:extLst>
+                  <a:ext uri="{0D108BD9-81ED-4DB2-BD59-A6C34878D82A}">
+                    <a16:rowId xmlns:a16="http://schemas.microsoft.com/office/drawing/2014/main" val="3813841085"/>
+                  </a:ext>
+                </a:extLst>
+              </a:tr>
+              <a:tr h="370840">
+                <a:tc>
+                  <a:txBody>
+                    <a:bodyPr/>
+                    <a:lstStyle/>
+                    <a:p>
+                      <a:pPr algn="ctr"/>
+                      <a:r>
+                        <a:rPr lang="en-DE" sz="2400" b="1" i="0" dirty="0">
+                          <a:latin typeface="Arial Narrow" panose="020B0604020202020204" pitchFamily="34" charset="0"/>
+                          <a:cs typeface="Arial Narrow" panose="020B0604020202020204" pitchFamily="34" charset="0"/>
+                        </a:rPr>
+                        <a:t>a</a:t>
+                      </a:r>
+                    </a:p>
+                  </a:txBody>
+                  <a:tcPr/>
+                </a:tc>
+                <a:tc>
+                  <a:txBody>
+                    <a:bodyPr/>
+                    <a:lstStyle/>
+                    <a:p>
+                      <a:pPr algn="ctr"/>
+                      <a:r>
+                        <a:rPr lang="en-DE" sz="2400" b="1" i="0" dirty="0">
+                          <a:latin typeface="Arial Narrow" panose="020B0604020202020204" pitchFamily="34" charset="0"/>
+                          <a:cs typeface="Arial Narrow" panose="020B0604020202020204" pitchFamily="34" charset="0"/>
+                        </a:rPr>
+                        <a:t>b</a:t>
+                      </a:r>
+                    </a:p>
+                  </a:txBody>
+                  <a:tcPr>
+                    <a:solidFill>
+                      <a:schemeClr val="accent6"/>
+                    </a:solidFill>
+                  </a:tcPr>
+                </a:tc>
+                <a:tc>
+                  <a:txBody>
+                    <a:bodyPr/>
+                    <a:lstStyle/>
+                    <a:p>
+                      <a:pPr algn="ctr"/>
+                      <a:r>
+                        <a:rPr lang="en-DE" sz="2400" b="1" i="0" dirty="0">
+                          <a:latin typeface="Arial Narrow" panose="020B0604020202020204" pitchFamily="34" charset="0"/>
+                          <a:cs typeface="Arial Narrow" panose="020B0604020202020204" pitchFamily="34" charset="0"/>
+                        </a:rPr>
+                        <a:t>c</a:t>
+                      </a:r>
+                    </a:p>
+                  </a:txBody>
+                  <a:tcPr>
+                    <a:solidFill>
+                      <a:schemeClr val="accent6"/>
+                    </a:solidFill>
+                  </a:tcPr>
+                </a:tc>
+                <a:tc>
+                  <a:txBody>
+                    <a:bodyPr/>
+                    <a:lstStyle/>
+                    <a:p>
+                      <a:pPr algn="ctr"/>
+                      <a:r>
+                        <a:rPr lang="en-DE" sz="2400" b="1" i="0" dirty="0">
+                          <a:latin typeface="Arial Narrow" panose="020B0604020202020204" pitchFamily="34" charset="0"/>
+                          <a:cs typeface="Arial Narrow" panose="020B0604020202020204" pitchFamily="34" charset="0"/>
+                        </a:rPr>
+                        <a:t>d</a:t>
+                      </a:r>
+                    </a:p>
+                  </a:txBody>
+                  <a:tcPr>
+                    <a:solidFill>
+                      <a:schemeClr val="accent6"/>
+                    </a:solidFill>
+                  </a:tcPr>
+                </a:tc>
+                <a:extLst>
+                  <a:ext uri="{0D108BD9-81ED-4DB2-BD59-A6C34878D82A}">
+                    <a16:rowId xmlns:a16="http://schemas.microsoft.com/office/drawing/2014/main" val="2392955628"/>
+                  </a:ext>
+                </a:extLst>
+              </a:tr>
+            </a:tbl>
+          </a:graphicData>
+        </a:graphic>
+      </p:graphicFrame>
+      <p:sp>
+        <p:nvSpPr>
+          <p:cNvPr id="10" name="TextBox 9">
+            <a:extLst>
+              <a:ext uri="{FF2B5EF4-FFF2-40B4-BE49-F238E27FC236}">
+                <a16:creationId xmlns:a16="http://schemas.microsoft.com/office/drawing/2014/main" id="{941E6B91-5F6A-233B-FDBA-EA6FC517D39C}"/>
+              </a:ext>
+            </a:extLst>
+          </p:cNvPr>
+          <p:cNvSpPr txBox="1"/>
           <p:nvPr/>
-        </p:nvPicPr>
-        <p:blipFill>
-          <a:blip r:embed="rId5">
-            <a:extLst>
-              <a:ext uri="{96DAC541-7B7A-43D3-8B79-37D633B846F1}">
-                <asvg:svgBlip xmlns:asvg="http://schemas.microsoft.com/office/drawing/2016/SVG/main" r:embed="rId6"/>
-              </a:ext>
-            </a:extLst>
-          </a:blip>
-          <a:stretch>
-            <a:fillRect/>
-          </a:stretch>
-        </p:blipFill>
-        <p:spPr>
-          <a:xfrm>
-            <a:off x="7668075" y="8826753"/>
-            <a:ext cx="914400" cy="914400"/>
+        </p:nvSpPr>
+        <p:spPr>
+          <a:xfrm>
+            <a:off x="264001" y="8398026"/>
+            <a:ext cx="1356462" cy="707886"/>
           </a:xfrm>
           <a:prstGeom prst="rect">
             <a:avLst/>
           </a:prstGeom>
-        </p:spPr>
-      </p:pic>
+          <a:noFill/>
+        </p:spPr>
+        <p:txBody>
+          <a:bodyPr wrap="none" rtlCol="0">
+            <a:spAutoFit/>
+          </a:bodyPr>
+          <a:lstStyle/>
+          <a:p>
+            <a:pPr algn="l"/>
+            <a:r>
+              <a:rPr lang="en-GB" sz="4000" dirty="0"/>
+              <a:t>s</a:t>
+            </a:r>
+            <a:r>
+              <a:rPr lang="en-DE" sz="4000" dirty="0"/>
+              <a:t>[1:4]</a:t>
+            </a:r>
+          </a:p>
+        </p:txBody>
+      </p:sp>
+      <p:graphicFrame>
+        <p:nvGraphicFramePr>
+          <p:cNvPr id="14" name="Table 13">
+            <a:extLst>
+              <a:ext uri="{FF2B5EF4-FFF2-40B4-BE49-F238E27FC236}">
+                <a16:creationId xmlns:a16="http://schemas.microsoft.com/office/drawing/2014/main" id="{1A471107-A872-A42B-489F-E96C66AA901D}"/>
+              </a:ext>
+            </a:extLst>
+          </p:cNvPr>
+          <p:cNvGraphicFramePr>
+            <a:graphicFrameLocks noGrp="1"/>
+          </p:cNvGraphicFramePr>
+          <p:nvPr>
+            <p:extLst>
+              <p:ext uri="{D42A27DB-BD31-4B8C-83A1-F6EECF244321}">
+                <p14:modId xmlns:p14="http://schemas.microsoft.com/office/powerpoint/2010/main" val="4259096670"/>
+              </p:ext>
+            </p:extLst>
+          </p:nvPr>
+        </p:nvGraphicFramePr>
+        <p:xfrm>
+          <a:off x="1761066" y="10202062"/>
+          <a:ext cx="7707580" cy="914400"/>
+        </p:xfrm>
+        <a:graphic>
+          <a:graphicData uri="http://schemas.openxmlformats.org/drawingml/2006/table">
+            <a:tbl>
+              <a:tblPr firstRow="1" bandRow="1">
+                <a:tableStyleId>{5C22544A-7EE6-4342-B048-85BDC9FD1C3A}</a:tableStyleId>
+              </a:tblPr>
+              <a:tblGrid>
+                <a:gridCol w="1926895">
+                  <a:extLst>
+                    <a:ext uri="{9D8B030D-6E8A-4147-A177-3AD203B41FA5}">
+                      <a16:colId xmlns:a16="http://schemas.microsoft.com/office/drawing/2014/main" val="2355591543"/>
+                    </a:ext>
+                  </a:extLst>
+                </a:gridCol>
+                <a:gridCol w="1926895">
+                  <a:extLst>
+                    <a:ext uri="{9D8B030D-6E8A-4147-A177-3AD203B41FA5}">
+                      <a16:colId xmlns:a16="http://schemas.microsoft.com/office/drawing/2014/main" val="1690173566"/>
+                    </a:ext>
+                  </a:extLst>
+                </a:gridCol>
+                <a:gridCol w="1926895">
+                  <a:extLst>
+                    <a:ext uri="{9D8B030D-6E8A-4147-A177-3AD203B41FA5}">
+                      <a16:colId xmlns:a16="http://schemas.microsoft.com/office/drawing/2014/main" val="434348016"/>
+                    </a:ext>
+                  </a:extLst>
+                </a:gridCol>
+                <a:gridCol w="1926895">
+                  <a:extLst>
+                    <a:ext uri="{9D8B030D-6E8A-4147-A177-3AD203B41FA5}">
+                      <a16:colId xmlns:a16="http://schemas.microsoft.com/office/drawing/2014/main" val="1805346127"/>
+                    </a:ext>
+                  </a:extLst>
+                </a:gridCol>
+              </a:tblGrid>
+              <a:tr h="370840">
+                <a:tc>
+                  <a:txBody>
+                    <a:bodyPr/>
+                    <a:lstStyle/>
+                    <a:p>
+                      <a:pPr algn="ctr"/>
+                      <a:r>
+                        <a:rPr lang="en-DE" sz="2400" b="1" i="0" dirty="0">
+                          <a:latin typeface="Arial Narrow" panose="020B0604020202020204" pitchFamily="34" charset="0"/>
+                          <a:cs typeface="Arial Narrow" panose="020B0604020202020204" pitchFamily="34" charset="0"/>
+                        </a:rPr>
+                        <a:t>0</a:t>
+                      </a:r>
+                    </a:p>
+                  </a:txBody>
+                  <a:tcPr/>
+                </a:tc>
+                <a:tc>
+                  <a:txBody>
+                    <a:bodyPr/>
+                    <a:lstStyle/>
+                    <a:p>
+                      <a:pPr algn="ctr"/>
+                      <a:r>
+                        <a:rPr lang="en-DE" sz="2400" b="1" i="0" dirty="0">
+                          <a:latin typeface="Arial Narrow" panose="020B0604020202020204" pitchFamily="34" charset="0"/>
+                          <a:cs typeface="Arial Narrow" panose="020B0604020202020204" pitchFamily="34" charset="0"/>
+                        </a:rPr>
+                        <a:t>1</a:t>
+                      </a:r>
+                    </a:p>
+                  </a:txBody>
+                  <a:tcPr/>
+                </a:tc>
+                <a:tc>
+                  <a:txBody>
+                    <a:bodyPr/>
+                    <a:lstStyle/>
+                    <a:p>
+                      <a:pPr algn="ctr"/>
+                      <a:r>
+                        <a:rPr lang="en-DE" sz="2400" b="1" i="0" dirty="0">
+                          <a:latin typeface="Arial Narrow" panose="020B0604020202020204" pitchFamily="34" charset="0"/>
+                          <a:cs typeface="Arial Narrow" panose="020B0604020202020204" pitchFamily="34" charset="0"/>
+                        </a:rPr>
+                        <a:t>2</a:t>
+                      </a:r>
+                    </a:p>
+                  </a:txBody>
+                  <a:tcPr/>
+                </a:tc>
+                <a:tc>
+                  <a:txBody>
+                    <a:bodyPr/>
+                    <a:lstStyle/>
+                    <a:p>
+                      <a:pPr algn="ctr"/>
+                      <a:r>
+                        <a:rPr lang="en-DE" sz="2400" b="1" i="0" dirty="0">
+                          <a:latin typeface="Arial Narrow" panose="020B0604020202020204" pitchFamily="34" charset="0"/>
+                          <a:cs typeface="Arial Narrow" panose="020B0604020202020204" pitchFamily="34" charset="0"/>
+                        </a:rPr>
+                        <a:t>3</a:t>
+                      </a:r>
+                    </a:p>
+                  </a:txBody>
+                  <a:tcPr/>
+                </a:tc>
+                <a:extLst>
+                  <a:ext uri="{0D108BD9-81ED-4DB2-BD59-A6C34878D82A}">
+                    <a16:rowId xmlns:a16="http://schemas.microsoft.com/office/drawing/2014/main" val="3813841085"/>
+                  </a:ext>
+                </a:extLst>
+              </a:tr>
+              <a:tr h="370840">
+                <a:tc>
+                  <a:txBody>
+                    <a:bodyPr/>
+                    <a:lstStyle/>
+                    <a:p>
+                      <a:pPr algn="ctr"/>
+                      <a:r>
+                        <a:rPr lang="en-DE" sz="2400" b="1" i="0" dirty="0">
+                          <a:latin typeface="Arial Narrow" panose="020B0604020202020204" pitchFamily="34" charset="0"/>
+                          <a:cs typeface="Arial Narrow" panose="020B0604020202020204" pitchFamily="34" charset="0"/>
+                        </a:rPr>
+                        <a:t>a</a:t>
+                      </a:r>
+                    </a:p>
+                  </a:txBody>
+                  <a:tcPr>
+                    <a:solidFill>
+                      <a:schemeClr val="accent6"/>
+                    </a:solidFill>
+                  </a:tcPr>
+                </a:tc>
+                <a:tc>
+                  <a:txBody>
+                    <a:bodyPr/>
+                    <a:lstStyle/>
+                    <a:p>
+                      <a:pPr algn="ctr"/>
+                      <a:r>
+                        <a:rPr lang="en-DE" sz="2400" b="1" i="0" dirty="0">
+                          <a:latin typeface="Arial Narrow" panose="020B0604020202020204" pitchFamily="34" charset="0"/>
+                          <a:cs typeface="Arial Narrow" panose="020B0604020202020204" pitchFamily="34" charset="0"/>
+                        </a:rPr>
+                        <a:t>b</a:t>
+                      </a:r>
+                    </a:p>
+                  </a:txBody>
+                  <a:tcPr>
+                    <a:solidFill>
+                      <a:schemeClr val="accent6"/>
+                    </a:solidFill>
+                  </a:tcPr>
+                </a:tc>
+                <a:tc>
+                  <a:txBody>
+                    <a:bodyPr/>
+                    <a:lstStyle/>
+                    <a:p>
+                      <a:pPr algn="ctr"/>
+                      <a:r>
+                        <a:rPr lang="en-DE" sz="2400" b="1" i="0" dirty="0">
+                          <a:latin typeface="Arial Narrow" panose="020B0604020202020204" pitchFamily="34" charset="0"/>
+                          <a:cs typeface="Arial Narrow" panose="020B0604020202020204" pitchFamily="34" charset="0"/>
+                        </a:rPr>
+                        <a:t>c</a:t>
+                      </a:r>
+                    </a:p>
+                  </a:txBody>
+                  <a:tcPr>
+                    <a:solidFill>
+                      <a:schemeClr val="accent6"/>
+                    </a:solidFill>
+                  </a:tcPr>
+                </a:tc>
+                <a:tc>
+                  <a:txBody>
+                    <a:bodyPr/>
+                    <a:lstStyle/>
+                    <a:p>
+                      <a:pPr algn="ctr"/>
+                      <a:r>
+                        <a:rPr lang="en-DE" sz="2400" b="1" i="0" dirty="0">
+                          <a:latin typeface="Arial Narrow" panose="020B0604020202020204" pitchFamily="34" charset="0"/>
+                          <a:cs typeface="Arial Narrow" panose="020B0604020202020204" pitchFamily="34" charset="0"/>
+                        </a:rPr>
+                        <a:t>d</a:t>
+                      </a:r>
+                    </a:p>
+                  </a:txBody>
+                  <a:tcPr/>
+                </a:tc>
+                <a:extLst>
+                  <a:ext uri="{0D108BD9-81ED-4DB2-BD59-A6C34878D82A}">
+                    <a16:rowId xmlns:a16="http://schemas.microsoft.com/office/drawing/2014/main" val="2392955628"/>
+                  </a:ext>
+                </a:extLst>
+              </a:tr>
+            </a:tbl>
+          </a:graphicData>
+        </a:graphic>
+      </p:graphicFrame>
+      <p:sp>
+        <p:nvSpPr>
+          <p:cNvPr id="15" name="TextBox 14">
+            <a:extLst>
+              <a:ext uri="{FF2B5EF4-FFF2-40B4-BE49-F238E27FC236}">
+                <a16:creationId xmlns:a16="http://schemas.microsoft.com/office/drawing/2014/main" id="{036D95CF-C1B8-4D7B-AEC7-FC07FF6C3E70}"/>
+              </a:ext>
+            </a:extLst>
+          </p:cNvPr>
+          <p:cNvSpPr txBox="1"/>
+          <p:nvPr/>
+        </p:nvSpPr>
+        <p:spPr>
+          <a:xfrm>
+            <a:off x="264001" y="10324973"/>
+            <a:ext cx="1096775" cy="707886"/>
+          </a:xfrm>
+          <a:prstGeom prst="rect">
+            <a:avLst/>
+          </a:prstGeom>
+          <a:noFill/>
+        </p:spPr>
+        <p:txBody>
+          <a:bodyPr wrap="none" rtlCol="0">
+            <a:spAutoFit/>
+          </a:bodyPr>
+          <a:lstStyle>
+            <a:defPPr>
+              <a:defRPr lang="en-US"/>
+            </a:defPPr>
+            <a:lvl1pPr>
+              <a:defRPr sz="4000"/>
+            </a:lvl1pPr>
+          </a:lstStyle>
+          <a:p>
+            <a:r>
+              <a:rPr lang="en-GB" dirty="0"/>
+              <a:t>s[:3]</a:t>
+            </a:r>
+          </a:p>
+        </p:txBody>
+      </p:sp>
+      <p:graphicFrame>
+        <p:nvGraphicFramePr>
+          <p:cNvPr id="16" name="Table 15">
+            <a:extLst>
+              <a:ext uri="{FF2B5EF4-FFF2-40B4-BE49-F238E27FC236}">
+                <a16:creationId xmlns:a16="http://schemas.microsoft.com/office/drawing/2014/main" id="{029C5998-E146-9CFA-A09E-D1126D665C8D}"/>
+              </a:ext>
+            </a:extLst>
+          </p:cNvPr>
+          <p:cNvGraphicFramePr>
+            <a:graphicFrameLocks noGrp="1"/>
+          </p:cNvGraphicFramePr>
+          <p:nvPr>
+            <p:extLst>
+              <p:ext uri="{D42A27DB-BD31-4B8C-83A1-F6EECF244321}">
+                <p14:modId xmlns:p14="http://schemas.microsoft.com/office/powerpoint/2010/main" val="1356480996"/>
+              </p:ext>
+            </p:extLst>
+          </p:nvPr>
+        </p:nvGraphicFramePr>
+        <p:xfrm>
+          <a:off x="1761066" y="12110247"/>
+          <a:ext cx="7707580" cy="914400"/>
+        </p:xfrm>
+        <a:graphic>
+          <a:graphicData uri="http://schemas.openxmlformats.org/drawingml/2006/table">
+            <a:tbl>
+              <a:tblPr firstRow="1" bandRow="1">
+                <a:tableStyleId>{5C22544A-7EE6-4342-B048-85BDC9FD1C3A}</a:tableStyleId>
+              </a:tblPr>
+              <a:tblGrid>
+                <a:gridCol w="1926895">
+                  <a:extLst>
+                    <a:ext uri="{9D8B030D-6E8A-4147-A177-3AD203B41FA5}">
+                      <a16:colId xmlns:a16="http://schemas.microsoft.com/office/drawing/2014/main" val="2355591543"/>
+                    </a:ext>
+                  </a:extLst>
+                </a:gridCol>
+                <a:gridCol w="1926895">
+                  <a:extLst>
+                    <a:ext uri="{9D8B030D-6E8A-4147-A177-3AD203B41FA5}">
+                      <a16:colId xmlns:a16="http://schemas.microsoft.com/office/drawing/2014/main" val="1690173566"/>
+                    </a:ext>
+                  </a:extLst>
+                </a:gridCol>
+                <a:gridCol w="1926895">
+                  <a:extLst>
+                    <a:ext uri="{9D8B030D-6E8A-4147-A177-3AD203B41FA5}">
+                      <a16:colId xmlns:a16="http://schemas.microsoft.com/office/drawing/2014/main" val="434348016"/>
+                    </a:ext>
+                  </a:extLst>
+                </a:gridCol>
+                <a:gridCol w="1926895">
+                  <a:extLst>
+                    <a:ext uri="{9D8B030D-6E8A-4147-A177-3AD203B41FA5}">
+                      <a16:colId xmlns:a16="http://schemas.microsoft.com/office/drawing/2014/main" val="1805346127"/>
+                    </a:ext>
+                  </a:extLst>
+                </a:gridCol>
+              </a:tblGrid>
+              <a:tr h="370840">
+                <a:tc>
+                  <a:txBody>
+                    <a:bodyPr/>
+                    <a:lstStyle/>
+                    <a:p>
+                      <a:pPr algn="ctr"/>
+                      <a:r>
+                        <a:rPr lang="en-DE" sz="2400" b="1" i="0" dirty="0">
+                          <a:latin typeface="Arial Narrow" panose="020B0604020202020204" pitchFamily="34" charset="0"/>
+                          <a:cs typeface="Arial Narrow" panose="020B0604020202020204" pitchFamily="34" charset="0"/>
+                        </a:rPr>
+                        <a:t>0</a:t>
+                      </a:r>
+                    </a:p>
+                  </a:txBody>
+                  <a:tcPr/>
+                </a:tc>
+                <a:tc>
+                  <a:txBody>
+                    <a:bodyPr/>
+                    <a:lstStyle/>
+                    <a:p>
+                      <a:pPr algn="ctr"/>
+                      <a:r>
+                        <a:rPr lang="en-DE" sz="2400" b="1" i="0" dirty="0">
+                          <a:latin typeface="Arial Narrow" panose="020B0604020202020204" pitchFamily="34" charset="0"/>
+                          <a:cs typeface="Arial Narrow" panose="020B0604020202020204" pitchFamily="34" charset="0"/>
+                        </a:rPr>
+                        <a:t>1</a:t>
+                      </a:r>
+                    </a:p>
+                  </a:txBody>
+                  <a:tcPr/>
+                </a:tc>
+                <a:tc>
+                  <a:txBody>
+                    <a:bodyPr/>
+                    <a:lstStyle/>
+                    <a:p>
+                      <a:pPr algn="ctr"/>
+                      <a:r>
+                        <a:rPr lang="en-DE" sz="2400" b="1" i="0" dirty="0">
+                          <a:latin typeface="Arial Narrow" panose="020B0604020202020204" pitchFamily="34" charset="0"/>
+                          <a:cs typeface="Arial Narrow" panose="020B0604020202020204" pitchFamily="34" charset="0"/>
+                        </a:rPr>
+                        <a:t>2</a:t>
+                      </a:r>
+                    </a:p>
+                  </a:txBody>
+                  <a:tcPr/>
+                </a:tc>
+                <a:tc>
+                  <a:txBody>
+                    <a:bodyPr/>
+                    <a:lstStyle/>
+                    <a:p>
+                      <a:pPr algn="ctr"/>
+                      <a:r>
+                        <a:rPr lang="en-DE" sz="2400" b="1" i="0" dirty="0">
+                          <a:latin typeface="Arial Narrow" panose="020B0604020202020204" pitchFamily="34" charset="0"/>
+                          <a:cs typeface="Arial Narrow" panose="020B0604020202020204" pitchFamily="34" charset="0"/>
+                        </a:rPr>
+                        <a:t>3</a:t>
+                      </a:r>
+                    </a:p>
+                  </a:txBody>
+                  <a:tcPr/>
+                </a:tc>
+                <a:extLst>
+                  <a:ext uri="{0D108BD9-81ED-4DB2-BD59-A6C34878D82A}">
+                    <a16:rowId xmlns:a16="http://schemas.microsoft.com/office/drawing/2014/main" val="3813841085"/>
+                  </a:ext>
+                </a:extLst>
+              </a:tr>
+              <a:tr h="370840">
+                <a:tc>
+                  <a:txBody>
+                    <a:bodyPr/>
+                    <a:lstStyle/>
+                    <a:p>
+                      <a:pPr algn="ctr"/>
+                      <a:r>
+                        <a:rPr lang="en-DE" sz="2400" b="1" i="0" dirty="0">
+                          <a:latin typeface="Arial Narrow" panose="020B0604020202020204" pitchFamily="34" charset="0"/>
+                          <a:cs typeface="Arial Narrow" panose="020B0604020202020204" pitchFamily="34" charset="0"/>
+                        </a:rPr>
+                        <a:t>a</a:t>
+                      </a:r>
+                    </a:p>
+                  </a:txBody>
+                  <a:tcPr/>
+                </a:tc>
+                <a:tc>
+                  <a:txBody>
+                    <a:bodyPr/>
+                    <a:lstStyle/>
+                    <a:p>
+                      <a:pPr algn="ctr"/>
+                      <a:r>
+                        <a:rPr lang="en-DE" sz="2400" b="1" i="0" dirty="0">
+                          <a:latin typeface="Arial Narrow" panose="020B0604020202020204" pitchFamily="34" charset="0"/>
+                          <a:cs typeface="Arial Narrow" panose="020B0604020202020204" pitchFamily="34" charset="0"/>
+                        </a:rPr>
+                        <a:t>b</a:t>
+                      </a:r>
+                    </a:p>
+                  </a:txBody>
+                  <a:tcPr/>
+                </a:tc>
+                <a:tc>
+                  <a:txBody>
+                    <a:bodyPr/>
+                    <a:lstStyle/>
+                    <a:p>
+                      <a:pPr algn="ctr"/>
+                      <a:r>
+                        <a:rPr lang="en-DE" sz="2400" b="1" i="0" dirty="0">
+                          <a:latin typeface="Arial Narrow" panose="020B0604020202020204" pitchFamily="34" charset="0"/>
+                          <a:cs typeface="Arial Narrow" panose="020B0604020202020204" pitchFamily="34" charset="0"/>
+                        </a:rPr>
+                        <a:t>c</a:t>
+                      </a:r>
+                    </a:p>
+                  </a:txBody>
+                  <a:tcPr/>
+                </a:tc>
+                <a:tc>
+                  <a:txBody>
+                    <a:bodyPr/>
+                    <a:lstStyle/>
+                    <a:p>
+                      <a:pPr algn="ctr"/>
+                      <a:r>
+                        <a:rPr lang="en-DE" sz="2400" b="1" i="0" dirty="0">
+                          <a:latin typeface="Arial Narrow" panose="020B0604020202020204" pitchFamily="34" charset="0"/>
+                          <a:cs typeface="Arial Narrow" panose="020B0604020202020204" pitchFamily="34" charset="0"/>
+                        </a:rPr>
+                        <a:t>d</a:t>
+                      </a:r>
+                    </a:p>
+                  </a:txBody>
+                  <a:tcPr>
+                    <a:solidFill>
+                      <a:schemeClr val="accent6"/>
+                    </a:solidFill>
+                  </a:tcPr>
+                </a:tc>
+                <a:extLst>
+                  <a:ext uri="{0D108BD9-81ED-4DB2-BD59-A6C34878D82A}">
+                    <a16:rowId xmlns:a16="http://schemas.microsoft.com/office/drawing/2014/main" val="2392955628"/>
+                  </a:ext>
+                </a:extLst>
+              </a:tr>
+            </a:tbl>
+          </a:graphicData>
+        </a:graphic>
+      </p:graphicFrame>
+      <p:sp>
+        <p:nvSpPr>
+          <p:cNvPr id="20" name="TextBox 19">
+            <a:extLst>
+              <a:ext uri="{FF2B5EF4-FFF2-40B4-BE49-F238E27FC236}">
+                <a16:creationId xmlns:a16="http://schemas.microsoft.com/office/drawing/2014/main" id="{24D32C7C-558D-FC12-F2CF-5C8EF5D6F8AF}"/>
+              </a:ext>
+            </a:extLst>
+          </p:cNvPr>
+          <p:cNvSpPr txBox="1"/>
+          <p:nvPr/>
+        </p:nvSpPr>
+        <p:spPr>
+          <a:xfrm>
+            <a:off x="264001" y="12223918"/>
+            <a:ext cx="1096775" cy="707886"/>
+          </a:xfrm>
+          <a:prstGeom prst="rect">
+            <a:avLst/>
+          </a:prstGeom>
+          <a:noFill/>
+        </p:spPr>
+        <p:txBody>
+          <a:bodyPr wrap="none" rtlCol="0">
+            <a:spAutoFit/>
+          </a:bodyPr>
+          <a:lstStyle>
+            <a:defPPr>
+              <a:defRPr lang="en-US"/>
+            </a:defPPr>
+            <a:lvl1pPr>
+              <a:defRPr sz="4000"/>
+            </a:lvl1pPr>
+          </a:lstStyle>
+          <a:p>
+            <a:r>
+              <a:rPr lang="en-GB" dirty="0"/>
+              <a:t>s[3:]</a:t>
+            </a:r>
+          </a:p>
+        </p:txBody>
+      </p:sp>
+      <p:graphicFrame>
+        <p:nvGraphicFramePr>
+          <p:cNvPr id="21" name="Table 20">
+            <a:extLst>
+              <a:ext uri="{FF2B5EF4-FFF2-40B4-BE49-F238E27FC236}">
+                <a16:creationId xmlns:a16="http://schemas.microsoft.com/office/drawing/2014/main" id="{1E638342-6156-9971-60AF-11EF27422642}"/>
+              </a:ext>
+            </a:extLst>
+          </p:cNvPr>
+          <p:cNvGraphicFramePr>
+            <a:graphicFrameLocks noGrp="1"/>
+          </p:cNvGraphicFramePr>
+          <p:nvPr>
+            <p:extLst>
+              <p:ext uri="{D42A27DB-BD31-4B8C-83A1-F6EECF244321}">
+                <p14:modId xmlns:p14="http://schemas.microsoft.com/office/powerpoint/2010/main" val="1115857156"/>
+              </p:ext>
+            </p:extLst>
+          </p:nvPr>
+        </p:nvGraphicFramePr>
+        <p:xfrm>
+          <a:off x="1727200" y="14018433"/>
+          <a:ext cx="7707580" cy="914400"/>
+        </p:xfrm>
+        <a:graphic>
+          <a:graphicData uri="http://schemas.openxmlformats.org/drawingml/2006/table">
+            <a:tbl>
+              <a:tblPr firstRow="1" bandRow="1">
+                <a:tableStyleId>{5C22544A-7EE6-4342-B048-85BDC9FD1C3A}</a:tableStyleId>
+              </a:tblPr>
+              <a:tblGrid>
+                <a:gridCol w="1926895">
+                  <a:extLst>
+                    <a:ext uri="{9D8B030D-6E8A-4147-A177-3AD203B41FA5}">
+                      <a16:colId xmlns:a16="http://schemas.microsoft.com/office/drawing/2014/main" val="2355591543"/>
+                    </a:ext>
+                  </a:extLst>
+                </a:gridCol>
+                <a:gridCol w="1926895">
+                  <a:extLst>
+                    <a:ext uri="{9D8B030D-6E8A-4147-A177-3AD203B41FA5}">
+                      <a16:colId xmlns:a16="http://schemas.microsoft.com/office/drawing/2014/main" val="1690173566"/>
+                    </a:ext>
+                  </a:extLst>
+                </a:gridCol>
+                <a:gridCol w="1926895">
+                  <a:extLst>
+                    <a:ext uri="{9D8B030D-6E8A-4147-A177-3AD203B41FA5}">
+                      <a16:colId xmlns:a16="http://schemas.microsoft.com/office/drawing/2014/main" val="434348016"/>
+                    </a:ext>
+                  </a:extLst>
+                </a:gridCol>
+                <a:gridCol w="1926895">
+                  <a:extLst>
+                    <a:ext uri="{9D8B030D-6E8A-4147-A177-3AD203B41FA5}">
+                      <a16:colId xmlns:a16="http://schemas.microsoft.com/office/drawing/2014/main" val="1805346127"/>
+                    </a:ext>
+                  </a:extLst>
+                </a:gridCol>
+              </a:tblGrid>
+              <a:tr h="370840">
+                <a:tc>
+                  <a:txBody>
+                    <a:bodyPr/>
+                    <a:lstStyle/>
+                    <a:p>
+                      <a:pPr algn="ctr"/>
+                      <a:r>
+                        <a:rPr lang="en-DE" sz="2400" b="1" i="0" dirty="0">
+                          <a:latin typeface="Arial Narrow" panose="020B0604020202020204" pitchFamily="34" charset="0"/>
+                          <a:cs typeface="Arial Narrow" panose="020B0604020202020204" pitchFamily="34" charset="0"/>
+                        </a:rPr>
+                        <a:t>0</a:t>
+                      </a:r>
+                    </a:p>
+                  </a:txBody>
+                  <a:tcPr/>
+                </a:tc>
+                <a:tc>
+                  <a:txBody>
+                    <a:bodyPr/>
+                    <a:lstStyle/>
+                    <a:p>
+                      <a:pPr algn="ctr"/>
+                      <a:r>
+                        <a:rPr lang="en-DE" sz="2400" b="1" i="0" dirty="0">
+                          <a:latin typeface="Arial Narrow" panose="020B0604020202020204" pitchFamily="34" charset="0"/>
+                          <a:cs typeface="Arial Narrow" panose="020B0604020202020204" pitchFamily="34" charset="0"/>
+                        </a:rPr>
+                        <a:t>1</a:t>
+                      </a:r>
+                    </a:p>
+                  </a:txBody>
+                  <a:tcPr/>
+                </a:tc>
+                <a:tc>
+                  <a:txBody>
+                    <a:bodyPr/>
+                    <a:lstStyle/>
+                    <a:p>
+                      <a:pPr algn="ctr"/>
+                      <a:r>
+                        <a:rPr lang="en-DE" sz="2400" b="1" i="0" dirty="0">
+                          <a:latin typeface="Arial Narrow" panose="020B0604020202020204" pitchFamily="34" charset="0"/>
+                          <a:cs typeface="Arial Narrow" panose="020B0604020202020204" pitchFamily="34" charset="0"/>
+                        </a:rPr>
+                        <a:t>2</a:t>
+                      </a:r>
+                    </a:p>
+                  </a:txBody>
+                  <a:tcPr/>
+                </a:tc>
+                <a:tc>
+                  <a:txBody>
+                    <a:bodyPr/>
+                    <a:lstStyle/>
+                    <a:p>
+                      <a:pPr algn="ctr"/>
+                      <a:r>
+                        <a:rPr lang="en-DE" sz="2400" b="1" i="0" dirty="0">
+                          <a:latin typeface="Arial Narrow" panose="020B0604020202020204" pitchFamily="34" charset="0"/>
+                          <a:cs typeface="Arial Narrow" panose="020B0604020202020204" pitchFamily="34" charset="0"/>
+                        </a:rPr>
+                        <a:t>3</a:t>
+                      </a:r>
+                    </a:p>
+                  </a:txBody>
+                  <a:tcPr/>
+                </a:tc>
+                <a:extLst>
+                  <a:ext uri="{0D108BD9-81ED-4DB2-BD59-A6C34878D82A}">
+                    <a16:rowId xmlns:a16="http://schemas.microsoft.com/office/drawing/2014/main" val="3813841085"/>
+                  </a:ext>
+                </a:extLst>
+              </a:tr>
+              <a:tr h="370840">
+                <a:tc>
+                  <a:txBody>
+                    <a:bodyPr/>
+                    <a:lstStyle/>
+                    <a:p>
+                      <a:pPr algn="ctr"/>
+                      <a:r>
+                        <a:rPr lang="en-DE" sz="2400" b="1" i="0" dirty="0">
+                          <a:latin typeface="Arial Narrow" panose="020B0604020202020204" pitchFamily="34" charset="0"/>
+                          <a:cs typeface="Arial Narrow" panose="020B0604020202020204" pitchFamily="34" charset="0"/>
+                        </a:rPr>
+                        <a:t>d</a:t>
+                      </a:r>
+                    </a:p>
+                  </a:txBody>
+                  <a:tcPr>
+                    <a:solidFill>
+                      <a:schemeClr val="accent6"/>
+                    </a:solidFill>
+                  </a:tcPr>
+                </a:tc>
+                <a:tc>
+                  <a:txBody>
+                    <a:bodyPr/>
+                    <a:lstStyle/>
+                    <a:p>
+                      <a:pPr algn="ctr"/>
+                      <a:r>
+                        <a:rPr lang="en-DE" sz="2400" b="1" i="0" dirty="0">
+                          <a:latin typeface="Arial Narrow" panose="020B0604020202020204" pitchFamily="34" charset="0"/>
+                          <a:cs typeface="Arial Narrow" panose="020B0604020202020204" pitchFamily="34" charset="0"/>
+                        </a:rPr>
+                        <a:t>c</a:t>
+                      </a:r>
+                    </a:p>
+                  </a:txBody>
+                  <a:tcPr>
+                    <a:solidFill>
+                      <a:schemeClr val="accent6"/>
+                    </a:solidFill>
+                  </a:tcPr>
+                </a:tc>
+                <a:tc>
+                  <a:txBody>
+                    <a:bodyPr/>
+                    <a:lstStyle/>
+                    <a:p>
+                      <a:pPr algn="ctr"/>
+                      <a:r>
+                        <a:rPr lang="en-DE" sz="2400" b="1" i="0" dirty="0">
+                          <a:latin typeface="Arial Narrow" panose="020B0604020202020204" pitchFamily="34" charset="0"/>
+                          <a:cs typeface="Arial Narrow" panose="020B0604020202020204" pitchFamily="34" charset="0"/>
+                        </a:rPr>
+                        <a:t>b</a:t>
+                      </a:r>
+                    </a:p>
+                  </a:txBody>
+                  <a:tcPr>
+                    <a:solidFill>
+                      <a:schemeClr val="accent6"/>
+                    </a:solidFill>
+                  </a:tcPr>
+                </a:tc>
+                <a:tc>
+                  <a:txBody>
+                    <a:bodyPr/>
+                    <a:lstStyle/>
+                    <a:p>
+                      <a:pPr algn="ctr"/>
+                      <a:r>
+                        <a:rPr lang="en-DE" sz="2400" b="1" i="0" dirty="0">
+                          <a:latin typeface="Arial Narrow" panose="020B0604020202020204" pitchFamily="34" charset="0"/>
+                          <a:cs typeface="Arial Narrow" panose="020B0604020202020204" pitchFamily="34" charset="0"/>
+                        </a:rPr>
+                        <a:t>a</a:t>
+                      </a:r>
+                    </a:p>
+                  </a:txBody>
+                  <a:tcPr>
+                    <a:solidFill>
+                      <a:schemeClr val="accent6"/>
+                    </a:solidFill>
+                  </a:tcPr>
+                </a:tc>
+                <a:extLst>
+                  <a:ext uri="{0D108BD9-81ED-4DB2-BD59-A6C34878D82A}">
+                    <a16:rowId xmlns:a16="http://schemas.microsoft.com/office/drawing/2014/main" val="2392955628"/>
+                  </a:ext>
+                </a:extLst>
+              </a:tr>
+            </a:tbl>
+          </a:graphicData>
+        </a:graphic>
+      </p:graphicFrame>
+      <p:sp>
+        <p:nvSpPr>
+          <p:cNvPr id="22" name="TextBox 21">
+            <a:extLst>
+              <a:ext uri="{FF2B5EF4-FFF2-40B4-BE49-F238E27FC236}">
+                <a16:creationId xmlns:a16="http://schemas.microsoft.com/office/drawing/2014/main" id="{A1BCFE1C-E2BB-ABD4-3690-F433F76AC510}"/>
+              </a:ext>
+            </a:extLst>
+          </p:cNvPr>
+          <p:cNvSpPr txBox="1"/>
+          <p:nvPr/>
+        </p:nvSpPr>
+        <p:spPr>
+          <a:xfrm>
+            <a:off x="264001" y="14111102"/>
+            <a:ext cx="1391728" cy="707886"/>
+          </a:xfrm>
+          <a:prstGeom prst="rect">
+            <a:avLst/>
+          </a:prstGeom>
+          <a:noFill/>
+        </p:spPr>
+        <p:txBody>
+          <a:bodyPr wrap="none" rtlCol="0">
+            <a:spAutoFit/>
+          </a:bodyPr>
+          <a:lstStyle>
+            <a:defPPr>
+              <a:defRPr lang="en-US"/>
+            </a:defPPr>
+            <a:lvl1pPr>
+              <a:defRPr sz="4000"/>
+            </a:lvl1pPr>
+          </a:lstStyle>
+          <a:p>
+            <a:r>
+              <a:rPr lang="en-GB" dirty="0"/>
+              <a:t>s[::-1]</a:t>
+            </a:r>
+          </a:p>
+        </p:txBody>
+      </p:sp>
+      <p:sp>
+        <p:nvSpPr>
+          <p:cNvPr id="24" name="TextBox 23">
+            <a:extLst>
+              <a:ext uri="{FF2B5EF4-FFF2-40B4-BE49-F238E27FC236}">
+                <a16:creationId xmlns:a16="http://schemas.microsoft.com/office/drawing/2014/main" id="{E6820BAC-0F83-4AAA-C528-9DA90F473A90}"/>
+              </a:ext>
+            </a:extLst>
+          </p:cNvPr>
+          <p:cNvSpPr txBox="1"/>
+          <p:nvPr/>
+        </p:nvSpPr>
+        <p:spPr>
+          <a:xfrm>
+            <a:off x="1825643" y="7591260"/>
+            <a:ext cx="5815823" cy="707886"/>
+          </a:xfrm>
+          <a:prstGeom prst="rect">
+            <a:avLst/>
+          </a:prstGeom>
+          <a:noFill/>
+        </p:spPr>
+        <p:txBody>
+          <a:bodyPr wrap="none" rtlCol="0">
+            <a:spAutoFit/>
+          </a:bodyPr>
+          <a:lstStyle>
+            <a:defPPr>
+              <a:defRPr lang="en-US"/>
+            </a:defPPr>
+            <a:lvl1pPr>
+              <a:defRPr sz="4000"/>
+            </a:lvl1pPr>
+          </a:lstStyle>
+          <a:p>
+            <a:r>
+              <a:rPr lang="en-GB" dirty="0"/>
+              <a:t>character from index 1 to 3</a:t>
+            </a:r>
+          </a:p>
+        </p:txBody>
+      </p:sp>
+      <p:sp>
+        <p:nvSpPr>
+          <p:cNvPr id="25" name="TextBox 24">
+            <a:extLst>
+              <a:ext uri="{FF2B5EF4-FFF2-40B4-BE49-F238E27FC236}">
+                <a16:creationId xmlns:a16="http://schemas.microsoft.com/office/drawing/2014/main" id="{3BC5F93F-8742-1C94-A441-510A6D88A11B}"/>
+              </a:ext>
+            </a:extLst>
+          </p:cNvPr>
+          <p:cNvSpPr txBox="1"/>
+          <p:nvPr/>
+        </p:nvSpPr>
+        <p:spPr>
+          <a:xfrm>
+            <a:off x="1754135" y="9489626"/>
+            <a:ext cx="4434804" cy="707886"/>
+          </a:xfrm>
+          <a:prstGeom prst="rect">
+            <a:avLst/>
+          </a:prstGeom>
+          <a:noFill/>
+        </p:spPr>
+        <p:txBody>
+          <a:bodyPr wrap="none" rtlCol="0">
+            <a:spAutoFit/>
+          </a:bodyPr>
+          <a:lstStyle>
+            <a:defPPr>
+              <a:defRPr lang="en-US"/>
+            </a:defPPr>
+            <a:lvl1pPr>
+              <a:defRPr sz="4000"/>
+            </a:lvl1pPr>
+          </a:lstStyle>
+          <a:p>
+            <a:r>
+              <a:rPr lang="en-GB" dirty="0"/>
+              <a:t>from start to index 2</a:t>
+            </a:r>
+          </a:p>
+        </p:txBody>
+      </p:sp>
+      <p:sp>
+        <p:nvSpPr>
+          <p:cNvPr id="26" name="TextBox 25">
+            <a:extLst>
+              <a:ext uri="{FF2B5EF4-FFF2-40B4-BE49-F238E27FC236}">
+                <a16:creationId xmlns:a16="http://schemas.microsoft.com/office/drawing/2014/main" id="{2A06D8BD-30B6-E955-5FB7-258B187134A2}"/>
+              </a:ext>
+            </a:extLst>
+          </p:cNvPr>
+          <p:cNvSpPr txBox="1"/>
+          <p:nvPr/>
+        </p:nvSpPr>
+        <p:spPr>
+          <a:xfrm>
+            <a:off x="1754138" y="11399421"/>
+            <a:ext cx="4272132" cy="707886"/>
+          </a:xfrm>
+          <a:prstGeom prst="rect">
+            <a:avLst/>
+          </a:prstGeom>
+          <a:noFill/>
+        </p:spPr>
+        <p:txBody>
+          <a:bodyPr wrap="none" rtlCol="0">
+            <a:spAutoFit/>
+          </a:bodyPr>
+          <a:lstStyle>
+            <a:defPPr>
+              <a:defRPr lang="en-US"/>
+            </a:defPPr>
+            <a:lvl1pPr>
+              <a:defRPr sz="4000"/>
+            </a:lvl1pPr>
+          </a:lstStyle>
+          <a:p>
+            <a:r>
+              <a:rPr lang="en-GB" dirty="0"/>
+              <a:t>from index 3 to end</a:t>
+            </a:r>
+          </a:p>
+        </p:txBody>
+      </p:sp>
+      <p:sp>
+        <p:nvSpPr>
+          <p:cNvPr id="27" name="TextBox 26">
+            <a:extLst>
+              <a:ext uri="{FF2B5EF4-FFF2-40B4-BE49-F238E27FC236}">
+                <a16:creationId xmlns:a16="http://schemas.microsoft.com/office/drawing/2014/main" id="{37F8EF1E-6CA8-E825-363C-D85A60FA61B3}"/>
+              </a:ext>
+            </a:extLst>
+          </p:cNvPr>
+          <p:cNvSpPr txBox="1"/>
+          <p:nvPr/>
+        </p:nvSpPr>
+        <p:spPr>
+          <a:xfrm>
+            <a:off x="1737207" y="13312488"/>
+            <a:ext cx="3007618" cy="707886"/>
+          </a:xfrm>
+          <a:prstGeom prst="rect">
+            <a:avLst/>
+          </a:prstGeom>
+          <a:noFill/>
+        </p:spPr>
+        <p:txBody>
+          <a:bodyPr wrap="none" rtlCol="0">
+            <a:spAutoFit/>
+          </a:bodyPr>
+          <a:lstStyle>
+            <a:defPPr>
+              <a:defRPr lang="en-US"/>
+            </a:defPPr>
+            <a:lvl1pPr>
+              <a:defRPr sz="4000"/>
+            </a:lvl1pPr>
+          </a:lstStyle>
+          <a:p>
+            <a:r>
+              <a:rPr lang="en-GB" dirty="0"/>
+              <a:t>reverse string</a:t>
+            </a:r>
+          </a:p>
+        </p:txBody>
+      </p:sp>
+      <p:sp>
+        <p:nvSpPr>
+          <p:cNvPr id="7" name="TextBox 6">
+            <a:extLst>
+              <a:ext uri="{FF2B5EF4-FFF2-40B4-BE49-F238E27FC236}">
+                <a16:creationId xmlns:a16="http://schemas.microsoft.com/office/drawing/2014/main" id="{6831FAEE-955B-B8EA-0F49-BCDF9341F9F2}"/>
+              </a:ext>
+            </a:extLst>
+          </p:cNvPr>
+          <p:cNvSpPr txBox="1"/>
+          <p:nvPr/>
+        </p:nvSpPr>
+        <p:spPr>
+          <a:xfrm>
+            <a:off x="-5510463" y="2935704"/>
+            <a:ext cx="4645054" cy="707886"/>
+          </a:xfrm>
+          <a:prstGeom prst="rect">
+            <a:avLst/>
+          </a:prstGeom>
+          <a:noFill/>
+        </p:spPr>
+        <p:txBody>
+          <a:bodyPr wrap="none" rtlCol="0">
+            <a:spAutoFit/>
+          </a:bodyPr>
+          <a:lstStyle/>
+          <a:p>
+            <a:r>
+              <a:rPr lang="en-GB" sz="4000" b="1" dirty="0">
+                <a:latin typeface="+mj-lt"/>
+              </a:rPr>
+              <a:t>py_005_string_slicing</a:t>
+            </a:r>
+            <a:endParaRPr lang="en-DE" sz="4000" b="1" dirty="0">
+              <a:latin typeface="+mj-lt"/>
+            </a:endParaRPr>
+          </a:p>
+        </p:txBody>
+      </p:sp>
     </p:spTree>
     <p:extLst>
       <p:ext uri="{BB962C8B-B14F-4D97-AF65-F5344CB8AC3E}">
@@ -10313,6 +11525,37 @@
           <a:chExt cx="0" cy="0"/>
         </a:xfrm>
       </p:grpSpPr>
+      <p:pic>
+        <p:nvPicPr>
+          <p:cNvPr id="10" name="Picture 9">
+            <a:extLst>
+              <a:ext uri="{FF2B5EF4-FFF2-40B4-BE49-F238E27FC236}">
+                <a16:creationId xmlns:a16="http://schemas.microsoft.com/office/drawing/2014/main" id="{12A42397-E50A-DF63-3760-9C9A97C7B3A5}"/>
+              </a:ext>
+            </a:extLst>
+          </p:cNvPr>
+          <p:cNvPicPr>
+            <a:picLocks noChangeAspect="1"/>
+          </p:cNvPicPr>
+          <p:nvPr/>
+        </p:nvPicPr>
+        <p:blipFill rotWithShape="1">
+          <a:blip r:embed="rId3"/>
+          <a:srcRect l="12533" t="28553" r="8210" b="15149"/>
+          <a:stretch>
+            <a:fillRect/>
+          </a:stretch>
+        </p:blipFill>
+        <p:spPr>
+          <a:xfrm>
+            <a:off x="223306" y="5899840"/>
+            <a:ext cx="9838800" cy="3920149"/>
+          </a:xfrm>
+          <a:prstGeom prst="rect">
+            <a:avLst/>
+          </a:prstGeom>
+        </p:spPr>
+      </p:pic>
       <p:grpSp>
         <p:nvGrpSpPr>
           <p:cNvPr id="15" name="Group 14">
@@ -10327,7 +11570,7 @@
         </p:nvGrpSpPr>
         <p:grpSpPr>
           <a:xfrm>
-            <a:off x="223306" y="5058812"/>
+            <a:off x="223306" y="4625678"/>
             <a:ext cx="9838800" cy="1107996"/>
             <a:chOff x="223306" y="2872200"/>
             <a:chExt cx="9838800" cy="1107996"/>
@@ -10392,7 +11635,7 @@
                 <a:rPr lang="en-GB" sz="6600" b="1" dirty="0">
                   <a:latin typeface="+mj-lt"/>
                 </a:rPr>
-                <a:t>Use 'with' Statement</a:t>
+                <a:t>List Comprehensions</a:t>
               </a:r>
               <a:endParaRPr lang="en-GB" b="1" dirty="0">
                 <a:ln w="0"/>
@@ -10426,7 +11669,7 @@
             <p:nvPr/>
           </p:nvPicPr>
           <p:blipFill>
-            <a:blip r:embed="rId3"/>
+            <a:blip r:embed="rId4"/>
             <a:stretch>
               <a:fillRect/>
             </a:stretch>
@@ -10444,10 +11687,10 @@
       </p:grpSp>
       <p:sp>
         <p:nvSpPr>
-          <p:cNvPr id="7" name="TextBox 6">
-            <a:extLst>
-              <a:ext uri="{FF2B5EF4-FFF2-40B4-BE49-F238E27FC236}">
-                <a16:creationId xmlns:a16="http://schemas.microsoft.com/office/drawing/2014/main" id="{FC490A48-FDDC-CA56-7D3A-6259AD2D71C3}"/>
+          <p:cNvPr id="13" name="TextBox 12">
+            <a:extLst>
+              <a:ext uri="{FF2B5EF4-FFF2-40B4-BE49-F238E27FC236}">
+                <a16:creationId xmlns:a16="http://schemas.microsoft.com/office/drawing/2014/main" id="{6AACDDF8-9461-833E-A5D0-B258E1311441}"/>
               </a:ext>
             </a:extLst>
           </p:cNvPr>
@@ -10456,8 +11699,8 @@
         </p:nvSpPr>
         <p:spPr>
           <a:xfrm>
-            <a:off x="186673" y="13917695"/>
-            <a:ext cx="2545762" cy="707886"/>
+            <a:off x="86674" y="10244674"/>
+            <a:ext cx="10112064" cy="923330"/>
           </a:xfrm>
           <a:prstGeom prst="rect">
             <a:avLst/>
@@ -10471,200 +11714,12 @@
           <a:lstStyle/>
           <a:p>
             <a:r>
-              <a:rPr lang="en-US" sz="4000" b="1" dirty="0"/>
-              <a:t>Automatic:</a:t>
-            </a:r>
-            <a:endParaRPr lang="en-DE" sz="4000" dirty="0"/>
-          </a:p>
-        </p:txBody>
-      </p:sp>
-      <p:sp>
-        <p:nvSpPr>
-          <p:cNvPr id="11" name="TextBox 10">
-            <a:extLst>
-              <a:ext uri="{FF2B5EF4-FFF2-40B4-BE49-F238E27FC236}">
-                <a16:creationId xmlns:a16="http://schemas.microsoft.com/office/drawing/2014/main" id="{3C107D96-4FC3-027C-1D15-683F85C805B5}"/>
-              </a:ext>
-            </a:extLst>
-          </p:cNvPr>
-          <p:cNvSpPr txBox="1"/>
-          <p:nvPr/>
-        </p:nvSpPr>
-        <p:spPr>
-          <a:xfrm>
-            <a:off x="3425118" y="13917695"/>
-            <a:ext cx="6673622" cy="830997"/>
-          </a:xfrm>
-          <a:prstGeom prst="rect">
-            <a:avLst/>
-          </a:prstGeom>
-          <a:noFill/>
-        </p:spPr>
-        <p:txBody>
-          <a:bodyPr wrap="none" rtlCol="0">
-            <a:spAutoFit/>
-          </a:bodyPr>
-          <a:lstStyle/>
-          <a:p>
-            <a:r>
-              <a:rPr lang="en-GB" sz="4800" dirty="0">
+              <a:rPr lang="en-GB" sz="5400" dirty="0">
                 <a:latin typeface="Patrick Hand" pitchFamily="2" charset="77"/>
               </a:rPr>
-              <a:t>No more manual close() calls</a:t>
-            </a:r>
-            <a:endParaRPr lang="en-DE" sz="4800" dirty="0">
-              <a:latin typeface="Patrick Hand" pitchFamily="2" charset="77"/>
-            </a:endParaRPr>
-          </a:p>
-        </p:txBody>
-      </p:sp>
-      <p:sp>
-        <p:nvSpPr>
-          <p:cNvPr id="8" name="TextBox 7">
-            <a:extLst>
-              <a:ext uri="{FF2B5EF4-FFF2-40B4-BE49-F238E27FC236}">
-                <a16:creationId xmlns:a16="http://schemas.microsoft.com/office/drawing/2014/main" id="{12E3EC7A-21B7-943A-EA25-C438EAE74DC0}"/>
-              </a:ext>
-            </a:extLst>
-          </p:cNvPr>
-          <p:cNvSpPr txBox="1"/>
-          <p:nvPr/>
-        </p:nvSpPr>
-        <p:spPr>
-          <a:xfrm>
-            <a:off x="186673" y="15000794"/>
-            <a:ext cx="1344663" cy="707886"/>
-          </a:xfrm>
-          <a:prstGeom prst="rect">
-            <a:avLst/>
-          </a:prstGeom>
-          <a:noFill/>
-        </p:spPr>
-        <p:txBody>
-          <a:bodyPr wrap="none" rtlCol="0">
-            <a:spAutoFit/>
-          </a:bodyPr>
-          <a:lstStyle/>
-          <a:p>
-            <a:r>
-              <a:rPr lang="en-GB" sz="4000" b="1" dirty="0"/>
-              <a:t>Safe: </a:t>
-            </a:r>
-            <a:endParaRPr lang="en-DE" sz="4000" b="1" dirty="0"/>
-          </a:p>
-        </p:txBody>
-      </p:sp>
-      <p:sp>
-        <p:nvSpPr>
-          <p:cNvPr id="12" name="TextBox 11">
-            <a:extLst>
-              <a:ext uri="{FF2B5EF4-FFF2-40B4-BE49-F238E27FC236}">
-                <a16:creationId xmlns:a16="http://schemas.microsoft.com/office/drawing/2014/main" id="{30FAB019-507A-2EC2-3DA2-A9BB1C904276}"/>
-              </a:ext>
-            </a:extLst>
-          </p:cNvPr>
-          <p:cNvSpPr txBox="1"/>
-          <p:nvPr/>
-        </p:nvSpPr>
-        <p:spPr>
-          <a:xfrm>
-            <a:off x="3490841" y="14991319"/>
-            <a:ext cx="6607899" cy="830997"/>
-          </a:xfrm>
-          <a:prstGeom prst="rect">
-            <a:avLst/>
-          </a:prstGeom>
-          <a:noFill/>
-        </p:spPr>
-        <p:txBody>
-          <a:bodyPr wrap="none" rtlCol="0">
-            <a:spAutoFit/>
-          </a:bodyPr>
-          <a:lstStyle/>
-          <a:p>
-            <a:r>
-              <a:rPr lang="en-GB" sz="4800" dirty="0">
-                <a:latin typeface="Patrick Hand" pitchFamily="2" charset="77"/>
-              </a:rPr>
-              <a:t>Prevents leaks during errors</a:t>
-            </a:r>
-            <a:endParaRPr lang="en-DE" sz="4800" dirty="0">
-              <a:latin typeface="Patrick Hand" pitchFamily="2" charset="77"/>
-            </a:endParaRPr>
-          </a:p>
-        </p:txBody>
-      </p:sp>
-      <p:sp>
-        <p:nvSpPr>
-          <p:cNvPr id="9" name="TextBox 8">
-            <a:extLst>
-              <a:ext uri="{FF2B5EF4-FFF2-40B4-BE49-F238E27FC236}">
-                <a16:creationId xmlns:a16="http://schemas.microsoft.com/office/drawing/2014/main" id="{15FEAAD5-4282-A2CD-8811-5319C0B2D77D}"/>
-              </a:ext>
-            </a:extLst>
-          </p:cNvPr>
-          <p:cNvSpPr txBox="1"/>
-          <p:nvPr/>
-        </p:nvSpPr>
-        <p:spPr>
-          <a:xfrm>
-            <a:off x="186673" y="16064942"/>
-            <a:ext cx="1625766" cy="707886"/>
-          </a:xfrm>
-          <a:prstGeom prst="rect">
-            <a:avLst/>
-          </a:prstGeom>
-          <a:noFill/>
-        </p:spPr>
-        <p:txBody>
-          <a:bodyPr wrap="none" rtlCol="0">
-            <a:spAutoFit/>
-          </a:bodyPr>
-          <a:lstStyle/>
-          <a:p>
-            <a:r>
-              <a:rPr lang="en-GB" sz="4000" b="1" dirty="0"/>
-              <a:t>Clean: </a:t>
-            </a:r>
-            <a:endParaRPr lang="en-DE" sz="4000" b="1" dirty="0"/>
-          </a:p>
-        </p:txBody>
-      </p:sp>
-      <p:sp>
-        <p:nvSpPr>
-          <p:cNvPr id="13" name="TextBox 12">
-            <a:extLst>
-              <a:ext uri="{FF2B5EF4-FFF2-40B4-BE49-F238E27FC236}">
-                <a16:creationId xmlns:a16="http://schemas.microsoft.com/office/drawing/2014/main" id="{6AACDDF8-9461-833E-A5D0-B258E1311441}"/>
-              </a:ext>
-            </a:extLst>
-          </p:cNvPr>
-          <p:cNvSpPr txBox="1"/>
-          <p:nvPr/>
-        </p:nvSpPr>
-        <p:spPr>
-          <a:xfrm>
-            <a:off x="3668775" y="16064942"/>
-            <a:ext cx="6429965" cy="830997"/>
-          </a:xfrm>
-          <a:prstGeom prst="rect">
-            <a:avLst/>
-          </a:prstGeom>
-          <a:noFill/>
-        </p:spPr>
-        <p:txBody>
-          <a:bodyPr wrap="none" rtlCol="0">
-            <a:spAutoFit/>
-          </a:bodyPr>
-          <a:lstStyle/>
-          <a:p>
-            <a:r>
-              <a:rPr lang="en-GB" sz="4800" dirty="0">
-                <a:latin typeface="Patrick Hand" pitchFamily="2" charset="77"/>
-              </a:rPr>
-              <a:t>Less code, better readability</a:t>
-            </a:r>
-            <a:endParaRPr lang="en-DE" sz="4800" dirty="0">
+              <a:t>Prefer List Comprehensions Over Loops</a:t>
+            </a:r>
+            <a:endParaRPr lang="en-DE" sz="5400" dirty="0">
               <a:latin typeface="Patrick Hand" pitchFamily="2" charset="77"/>
             </a:endParaRPr>
           </a:p>
@@ -10686,7 +11741,7 @@
         </p:nvCxnSpPr>
         <p:spPr>
           <a:xfrm>
-            <a:off x="235460" y="9058736"/>
+            <a:off x="235460" y="8697791"/>
             <a:ext cx="9838255" cy="0"/>
           </a:xfrm>
           <a:prstGeom prst="line">
@@ -10730,10 +11785,10 @@
           <p:nvPr/>
         </p:nvPicPr>
         <p:blipFill>
-          <a:blip r:embed="rId4">
+          <a:blip r:embed="rId5">
             <a:extLst>
               <a:ext uri="{96DAC541-7B7A-43D3-8B79-37D633B846F1}">
-                <asvg:svgBlip xmlns:asvg="http://schemas.microsoft.com/office/drawing/2016/SVG/main" r:embed="rId5"/>
+                <asvg:svgBlip xmlns:asvg="http://schemas.microsoft.com/office/drawing/2016/SVG/main" r:embed="rId6"/>
               </a:ext>
             </a:extLst>
           </a:blip>
@@ -10743,7 +11798,7 @@
         </p:blipFill>
         <p:spPr>
           <a:xfrm>
-            <a:off x="8973493" y="9218781"/>
+            <a:off x="9286312" y="8761584"/>
             <a:ext cx="914400" cy="914400"/>
           </a:xfrm>
           <a:prstGeom prst="rect">
@@ -10766,10 +11821,10 @@
           <p:nvPr/>
         </p:nvPicPr>
         <p:blipFill>
-          <a:blip r:embed="rId6">
+          <a:blip r:embed="rId7">
             <a:extLst>
               <a:ext uri="{96DAC541-7B7A-43D3-8B79-37D633B846F1}">
-                <asvg:svgBlip xmlns:asvg="http://schemas.microsoft.com/office/drawing/2016/SVG/main" r:embed="rId7"/>
+                <asvg:svgBlip xmlns:asvg="http://schemas.microsoft.com/office/drawing/2016/SVG/main" r:embed="rId8"/>
               </a:ext>
             </a:extLst>
           </a:blip>
@@ -10779,7 +11834,7 @@
         </p:blipFill>
         <p:spPr>
           <a:xfrm>
-            <a:off x="8973493" y="6740024"/>
+            <a:off x="6519055" y="6740024"/>
             <a:ext cx="914400" cy="914400"/>
           </a:xfrm>
           <a:prstGeom prst="rect">
@@ -10787,6 +11842,46 @@
           </a:prstGeom>
         </p:spPr>
       </p:pic>
+      <p:sp>
+        <p:nvSpPr>
+          <p:cNvPr id="2" name="TextBox 1">
+            <a:extLst>
+              <a:ext uri="{FF2B5EF4-FFF2-40B4-BE49-F238E27FC236}">
+                <a16:creationId xmlns:a16="http://schemas.microsoft.com/office/drawing/2014/main" id="{C6980289-6424-63AF-C0EC-C2EF73FE186B}"/>
+              </a:ext>
+            </a:extLst>
+          </p:cNvPr>
+          <p:cNvSpPr txBox="1"/>
+          <p:nvPr/>
+        </p:nvSpPr>
+        <p:spPr>
+          <a:xfrm>
+            <a:off x="-6569242" y="3080083"/>
+            <a:ext cx="6211509" cy="707886"/>
+          </a:xfrm>
+          <a:prstGeom prst="rect">
+            <a:avLst/>
+          </a:prstGeom>
+          <a:noFill/>
+        </p:spPr>
+        <p:txBody>
+          <a:bodyPr wrap="none" rtlCol="0">
+            <a:spAutoFit/>
+          </a:bodyPr>
+          <a:lstStyle/>
+          <a:p>
+            <a:r>
+              <a:rPr lang="en-GB" sz="4000" b="1" dirty="0">
+                <a:latin typeface="+mj-lt"/>
+              </a:rPr>
+              <a:t>py_006_list_comprehensions</a:t>
+            </a:r>
+            <a:endParaRPr lang="en-DE" sz="4000" b="1" dirty="0">
+              <a:latin typeface="+mj-lt"/>
+            </a:endParaRPr>
+          </a:p>
+        </p:txBody>
+      </p:sp>
     </p:spTree>
     <p:extLst>
       <p:ext uri="{BB962C8B-B14F-4D97-AF65-F5344CB8AC3E}">
@@ -10837,6 +11932,37 @@
           <a:chExt cx="0" cy="0"/>
         </a:xfrm>
       </p:grpSpPr>
+      <p:pic>
+        <p:nvPicPr>
+          <p:cNvPr id="28" name="Picture 27">
+            <a:extLst>
+              <a:ext uri="{FF2B5EF4-FFF2-40B4-BE49-F238E27FC236}">
+                <a16:creationId xmlns:a16="http://schemas.microsoft.com/office/drawing/2014/main" id="{BC46E8B4-CAF7-41BA-F7C0-9507E381E539}"/>
+              </a:ext>
+            </a:extLst>
+          </p:cNvPr>
+          <p:cNvPicPr>
+            <a:picLocks noChangeAspect="1"/>
+          </p:cNvPicPr>
+          <p:nvPr/>
+        </p:nvPicPr>
+        <p:blipFill rotWithShape="1">
+          <a:blip r:embed="rId4"/>
+          <a:srcRect l="21363" t="30504" r="11633" b="16598"/>
+          <a:stretch>
+            <a:fillRect/>
+          </a:stretch>
+        </p:blipFill>
+        <p:spPr>
+          <a:xfrm>
+            <a:off x="410506" y="6143223"/>
+            <a:ext cx="9464400" cy="5251469"/>
+          </a:xfrm>
+          <a:prstGeom prst="rect">
+            <a:avLst/>
+          </a:prstGeom>
+        </p:spPr>
+      </p:pic>
       <p:sp>
         <p:nvSpPr>
           <p:cNvPr id="9" name="TextBox 8">
@@ -10851,8 +11977,8 @@
         </p:nvSpPr>
         <p:spPr>
           <a:xfrm>
-            <a:off x="963120" y="4920953"/>
-            <a:ext cx="8359169" cy="1107996"/>
+            <a:off x="412958" y="4920953"/>
+            <a:ext cx="9459497" cy="1107996"/>
           </a:xfrm>
           <a:prstGeom prst="rect">
             <a:avLst/>
@@ -10893,7 +12019,7 @@
           <a:p>
             <a:pPr algn="ctr"/>
             <a:r>
-              <a:rPr lang="en-DE" sz="6600" b="1" dirty="0">
+              <a:rPr lang="en-GB" sz="6600" b="1" dirty="0">
                 <a:ln w="6600">
                   <a:solidFill>
                     <a:schemeClr val="accent2"/>
@@ -10908,49 +12034,9 @@
                     <a:schemeClr val="accent2"/>
                   </a:outerShdw>
                 </a:effectLst>
-                <a:latin typeface="Patrick Hand" pitchFamily="2" charset="77"/>
+                <a:latin typeface="+mj-lt"/>
               </a:rPr>
-              <a:t>Decor</a:t>
-            </a:r>
-            <a:r>
-              <a:rPr lang="en-US" sz="6600" b="1" dirty="0">
-                <a:ln w="6600">
-                  <a:solidFill>
-                    <a:schemeClr val="accent2"/>
-                  </a:solidFill>
-                  <a:prstDash val="solid"/>
-                </a:ln>
-                <a:solidFill>
-                  <a:srgbClr val="FFFFFF"/>
-                </a:solidFill>
-                <a:effectLst>
-                  <a:outerShdw dist="38100" dir="2700000" algn="tl" rotWithShape="0">
-                    <a:schemeClr val="accent2"/>
-                  </a:outerShdw>
-                </a:effectLst>
-                <a:latin typeface="Patrick Hand" pitchFamily="2" charset="77"/>
-              </a:rPr>
-              <a:t>a</a:t>
-            </a:r>
-            <a:r>
-              <a:rPr lang="en-DE" sz="6600" b="1" dirty="0">
-                <a:ln w="6600">
-                  <a:solidFill>
-                    <a:schemeClr val="accent2"/>
-                  </a:solidFill>
-                  <a:prstDash val="solid"/>
-                </a:ln>
-                <a:solidFill>
-                  <a:srgbClr val="FFFFFF"/>
-                </a:solidFill>
-                <a:effectLst>
-                  <a:outerShdw dist="38100" dir="2700000" algn="tl" rotWithShape="0">
-                    <a:schemeClr val="accent2"/>
-                  </a:outerShdw>
-                </a:effectLst>
-                <a:latin typeface="Patrick Hand" pitchFamily="2" charset="77"/>
-              </a:rPr>
-              <a:t>tors</a:t>
+              <a:t>Range Checking</a:t>
             </a:r>
             <a:endParaRPr lang="en-DE" sz="6600" dirty="0">
               <a:ln w="0"/>
@@ -10961,7 +12047,7 @@
                   </a:schemeClr>
                 </a:outerShdw>
               </a:effectLst>
-              <a:latin typeface="Patrick Hand" pitchFamily="2" charset="77"/>
+              <a:latin typeface="+mj-lt"/>
             </a:endParaRPr>
           </a:p>
         </p:txBody>
@@ -10981,14 +12067,14 @@
           <p:nvPr/>
         </p:nvPicPr>
         <p:blipFill>
-          <a:blip r:embed="rId4"/>
+          <a:blip r:embed="rId5"/>
           <a:stretch>
             <a:fillRect/>
           </a:stretch>
         </p:blipFill>
         <p:spPr>
           <a:xfrm>
-            <a:off x="1097040" y="4946903"/>
+            <a:off x="493928" y="4946903"/>
             <a:ext cx="1063167" cy="1063167"/>
           </a:xfrm>
           <a:prstGeom prst="rect">
@@ -11012,8 +12098,8 @@
         </p:nvCxnSpPr>
         <p:spPr>
           <a:xfrm>
-            <a:off x="963120" y="10225821"/>
-            <a:ext cx="8359169" cy="0"/>
+            <a:off x="405785" y="9170743"/>
+            <a:ext cx="9466670" cy="0"/>
           </a:xfrm>
           <a:prstGeom prst="line">
             <a:avLst/>
@@ -11056,10 +12142,10 @@
           <p:nvPr/>
         </p:nvPicPr>
         <p:blipFill>
-          <a:blip r:embed="rId5">
+          <a:blip r:embed="rId6">
             <a:extLst>
               <a:ext uri="{96DAC541-7B7A-43D3-8B79-37D633B846F1}">
-                <asvg:svgBlip xmlns:asvg="http://schemas.microsoft.com/office/drawing/2016/SVG/main" r:embed="rId6"/>
+                <asvg:svgBlip xmlns:asvg="http://schemas.microsoft.com/office/drawing/2016/SVG/main" r:embed="rId7"/>
               </a:ext>
             </a:extLst>
           </a:blip>
@@ -11069,7 +12155,7 @@
         </p:blipFill>
         <p:spPr>
           <a:xfrm>
-            <a:off x="5883882" y="10648304"/>
+            <a:off x="5883882" y="9409047"/>
             <a:ext cx="914400" cy="914400"/>
           </a:xfrm>
           <a:prstGeom prst="rect">
@@ -11092,10 +12178,10 @@
           <p:nvPr/>
         </p:nvPicPr>
         <p:blipFill>
-          <a:blip r:embed="rId7">
+          <a:blip r:embed="rId8">
             <a:extLst>
               <a:ext uri="{96DAC541-7B7A-43D3-8B79-37D633B846F1}">
-                <asvg:svgBlip xmlns:asvg="http://schemas.microsoft.com/office/drawing/2016/SVG/main" r:embed="rId8"/>
+                <asvg:svgBlip xmlns:asvg="http://schemas.microsoft.com/office/drawing/2016/SVG/main" r:embed="rId9"/>
               </a:ext>
             </a:extLst>
           </a:blip>
@@ -11105,7 +12191,7 @@
         </p:blipFill>
         <p:spPr>
           <a:xfrm>
-            <a:off x="5883882" y="8897747"/>
+            <a:off x="5883882" y="7244793"/>
             <a:ext cx="914400" cy="914400"/>
           </a:xfrm>
           <a:prstGeom prst="rect">
@@ -11127,8 +12213,8 @@
         </p:nvSpPr>
         <p:spPr>
           <a:xfrm>
-            <a:off x="405785" y="14009019"/>
-            <a:ext cx="9879628" cy="769441"/>
+            <a:off x="410506" y="11485362"/>
+            <a:ext cx="9464400" cy="2554545"/>
           </a:xfrm>
           <a:prstGeom prst="rect">
             <a:avLst/>
@@ -11136,30 +12222,19 @@
           <a:noFill/>
         </p:spPr>
         <p:txBody>
-          <a:bodyPr wrap="none" rtlCol="0">
+          <a:bodyPr wrap="square" rtlCol="0">
             <a:spAutoFit/>
           </a:bodyPr>
           <a:lstStyle/>
           <a:p>
-            <a:r>
-              <a:rPr lang="en-GB" sz="4400" dirty="0">
+            <a:pPr algn="ctr"/>
+            <a:r>
+              <a:rPr lang="en-GB" sz="8000" dirty="0">
                 <a:latin typeface="Patrick Hand" pitchFamily="2" charset="77"/>
               </a:rPr>
-              <a:t>Extend </a:t>
-            </a:r>
-            <a:r>
-              <a:rPr lang="en-GB" sz="4400" dirty="0" err="1">
-                <a:latin typeface="Patrick Hand" pitchFamily="2" charset="77"/>
-              </a:rPr>
-              <a:t>behavior</a:t>
-            </a:r>
-            <a:r>
-              <a:rPr lang="en-GB" sz="4400" dirty="0">
-                <a:latin typeface="Patrick Hand" pitchFamily="2" charset="77"/>
-              </a:rPr>
-              <a:t> without changing the core logic</a:t>
-            </a:r>
-            <a:endParaRPr lang="en-DE" sz="4400" dirty="0">
+              <a:t>Stop Using AND! Python's Secret Trick</a:t>
+            </a:r>
+            <a:endParaRPr lang="en-DE" sz="8000" dirty="0">
               <a:latin typeface="Patrick Hand" pitchFamily="2" charset="77"/>
             </a:endParaRPr>
           </a:p>
@@ -11236,6 +12311,37 @@
           <a:chExt cx="0" cy="0"/>
         </a:xfrm>
       </p:grpSpPr>
+      <p:pic>
+        <p:nvPicPr>
+          <p:cNvPr id="2" name="Picture 1">
+            <a:extLst>
+              <a:ext uri="{FF2B5EF4-FFF2-40B4-BE49-F238E27FC236}">
+                <a16:creationId xmlns:a16="http://schemas.microsoft.com/office/drawing/2014/main" id="{A37AA22C-DA9F-8DEB-92AB-F4257AA14F47}"/>
+              </a:ext>
+            </a:extLst>
+          </p:cNvPr>
+          <p:cNvPicPr>
+            <a:picLocks noChangeAspect="1"/>
+          </p:cNvPicPr>
+          <p:nvPr/>
+        </p:nvPicPr>
+        <p:blipFill rotWithShape="1">
+          <a:blip r:embed="rId3"/>
+          <a:srcRect l="17920" t="21567" r="12998" b="14415"/>
+          <a:stretch>
+            <a:fillRect/>
+          </a:stretch>
+        </p:blipFill>
+        <p:spPr>
+          <a:xfrm>
+            <a:off x="205353" y="5893036"/>
+            <a:ext cx="9838800" cy="7531988"/>
+          </a:xfrm>
+          <a:prstGeom prst="rect">
+            <a:avLst/>
+          </a:prstGeom>
+        </p:spPr>
+      </p:pic>
       <p:sp>
         <p:nvSpPr>
           <p:cNvPr id="4" name="TextBox 3">
@@ -11250,8 +12356,8 @@
         </p:nvSpPr>
         <p:spPr>
           <a:xfrm>
-            <a:off x="223306" y="4701002"/>
-            <a:ext cx="9838800" cy="1107996"/>
+            <a:off x="223306" y="4701000"/>
+            <a:ext cx="9838255" cy="1097069"/>
           </a:xfrm>
           <a:prstGeom prst="rect">
             <a:avLst/>
@@ -11273,8 +12379,8 @@
           </a:fontRef>
         </p:style>
         <p:txBody>
-          <a:bodyPr wrap="square" rtlCol="0">
-            <a:spAutoFit/>
+          <a:bodyPr wrap="square" rtlCol="0" anchor="ctr" anchorCtr="0">
+            <a:noAutofit/>
             <a:scene3d>
               <a:camera prst="orthographicFront"/>
               <a:lightRig rig="harsh" dir="t"/>
@@ -11290,30 +12396,12 @@
           </a:bodyPr>
           <a:lstStyle/>
           <a:p>
-            <a:pPr algn="ctr"/>
-            <a:r>
-              <a:rPr lang="en-GB" sz="6600" dirty="0"/>
-              <a:t>F-Strings </a:t>
-            </a:r>
-            <a:r>
-              <a:rPr lang="en-GB" sz="6600" b="1" dirty="0">
-                <a:ln w="22225">
-                  <a:solidFill>
-                    <a:schemeClr val="accent2"/>
-                  </a:solidFill>
-                  <a:prstDash val="solid"/>
-                </a:ln>
-                <a:solidFill>
-                  <a:srgbClr val="00B0F0"/>
-                </a:solidFill>
-              </a:rPr>
-              <a:t>vs</a:t>
-            </a:r>
-            <a:r>
-              <a:rPr lang="en-GB" sz="6600" dirty="0"/>
-              <a:t> Format</a:t>
-            </a:r>
-            <a:endParaRPr lang="en-GB" b="1" dirty="0">
+            <a:pPr algn="r"/>
+            <a:r>
+              <a:rPr lang="en-GB" sz="5400" b="1" dirty="0"/>
+              <a:t>Understanding Tuples &amp; Lists</a:t>
+            </a:r>
+            <a:endParaRPr lang="en-GB" sz="1400" b="1" dirty="0">
               <a:ln w="0"/>
               <a:solidFill>
                 <a:schemeClr val="tx1"/>
@@ -11345,7 +12433,7 @@
           <p:nvPr/>
         </p:nvPicPr>
         <p:blipFill>
-          <a:blip r:embed="rId3"/>
+          <a:blip r:embed="rId4"/>
           <a:stretch>
             <a:fillRect/>
           </a:stretch>
@@ -11362,10 +12450,10 @@
       </p:pic>
       <p:sp>
         <p:nvSpPr>
-          <p:cNvPr id="7" name="TextBox 6">
-            <a:extLst>
-              <a:ext uri="{FF2B5EF4-FFF2-40B4-BE49-F238E27FC236}">
-                <a16:creationId xmlns:a16="http://schemas.microsoft.com/office/drawing/2014/main" id="{470B9811-0F6C-A74D-399A-984849072C23}"/>
+          <p:cNvPr id="13" name="TextBox 12">
+            <a:extLst>
+              <a:ext uri="{FF2B5EF4-FFF2-40B4-BE49-F238E27FC236}">
+                <a16:creationId xmlns:a16="http://schemas.microsoft.com/office/drawing/2014/main" id="{52E6ABE3-1E92-6F86-7CA0-C6FADF7C5095}"/>
               </a:ext>
             </a:extLst>
           </p:cNvPr>
@@ -11374,48 +12462,8 @@
         </p:nvSpPr>
         <p:spPr>
           <a:xfrm>
-            <a:off x="223306" y="13037235"/>
-            <a:ext cx="2422971" cy="707886"/>
-          </a:xfrm>
-          <a:prstGeom prst="rect">
-            <a:avLst/>
-          </a:prstGeom>
-          <a:noFill/>
-        </p:spPr>
-        <p:txBody>
-          <a:bodyPr wrap="none" rtlCol="0">
-            <a:spAutoFit/>
-          </a:bodyPr>
-          <a:lstStyle/>
-          <a:p>
-            <a:r>
-              <a:rPr lang="en-GB" sz="4000" b="1" dirty="0"/>
-              <a:t>Readable:</a:t>
-            </a:r>
-            <a:r>
-              <a:rPr lang="en-GB" sz="4000" dirty="0"/>
-              <a:t> </a:t>
-            </a:r>
-            <a:endParaRPr lang="en-DE" sz="4000" dirty="0"/>
-          </a:p>
-        </p:txBody>
-      </p:sp>
-      <p:sp>
-        <p:nvSpPr>
-          <p:cNvPr id="11" name="TextBox 10">
-            <a:extLst>
-              <a:ext uri="{FF2B5EF4-FFF2-40B4-BE49-F238E27FC236}">
-                <a16:creationId xmlns:a16="http://schemas.microsoft.com/office/drawing/2014/main" id="{A78813AD-F7A7-B5FC-5C7D-0687E4D3D610}"/>
-              </a:ext>
-            </a:extLst>
-          </p:cNvPr>
-          <p:cNvSpPr txBox="1"/>
-          <p:nvPr/>
-        </p:nvSpPr>
-        <p:spPr>
-          <a:xfrm>
-            <a:off x="2381255" y="13037235"/>
-            <a:ext cx="7543776" cy="707886"/>
+            <a:off x="205353" y="13692417"/>
+            <a:ext cx="9838800" cy="707886"/>
           </a:xfrm>
           <a:prstGeom prst="rect">
             <a:avLst/>
@@ -11428,11 +12476,12 @@
           </a:bodyPr>
           <a:lstStyle/>
           <a:p>
+            <a:pPr algn="ctr"/>
             <a:r>
               <a:rPr lang="en-GB" sz="4000" dirty="0">
                 <a:latin typeface="Patrick Hand" pitchFamily="2" charset="77"/>
               </a:rPr>
-              <a:t>Direct variable injection into strings</a:t>
+              <a:t>Tuple vs List in Python - Spot the Difference!</a:t>
             </a:r>
             <a:endParaRPr lang="en-DE" sz="4000" dirty="0">
               <a:latin typeface="Patrick Hand" pitchFamily="2" charset="77"/>
@@ -11440,194 +12489,6 @@
           </a:p>
         </p:txBody>
       </p:sp>
-      <p:sp>
-        <p:nvSpPr>
-          <p:cNvPr id="8" name="TextBox 7">
-            <a:extLst>
-              <a:ext uri="{FF2B5EF4-FFF2-40B4-BE49-F238E27FC236}">
-                <a16:creationId xmlns:a16="http://schemas.microsoft.com/office/drawing/2014/main" id="{256376E3-CABD-1877-68D4-60BF8B8214F8}"/>
-              </a:ext>
-            </a:extLst>
-          </p:cNvPr>
-          <p:cNvSpPr txBox="1"/>
-          <p:nvPr/>
-        </p:nvSpPr>
-        <p:spPr>
-          <a:xfrm>
-            <a:off x="223306" y="14120334"/>
-            <a:ext cx="1727909" cy="707886"/>
-          </a:xfrm>
-          <a:prstGeom prst="rect">
-            <a:avLst/>
-          </a:prstGeom>
-          <a:noFill/>
-        </p:spPr>
-        <p:txBody>
-          <a:bodyPr wrap="none" rtlCol="0">
-            <a:spAutoFit/>
-          </a:bodyPr>
-          <a:lstStyle/>
-          <a:p>
-            <a:r>
-              <a:rPr lang="en-GB" sz="4000" b="1" dirty="0"/>
-              <a:t>Faster: </a:t>
-            </a:r>
-            <a:endParaRPr lang="en-DE" sz="4000" b="1" dirty="0"/>
-          </a:p>
-        </p:txBody>
-      </p:sp>
-      <p:sp>
-        <p:nvSpPr>
-          <p:cNvPr id="12" name="TextBox 11">
-            <a:extLst>
-              <a:ext uri="{FF2B5EF4-FFF2-40B4-BE49-F238E27FC236}">
-                <a16:creationId xmlns:a16="http://schemas.microsoft.com/office/drawing/2014/main" id="{084482C2-56C7-DEF8-3919-CB98C47190C8}"/>
-              </a:ext>
-            </a:extLst>
-          </p:cNvPr>
-          <p:cNvSpPr txBox="1"/>
-          <p:nvPr/>
-        </p:nvSpPr>
-        <p:spPr>
-          <a:xfrm>
-            <a:off x="2369994" y="14110858"/>
-            <a:ext cx="7915419" cy="707886"/>
-          </a:xfrm>
-          <a:prstGeom prst="rect">
-            <a:avLst/>
-          </a:prstGeom>
-          <a:noFill/>
-        </p:spPr>
-        <p:txBody>
-          <a:bodyPr wrap="square" rtlCol="0">
-            <a:spAutoFit/>
-          </a:bodyPr>
-          <a:lstStyle/>
-          <a:p>
-            <a:r>
-              <a:rPr lang="en-GB" sz="4000" dirty="0">
-                <a:latin typeface="Patrick Hand" pitchFamily="2" charset="77"/>
-              </a:rPr>
-              <a:t>F-Strings are optimized by the compiler</a:t>
-            </a:r>
-            <a:endParaRPr lang="en-DE" sz="4000" dirty="0">
-              <a:latin typeface="Patrick Hand" pitchFamily="2" charset="77"/>
-            </a:endParaRPr>
-          </a:p>
-        </p:txBody>
-      </p:sp>
-      <p:sp>
-        <p:nvSpPr>
-          <p:cNvPr id="9" name="TextBox 8">
-            <a:extLst>
-              <a:ext uri="{FF2B5EF4-FFF2-40B4-BE49-F238E27FC236}">
-                <a16:creationId xmlns:a16="http://schemas.microsoft.com/office/drawing/2014/main" id="{366DD4EA-520B-F2EB-D460-A5C71B3EE88D}"/>
-              </a:ext>
-            </a:extLst>
-          </p:cNvPr>
-          <p:cNvSpPr txBox="1"/>
-          <p:nvPr/>
-        </p:nvSpPr>
-        <p:spPr>
-          <a:xfrm>
-            <a:off x="223306" y="15203433"/>
-            <a:ext cx="2157963" cy="707886"/>
-          </a:xfrm>
-          <a:prstGeom prst="rect">
-            <a:avLst/>
-          </a:prstGeom>
-          <a:noFill/>
-        </p:spPr>
-        <p:txBody>
-          <a:bodyPr wrap="none" rtlCol="0">
-            <a:spAutoFit/>
-          </a:bodyPr>
-          <a:lstStyle/>
-          <a:p>
-            <a:r>
-              <a:rPr lang="en-GB" sz="4000" b="1" dirty="0"/>
-              <a:t>Modern: </a:t>
-            </a:r>
-            <a:endParaRPr lang="en-DE" sz="4000" b="1" dirty="0"/>
-          </a:p>
-        </p:txBody>
-      </p:sp>
-      <p:sp>
-        <p:nvSpPr>
-          <p:cNvPr id="13" name="TextBox 12">
-            <a:extLst>
-              <a:ext uri="{FF2B5EF4-FFF2-40B4-BE49-F238E27FC236}">
-                <a16:creationId xmlns:a16="http://schemas.microsoft.com/office/drawing/2014/main" id="{52E6ABE3-1E92-6F86-7CA0-C6FADF7C5095}"/>
-              </a:ext>
-            </a:extLst>
-          </p:cNvPr>
-          <p:cNvSpPr txBox="1"/>
-          <p:nvPr/>
-        </p:nvSpPr>
-        <p:spPr>
-          <a:xfrm>
-            <a:off x="2381269" y="15184482"/>
-            <a:ext cx="7543309" cy="707886"/>
-          </a:xfrm>
-          <a:prstGeom prst="rect">
-            <a:avLst/>
-          </a:prstGeom>
-          <a:noFill/>
-        </p:spPr>
-        <p:txBody>
-          <a:bodyPr wrap="square" rtlCol="0">
-            <a:spAutoFit/>
-          </a:bodyPr>
-          <a:lstStyle/>
-          <a:p>
-            <a:r>
-              <a:rPr lang="en-GB" sz="4000" dirty="0">
-                <a:latin typeface="Patrick Hand" pitchFamily="2" charset="77"/>
-              </a:rPr>
-              <a:t>The standard since Python 3.6+</a:t>
-            </a:r>
-            <a:endParaRPr lang="en-DE" sz="4000" dirty="0">
-              <a:latin typeface="Patrick Hand" pitchFamily="2" charset="77"/>
-            </a:endParaRPr>
-          </a:p>
-        </p:txBody>
-      </p:sp>
-      <p:pic>
-        <p:nvPicPr>
-          <p:cNvPr id="18" name="Graphic 17" descr="Shield Tick with solid fill">
-            <a:extLst>
-              <a:ext uri="{FF2B5EF4-FFF2-40B4-BE49-F238E27FC236}">
-                <a16:creationId xmlns:a16="http://schemas.microsoft.com/office/drawing/2014/main" id="{ACE77A71-8D07-48B7-30F8-7E68A4376FB7}"/>
-              </a:ext>
-            </a:extLst>
-          </p:cNvPr>
-          <p:cNvPicPr>
-            <a:picLocks noChangeAspect="1"/>
-          </p:cNvPicPr>
-          <p:nvPr/>
-        </p:nvPicPr>
-        <p:blipFill>
-          <a:blip r:embed="rId4">
-            <a:extLst>
-              <a:ext uri="{96DAC541-7B7A-43D3-8B79-37D633B846F1}">
-                <asvg:svgBlip xmlns:asvg="http://schemas.microsoft.com/office/drawing/2016/SVG/main" r:embed="rId5"/>
-              </a:ext>
-            </a:extLst>
-          </a:blip>
-          <a:stretch>
-            <a:fillRect/>
-          </a:stretch>
-        </p:blipFill>
-        <p:spPr>
-          <a:xfrm>
-            <a:off x="2646277" y="11430008"/>
-            <a:ext cx="914400" cy="914400"/>
-          </a:xfrm>
-          <a:prstGeom prst="rect">
-            <a:avLst/>
-          </a:prstGeom>
-        </p:spPr>
-      </p:pic>
       <p:cxnSp>
         <p:nvCxnSpPr>
           <p:cNvPr id="14" name="Straight Connector 13">
@@ -11644,7 +12505,7 @@
         </p:nvCxnSpPr>
         <p:spPr>
           <a:xfrm>
-            <a:off x="232736" y="12488613"/>
+            <a:off x="232736" y="11474464"/>
             <a:ext cx="9838255" cy="0"/>
           </a:xfrm>
           <a:prstGeom prst="line">
@@ -11673,42 +12534,6 @@
           </a:fontRef>
         </p:style>
       </p:cxnSp>
-      <p:pic>
-        <p:nvPicPr>
-          <p:cNvPr id="15" name="Graphic 14" descr="Close with solid fill">
-            <a:extLst>
-              <a:ext uri="{FF2B5EF4-FFF2-40B4-BE49-F238E27FC236}">
-                <a16:creationId xmlns:a16="http://schemas.microsoft.com/office/drawing/2014/main" id="{54038AA9-B89F-0FCE-89F0-93FC98974320}"/>
-              </a:ext>
-            </a:extLst>
-          </p:cNvPr>
-          <p:cNvPicPr>
-            <a:picLocks noChangeAspect="1"/>
-          </p:cNvPicPr>
-          <p:nvPr/>
-        </p:nvPicPr>
-        <p:blipFill>
-          <a:blip r:embed="rId6">
-            <a:extLst>
-              <a:ext uri="{96DAC541-7B7A-43D3-8B79-37D633B846F1}">
-                <asvg:svgBlip xmlns:asvg="http://schemas.microsoft.com/office/drawing/2016/SVG/main" r:embed="rId7"/>
-              </a:ext>
-            </a:extLst>
-          </a:blip>
-          <a:stretch>
-            <a:fillRect/>
-          </a:stretch>
-        </p:blipFill>
-        <p:spPr>
-          <a:xfrm>
-            <a:off x="767203" y="11530342"/>
-            <a:ext cx="914400" cy="914400"/>
-          </a:xfrm>
-          <a:prstGeom prst="rect">
-            <a:avLst/>
-          </a:prstGeom>
-        </p:spPr>
-      </p:pic>
       <p:cxnSp>
         <p:nvCxnSpPr>
           <p:cNvPr id="16" name="Straight Connector 15">
@@ -11725,7 +12550,7 @@
         </p:nvCxnSpPr>
         <p:spPr>
           <a:xfrm>
-            <a:off x="210435" y="8674898"/>
+            <a:off x="210435" y="9107156"/>
             <a:ext cx="9838255" cy="0"/>
           </a:xfrm>
           <a:prstGeom prst="line">

</xml_diff>

<commit_message>
feat: added ts_001 and ts_013
</commit_message>
<xml_diff>
--- a/assets/images.pptx
+++ b/assets/images.pptx
@@ -551,7 +551,7 @@
           <a:p>
             <a:fld id="{CEF57384-5D6E-7E42-90C4-560B39EF53DD}" type="datetimeFigureOut">
               <a:rPr lang="en-DE" smtClean="0"/>
-              <a:t>26.01.26</a:t>
+              <a:t>01.02.26</a:t>
             </a:fld>
             <a:endParaRPr lang="en-DE"/>
           </a:p>
@@ -1181,7 +1181,7 @@
             <a:fld id="{48A87A34-81AB-432B-8DAE-1953F412C126}" type="datetimeFigureOut">
               <a:rPr lang="en-US" smtClean="0"/>
               <a:pPr/>
-              <a:t>1/26/26</a:t>
+              <a:t>2/1/26</a:t>
             </a:fld>
             <a:endParaRPr lang="en-US" dirty="0"/>
           </a:p>
@@ -1351,7 +1351,7 @@
           <a:p>
             <a:fld id="{48A87A34-81AB-432B-8DAE-1953F412C126}" type="datetimeFigureOut">
               <a:rPr lang="en-US" smtClean="0"/>
-              <a:t>1/26/26</a:t>
+              <a:t>2/1/26</a:t>
             </a:fld>
             <a:endParaRPr lang="en-US" dirty="0"/>
           </a:p>
@@ -1531,7 +1531,7 @@
           <a:p>
             <a:fld id="{48A87A34-81AB-432B-8DAE-1953F412C126}" type="datetimeFigureOut">
               <a:rPr lang="en-US" smtClean="0"/>
-              <a:t>1/26/26</a:t>
+              <a:t>2/1/26</a:t>
             </a:fld>
             <a:endParaRPr lang="en-US" dirty="0"/>
           </a:p>
@@ -1764,7 +1764,7 @@
             <a:fld id="{48A87A34-81AB-432B-8DAE-1953F412C126}" type="datetimeFigureOut">
               <a:rPr lang="en-US" smtClean="0"/>
               <a:pPr/>
-              <a:t>1/26/26</a:t>
+              <a:t>2/1/26</a:t>
             </a:fld>
             <a:endParaRPr lang="en-US" dirty="0"/>
           </a:p>
@@ -2037,7 +2037,7 @@
           <a:p>
             <a:fld id="{48A87A34-81AB-432B-8DAE-1953F412C126}" type="datetimeFigureOut">
               <a:rPr lang="en-US" smtClean="0"/>
-              <a:t>1/26/26</a:t>
+              <a:t>2/1/26</a:t>
             </a:fld>
             <a:endParaRPr lang="en-US" dirty="0"/>
           </a:p>
@@ -2269,7 +2269,7 @@
           <a:p>
             <a:fld id="{48A87A34-81AB-432B-8DAE-1953F412C126}" type="datetimeFigureOut">
               <a:rPr lang="en-US" smtClean="0"/>
-              <a:t>1/26/26</a:t>
+              <a:t>2/1/26</a:t>
             </a:fld>
             <a:endParaRPr lang="en-US" dirty="0"/>
           </a:p>
@@ -2636,7 +2636,7 @@
           <a:p>
             <a:fld id="{48A87A34-81AB-432B-8DAE-1953F412C126}" type="datetimeFigureOut">
               <a:rPr lang="en-US" smtClean="0"/>
-              <a:t>1/26/26</a:t>
+              <a:t>2/1/26</a:t>
             </a:fld>
             <a:endParaRPr lang="en-US" dirty="0"/>
           </a:p>
@@ -2754,7 +2754,7 @@
           <a:p>
             <a:fld id="{48A87A34-81AB-432B-8DAE-1953F412C126}" type="datetimeFigureOut">
               <a:rPr lang="en-US" smtClean="0"/>
-              <a:t>1/26/26</a:t>
+              <a:t>2/1/26</a:t>
             </a:fld>
             <a:endParaRPr lang="en-US" dirty="0"/>
           </a:p>
@@ -2849,7 +2849,7 @@
           <a:p>
             <a:fld id="{48A87A34-81AB-432B-8DAE-1953F412C126}" type="datetimeFigureOut">
               <a:rPr lang="en-US" smtClean="0"/>
-              <a:t>1/26/26</a:t>
+              <a:t>2/1/26</a:t>
             </a:fld>
             <a:endParaRPr lang="en-US" dirty="0"/>
           </a:p>
@@ -3126,7 +3126,7 @@
           <a:p>
             <a:fld id="{48A87A34-81AB-432B-8DAE-1953F412C126}" type="datetimeFigureOut">
               <a:rPr lang="en-US" smtClean="0"/>
-              <a:t>1/26/26</a:t>
+              <a:t>2/1/26</a:t>
             </a:fld>
             <a:endParaRPr lang="en-US" dirty="0"/>
           </a:p>
@@ -3383,7 +3383,7 @@
           <a:p>
             <a:fld id="{48A87A34-81AB-432B-8DAE-1953F412C126}" type="datetimeFigureOut">
               <a:rPr lang="en-US" smtClean="0"/>
-              <a:t>1/26/26</a:t>
+              <a:t>2/1/26</a:t>
             </a:fld>
             <a:endParaRPr lang="en-US" dirty="0"/>
           </a:p>
@@ -3597,7 +3597,7 @@
             <a:fld id="{48A87A34-81AB-432B-8DAE-1953F412C126}" type="datetimeFigureOut">
               <a:rPr lang="en-US" smtClean="0"/>
               <a:pPr/>
-              <a:t>1/26/26</a:t>
+              <a:t>2/1/26</a:t>
             </a:fld>
             <a:endParaRPr lang="en-US" dirty="0"/>
           </a:p>
@@ -4368,6 +4368,37 @@
           <a:chExt cx="0" cy="0"/>
         </a:xfrm>
       </p:grpSpPr>
+      <p:pic>
+        <p:nvPicPr>
+          <p:cNvPr id="2" name="Picture 1">
+            <a:extLst>
+              <a:ext uri="{FF2B5EF4-FFF2-40B4-BE49-F238E27FC236}">
+                <a16:creationId xmlns:a16="http://schemas.microsoft.com/office/drawing/2014/main" id="{53C0D857-DB16-49AF-A520-2AA253E039A5}"/>
+              </a:ext>
+            </a:extLst>
+          </p:cNvPr>
+          <p:cNvPicPr>
+            <a:picLocks noChangeAspect="1"/>
+          </p:cNvPicPr>
+          <p:nvPr/>
+        </p:nvPicPr>
+        <p:blipFill rotWithShape="1">
+          <a:blip r:embed="rId3"/>
+          <a:srcRect l="18030" t="22086" r="11351" b="12407"/>
+          <a:stretch>
+            <a:fillRect/>
+          </a:stretch>
+        </p:blipFill>
+        <p:spPr>
+          <a:xfrm>
+            <a:off x="223306" y="5801029"/>
+            <a:ext cx="9838800" cy="7426390"/>
+          </a:xfrm>
+          <a:prstGeom prst="rect">
+            <a:avLst/>
+          </a:prstGeom>
+        </p:spPr>
+      </p:pic>
       <p:sp>
         <p:nvSpPr>
           <p:cNvPr id="4" name="TextBox 3">
@@ -4382,13 +4413,17 @@
         </p:nvSpPr>
         <p:spPr>
           <a:xfrm>
-            <a:off x="225526" y="4800391"/>
+            <a:off x="225526" y="4634141"/>
             <a:ext cx="9838800" cy="1121395"/>
           </a:xfrm>
           <a:prstGeom prst="rect">
             <a:avLst/>
           </a:prstGeom>
-          <a:ln/>
+          <a:ln w="12700">
+            <a:solidFill>
+              <a:schemeClr val="tx1"/>
+            </a:solidFill>
+          </a:ln>
         </p:spPr>
         <p:style>
           <a:lnRef idx="1">
@@ -4405,7 +4440,7 @@
           </a:fontRef>
         </p:style>
         <p:txBody>
-          <a:bodyPr wrap="none" rtlCol="0">
+          <a:bodyPr wrap="none" rtlCol="0" anchor="ctr" anchorCtr="0">
             <a:noAutofit/>
             <a:scene3d>
               <a:camera prst="orthographicFront"/>
@@ -4422,24 +4457,7 @@
           </a:bodyPr>
           <a:lstStyle/>
           <a:p>
-            <a:pPr marL="0" algn="ctr" defTabSz="457200" rtl="0" eaLnBrk="1" latinLnBrk="0" hangingPunct="1"/>
-            <a:r>
-              <a:rPr lang="en-US" sz="5400" b="1" dirty="0" err="1">
-                <a:ln w="0"/>
-                <a:solidFill>
-                  <a:schemeClr val="tx1"/>
-                </a:solidFill>
-                <a:effectLst>
-                  <a:outerShdw blurRad="38100" dist="19050" dir="2700000" algn="tl" rotWithShape="0">
-                    <a:schemeClr val="dk1">
-                      <a:alpha val="40000"/>
-                    </a:schemeClr>
-                  </a:outerShdw>
-                </a:effectLst>
-                <a:latin typeface="+mj-lt"/>
-              </a:rPr>
-              <a:t>defaultdict</a:t>
-            </a:r>
+            <a:pPr algn="ctr"/>
             <a:r>
               <a:rPr lang="en-US" sz="5400" b="1" dirty="0">
                 <a:ln w="0"/>
@@ -4455,10 +4473,38 @@
                 </a:effectLst>
                 <a:latin typeface="+mj-lt"/>
               </a:rPr>
-              <a:t> vs standard </a:t>
-            </a:r>
-            <a:r>
-              <a:rPr lang="en-US" sz="5400" b="1" dirty="0" err="1">
+              <a:t>Walrus Operator </a:t>
+            </a:r>
+            <a:r>
+              <a:rPr lang="en-US" sz="5400" b="1" dirty="0">
+                <a:ln w="12700">
+                  <a:solidFill>
+                    <a:schemeClr val="accent1"/>
+                  </a:solidFill>
+                  <a:prstDash val="solid"/>
+                </a:ln>
+                <a:pattFill prst="pct50">
+                  <a:fgClr>
+                    <a:schemeClr val="accent1"/>
+                  </a:fgClr>
+                  <a:bgClr>
+                    <a:schemeClr val="accent1">
+                      <a:lumMod val="20000"/>
+                      <a:lumOff val="80000"/>
+                    </a:schemeClr>
+                  </a:bgClr>
+                </a:pattFill>
+                <a:effectLst>
+                  <a:outerShdw dist="38100" dir="2640000" algn="bl" rotWithShape="0">
+                    <a:schemeClr val="accent1"/>
+                  </a:outerShdw>
+                </a:effectLst>
+                <a:latin typeface="+mj-lt"/>
+              </a:rPr>
+              <a:t>vs</a:t>
+            </a:r>
+            <a:r>
+              <a:rPr lang="en-US" sz="5400" b="1" dirty="0">
                 <a:ln w="0"/>
                 <a:solidFill>
                   <a:schemeClr val="tx1"/>
@@ -4472,7 +4518,7 @@
                 </a:effectLst>
                 <a:latin typeface="+mj-lt"/>
               </a:rPr>
-              <a:t>Dict</a:t>
+              <a:t> While</a:t>
             </a:r>
             <a:endParaRPr lang="en-GB" sz="1400" b="1" dirty="0">
               <a:ln w="0"/>
@@ -4506,14 +4552,14 @@
           <p:nvPr/>
         </p:nvPicPr>
         <p:blipFill>
-          <a:blip r:embed="rId3"/>
+          <a:blip r:embed="rId4"/>
           <a:stretch>
             <a:fillRect/>
           </a:stretch>
         </p:blipFill>
         <p:spPr>
           <a:xfrm>
-            <a:off x="264001" y="4834297"/>
+            <a:off x="264001" y="4668047"/>
             <a:ext cx="1063167" cy="1063167"/>
           </a:xfrm>
           <a:prstGeom prst="rect">
@@ -4523,10 +4569,10 @@
       </p:pic>
       <p:sp>
         <p:nvSpPr>
-          <p:cNvPr id="7" name="TextBox 6">
+          <p:cNvPr id="11" name="TextBox 10">
             <a:extLst>
               <a:ext uri="{FF2B5EF4-FFF2-40B4-BE49-F238E27FC236}">
-                <a16:creationId xmlns:a16="http://schemas.microsoft.com/office/drawing/2014/main" id="{82A83D46-1034-6666-755A-5BB815E6D643}"/>
+                <a16:creationId xmlns:a16="http://schemas.microsoft.com/office/drawing/2014/main" id="{AE8CD719-0BE7-56F8-0136-ADB67AE57FA3}"/>
               </a:ext>
             </a:extLst>
           </p:cNvPr>
@@ -4535,48 +4581,8 @@
         </p:nvSpPr>
         <p:spPr>
           <a:xfrm>
-            <a:off x="3239076" y="14657755"/>
-            <a:ext cx="3807261" cy="830997"/>
-          </a:xfrm>
-          <a:prstGeom prst="rect">
-            <a:avLst/>
-          </a:prstGeom>
-          <a:noFill/>
-        </p:spPr>
-        <p:txBody>
-          <a:bodyPr wrap="none" rtlCol="0">
-            <a:spAutoFit/>
-          </a:bodyPr>
-          <a:lstStyle/>
-          <a:p>
-            <a:r>
-              <a:rPr lang="en-GB" sz="4800" b="1" dirty="0"/>
-              <a:t>Elegant Logic:</a:t>
-            </a:r>
-            <a:r>
-              <a:rPr lang="en-GB" sz="4800" dirty="0"/>
-              <a:t> </a:t>
-            </a:r>
-            <a:endParaRPr lang="en-DE" sz="4800" dirty="0"/>
-          </a:p>
-        </p:txBody>
-      </p:sp>
-      <p:sp>
-        <p:nvSpPr>
-          <p:cNvPr id="11" name="TextBox 10">
-            <a:extLst>
-              <a:ext uri="{FF2B5EF4-FFF2-40B4-BE49-F238E27FC236}">
-                <a16:creationId xmlns:a16="http://schemas.microsoft.com/office/drawing/2014/main" id="{AE8CD719-0BE7-56F8-0136-ADB67AE57FA3}"/>
-              </a:ext>
-            </a:extLst>
-          </p:cNvPr>
-          <p:cNvSpPr txBox="1"/>
-          <p:nvPr/>
-        </p:nvSpPr>
-        <p:spPr>
-          <a:xfrm>
-            <a:off x="245874" y="15534245"/>
-            <a:ext cx="9793665" cy="1938992"/>
+            <a:off x="245874" y="13439438"/>
+            <a:ext cx="9793665" cy="1015663"/>
           </a:xfrm>
           <a:prstGeom prst="rect">
             <a:avLst/>
@@ -4594,7 +4600,7 @@
               <a:rPr lang="en-GB" sz="6000" dirty="0">
                 <a:latin typeface="Patrick Hand" pitchFamily="2" charset="77"/>
               </a:rPr>
-              <a:t>Automatically handle missing keys without manual checks</a:t>
+              <a:t>The Secret := Operator in Python</a:t>
             </a:r>
             <a:endParaRPr lang="en-DE" sz="6000" dirty="0">
               <a:latin typeface="Patrick Hand" pitchFamily="2" charset="77"/>
@@ -4618,7 +4624,7 @@
         </p:nvCxnSpPr>
         <p:spPr>
           <a:xfrm>
-            <a:off x="223579" y="10122614"/>
+            <a:off x="223579" y="9241468"/>
             <a:ext cx="9838255" cy="0"/>
           </a:xfrm>
           <a:prstGeom prst="line">
@@ -4647,78 +4653,6 @@
           </a:fontRef>
         </p:style>
       </p:cxnSp>
-      <p:pic>
-        <p:nvPicPr>
-          <p:cNvPr id="18" name="Graphic 17" descr="Shield Tick with solid fill">
-            <a:extLst>
-              <a:ext uri="{FF2B5EF4-FFF2-40B4-BE49-F238E27FC236}">
-                <a16:creationId xmlns:a16="http://schemas.microsoft.com/office/drawing/2014/main" id="{EB4807D0-9F0F-5D16-75CA-7253269DE562}"/>
-              </a:ext>
-            </a:extLst>
-          </p:cNvPr>
-          <p:cNvPicPr>
-            <a:picLocks noChangeAspect="1"/>
-          </p:cNvPicPr>
-          <p:nvPr/>
-        </p:nvPicPr>
-        <p:blipFill>
-          <a:blip r:embed="rId4">
-            <a:extLst>
-              <a:ext uri="{96DAC541-7B7A-43D3-8B79-37D633B846F1}">
-                <asvg:svgBlip xmlns:asvg="http://schemas.microsoft.com/office/drawing/2016/SVG/main" r:embed="rId5"/>
-              </a:ext>
-            </a:extLst>
-          </a:blip>
-          <a:stretch>
-            <a:fillRect/>
-          </a:stretch>
-        </p:blipFill>
-        <p:spPr>
-          <a:xfrm>
-            <a:off x="6801805" y="11312088"/>
-            <a:ext cx="914400" cy="914400"/>
-          </a:xfrm>
-          <a:prstGeom prst="rect">
-            <a:avLst/>
-          </a:prstGeom>
-        </p:spPr>
-      </p:pic>
-      <p:pic>
-        <p:nvPicPr>
-          <p:cNvPr id="19" name="Graphic 18" descr="Close with solid fill">
-            <a:extLst>
-              <a:ext uri="{FF2B5EF4-FFF2-40B4-BE49-F238E27FC236}">
-                <a16:creationId xmlns:a16="http://schemas.microsoft.com/office/drawing/2014/main" id="{46AA1765-F8D0-1254-85C9-AEF33D4A37DD}"/>
-              </a:ext>
-            </a:extLst>
-          </p:cNvPr>
-          <p:cNvPicPr>
-            <a:picLocks noChangeAspect="1"/>
-          </p:cNvPicPr>
-          <p:nvPr/>
-        </p:nvPicPr>
-        <p:blipFill>
-          <a:blip r:embed="rId6">
-            <a:extLst>
-              <a:ext uri="{96DAC541-7B7A-43D3-8B79-37D633B846F1}">
-                <asvg:svgBlip xmlns:asvg="http://schemas.microsoft.com/office/drawing/2016/SVG/main" r:embed="rId7"/>
-              </a:ext>
-            </a:extLst>
-          </a:blip>
-          <a:stretch>
-            <a:fillRect/>
-          </a:stretch>
-        </p:blipFill>
-        <p:spPr>
-          <a:xfrm>
-            <a:off x="6801805" y="6972845"/>
-            <a:ext cx="914400" cy="914400"/>
-          </a:xfrm>
-          <a:prstGeom prst="rect">
-            <a:avLst/>
-          </a:prstGeom>
-        </p:spPr>
-      </p:pic>
     </p:spTree>
     <p:extLst>
       <p:ext uri="{BB962C8B-B14F-4D97-AF65-F5344CB8AC3E}">
@@ -5846,6 +5780,37 @@
           <a:chExt cx="0" cy="0"/>
         </a:xfrm>
       </p:grpSpPr>
+      <p:pic>
+        <p:nvPicPr>
+          <p:cNvPr id="41" name="Picture 40">
+            <a:extLst>
+              <a:ext uri="{FF2B5EF4-FFF2-40B4-BE49-F238E27FC236}">
+                <a16:creationId xmlns:a16="http://schemas.microsoft.com/office/drawing/2014/main" id="{9FAAFB94-6F8B-B795-F4CF-8BD094558F2F}"/>
+              </a:ext>
+            </a:extLst>
+          </p:cNvPr>
+          <p:cNvPicPr>
+            <a:picLocks noChangeAspect="1"/>
+          </p:cNvPicPr>
+          <p:nvPr/>
+        </p:nvPicPr>
+        <p:blipFill rotWithShape="1">
+          <a:blip r:embed="rId3"/>
+          <a:srcRect l="17775" t="17533" r="12089" b="11256"/>
+          <a:stretch>
+            <a:fillRect/>
+          </a:stretch>
+        </p:blipFill>
+        <p:spPr>
+          <a:xfrm>
+            <a:off x="223579" y="5898182"/>
+            <a:ext cx="9838255" cy="10224757"/>
+          </a:xfrm>
+          <a:prstGeom prst="rect">
+            <a:avLst/>
+          </a:prstGeom>
+        </p:spPr>
+      </p:pic>
       <p:sp>
         <p:nvSpPr>
           <p:cNvPr id="4" name="TextBox 3">
@@ -5860,7 +5825,7 @@
         </p:nvSpPr>
         <p:spPr>
           <a:xfrm>
-            <a:off x="223306" y="4691271"/>
+            <a:off x="223306" y="4592415"/>
             <a:ext cx="9838800" cy="1236996"/>
           </a:xfrm>
           <a:prstGeom prst="rect">
@@ -5887,14 +5852,14 @@
           </a:fontRef>
         </p:style>
         <p:txBody>
-          <a:bodyPr wrap="square" rtlCol="0">
+          <a:bodyPr wrap="square" rtlCol="0" anchor="ctr" anchorCtr="0">
             <a:noAutofit/>
           </a:bodyPr>
           <a:lstStyle/>
           <a:p>
-            <a:pPr algn="ctr"/>
-            <a:r>
-              <a:rPr lang="en-GB" sz="6600" dirty="0">
+            <a:pPr algn="r"/>
+            <a:r>
+              <a:rPr lang="en-GB" sz="4400" dirty="0">
                 <a:ln w="0"/>
                 <a:solidFill>
                   <a:schemeClr val="tx1"/>
@@ -5906,11 +5871,10 @@
                     </a:schemeClr>
                   </a:outerShdw>
                 </a:effectLst>
-                <a:latin typeface="Patrick Hand" pitchFamily="2" charset="77"/>
               </a:rPr>
-              <a:t>Simplify Nested Access</a:t>
-            </a:r>
-            <a:endParaRPr lang="en-GB" dirty="0">
+              <a:t>Write Reusable Code with Generics</a:t>
+            </a:r>
+            <a:endParaRPr lang="en-GB" sz="4400" dirty="0">
               <a:ln w="0"/>
               <a:solidFill>
                 <a:schemeClr val="tx1"/>
@@ -5929,10 +5893,10 @@
       </p:sp>
       <p:sp>
         <p:nvSpPr>
-          <p:cNvPr id="8" name="TextBox 7">
+          <p:cNvPr id="13" name="TextBox 12">
             <a:extLst>
               <a:ext uri="{FF2B5EF4-FFF2-40B4-BE49-F238E27FC236}">
-                <a16:creationId xmlns:a16="http://schemas.microsoft.com/office/drawing/2014/main" id="{02929DF9-28B4-596B-3779-93529974DF88}"/>
+                <a16:creationId xmlns:a16="http://schemas.microsoft.com/office/drawing/2014/main" id="{2FE2217F-C2F1-2F4F-83A7-73EBD6CE883E}"/>
               </a:ext>
             </a:extLst>
           </p:cNvPr>
@@ -5941,8 +5905,8 @@
         </p:nvSpPr>
         <p:spPr>
           <a:xfrm>
-            <a:off x="2372910" y="12785470"/>
-            <a:ext cx="5539593" cy="1015663"/>
+            <a:off x="296796" y="16172366"/>
+            <a:ext cx="9691820" cy="923330"/>
           </a:xfrm>
           <a:prstGeom prst="rect">
             <a:avLst/>
@@ -5956,50 +5920,9 @@
           <a:lstStyle/>
           <a:p>
             <a:r>
-              <a:rPr lang="en-GB" sz="6000" b="1" dirty="0"/>
-              <a:t>Safe Navigation: </a:t>
-            </a:r>
-            <a:endParaRPr lang="en-DE" sz="6000" b="1" dirty="0"/>
-          </a:p>
-        </p:txBody>
-      </p:sp>
-      <p:sp>
-        <p:nvSpPr>
-          <p:cNvPr id="13" name="TextBox 12">
-            <a:extLst>
-              <a:ext uri="{FF2B5EF4-FFF2-40B4-BE49-F238E27FC236}">
-                <a16:creationId xmlns:a16="http://schemas.microsoft.com/office/drawing/2014/main" id="{2FE2217F-C2F1-2F4F-83A7-73EBD6CE883E}"/>
-              </a:ext>
-            </a:extLst>
-          </p:cNvPr>
-          <p:cNvSpPr txBox="1"/>
-          <p:nvPr/>
-        </p:nvSpPr>
-        <p:spPr>
-          <a:xfrm>
-            <a:off x="324721" y="13790373"/>
-            <a:ext cx="9635971" cy="1015663"/>
-          </a:xfrm>
-          <a:prstGeom prst="rect">
-            <a:avLst/>
-          </a:prstGeom>
-          <a:noFill/>
-        </p:spPr>
-        <p:txBody>
-          <a:bodyPr wrap="none" rtlCol="0">
-            <a:spAutoFit/>
-          </a:bodyPr>
-          <a:lstStyle/>
-          <a:p>
-            <a:r>
-              <a:rPr lang="en-GB" sz="6000" dirty="0">
-                <a:latin typeface="Patrick Hand" pitchFamily="2" charset="77"/>
-              </a:rPr>
-              <a:t>Access nested values line-by-line </a:t>
-            </a:r>
-            <a:endParaRPr lang="en-DE" sz="6000" dirty="0">
-              <a:latin typeface="Patrick Hand" pitchFamily="2" charset="77"/>
-            </a:endParaRPr>
+              <a:rPr lang="en-GB" sz="5400" dirty="0"/>
+              <a:t>Write type-safe generic functions.</a:t>
+            </a:r>
           </a:p>
         </p:txBody>
       </p:sp>
@@ -6019,7 +5942,7 @@
         </p:nvCxnSpPr>
         <p:spPr>
           <a:xfrm>
-            <a:off x="223579" y="12132642"/>
+            <a:off x="223579" y="11366518"/>
             <a:ext cx="9838255" cy="0"/>
           </a:xfrm>
           <a:prstGeom prst="line">
@@ -6050,10 +5973,10 @@
       </p:cxnSp>
       <p:pic>
         <p:nvPicPr>
-          <p:cNvPr id="18" name="Graphic 17" descr="Shield Tick with solid fill">
+          <p:cNvPr id="3" name="Picture 2">
             <a:extLst>
               <a:ext uri="{FF2B5EF4-FFF2-40B4-BE49-F238E27FC236}">
-                <a16:creationId xmlns:a16="http://schemas.microsoft.com/office/drawing/2014/main" id="{7D45EB65-7112-0EB0-9B6E-C9CD15F47E6A}"/>
+                <a16:creationId xmlns:a16="http://schemas.microsoft.com/office/drawing/2014/main" id="{632B8096-E902-961A-15A8-93FEB8CB072D}"/>
               </a:ext>
             </a:extLst>
           </p:cNvPr>
@@ -6063,138 +5986,21 @@
           <p:nvPr/>
         </p:nvPicPr>
         <p:blipFill>
-          <a:blip r:embed="rId3">
-            <a:extLst>
-              <a:ext uri="{96DAC541-7B7A-43D3-8B79-37D633B846F1}">
-                <asvg:svgBlip xmlns:asvg="http://schemas.microsoft.com/office/drawing/2016/SVG/main" r:embed="rId4"/>
-              </a:ext>
-            </a:extLst>
-          </a:blip>
+          <a:blip r:embed="rId4"/>
           <a:stretch>
             <a:fillRect/>
           </a:stretch>
         </p:blipFill>
         <p:spPr>
           <a:xfrm>
-            <a:off x="4247354" y="9981872"/>
-            <a:ext cx="914400" cy="914400"/>
+            <a:off x="319838" y="4712613"/>
+            <a:ext cx="1062000" cy="1062000"/>
           </a:xfrm>
           <a:prstGeom prst="rect">
             <a:avLst/>
           </a:prstGeom>
         </p:spPr>
       </p:pic>
-      <p:pic>
-        <p:nvPicPr>
-          <p:cNvPr id="19" name="Graphic 18" descr="Close with solid fill">
-            <a:extLst>
-              <a:ext uri="{FF2B5EF4-FFF2-40B4-BE49-F238E27FC236}">
-                <a16:creationId xmlns:a16="http://schemas.microsoft.com/office/drawing/2014/main" id="{E309D260-B766-F1FF-6112-14AF040E356A}"/>
-              </a:ext>
-            </a:extLst>
-          </p:cNvPr>
-          <p:cNvPicPr>
-            <a:picLocks noChangeAspect="1"/>
-          </p:cNvPicPr>
-          <p:nvPr/>
-        </p:nvPicPr>
-        <p:blipFill>
-          <a:blip r:embed="rId5">
-            <a:extLst>
-              <a:ext uri="{96DAC541-7B7A-43D3-8B79-37D633B846F1}">
-                <asvg:svgBlip xmlns:asvg="http://schemas.microsoft.com/office/drawing/2016/SVG/main" r:embed="rId6"/>
-              </a:ext>
-            </a:extLst>
-          </a:blip>
-          <a:stretch>
-            <a:fillRect/>
-          </a:stretch>
-        </p:blipFill>
-        <p:spPr>
-          <a:xfrm>
-            <a:off x="5580859" y="10124358"/>
-            <a:ext cx="914400" cy="914400"/>
-          </a:xfrm>
-          <a:prstGeom prst="rect">
-            <a:avLst/>
-          </a:prstGeom>
-        </p:spPr>
-      </p:pic>
-      <p:pic>
-        <p:nvPicPr>
-          <p:cNvPr id="3" name="Picture 2">
-            <a:extLst>
-              <a:ext uri="{FF2B5EF4-FFF2-40B4-BE49-F238E27FC236}">
-                <a16:creationId xmlns:a16="http://schemas.microsoft.com/office/drawing/2014/main" id="{632B8096-E902-961A-15A8-93FEB8CB072D}"/>
-              </a:ext>
-            </a:extLst>
-          </p:cNvPr>
-          <p:cNvPicPr>
-            <a:picLocks noChangeAspect="1"/>
-          </p:cNvPicPr>
-          <p:nvPr/>
-        </p:nvPicPr>
-        <p:blipFill>
-          <a:blip r:embed="rId7"/>
-          <a:stretch>
-            <a:fillRect/>
-          </a:stretch>
-        </p:blipFill>
-        <p:spPr>
-          <a:xfrm>
-            <a:off x="295124" y="4786755"/>
-            <a:ext cx="1062000" cy="1062000"/>
-          </a:xfrm>
-          <a:prstGeom prst="rect">
-            <a:avLst/>
-          </a:prstGeom>
-        </p:spPr>
-      </p:pic>
-      <p:cxnSp>
-        <p:nvCxnSpPr>
-          <p:cNvPr id="20" name="Straight Connector 19">
-            <a:extLst>
-              <a:ext uri="{FF2B5EF4-FFF2-40B4-BE49-F238E27FC236}">
-                <a16:creationId xmlns:a16="http://schemas.microsoft.com/office/drawing/2014/main" id="{9C2BEBA6-3540-099F-950A-DFE7B0760A09}"/>
-              </a:ext>
-            </a:extLst>
-          </p:cNvPr>
-          <p:cNvCxnSpPr>
-            <a:cxnSpLocks/>
-          </p:cNvCxnSpPr>
-          <p:nvPr/>
-        </p:nvCxnSpPr>
-        <p:spPr>
-          <a:xfrm>
-            <a:off x="216954" y="9005127"/>
-            <a:ext cx="9838255" cy="0"/>
-          </a:xfrm>
-          <a:prstGeom prst="line">
-            <a:avLst/>
-          </a:prstGeom>
-          <a:ln w="38100">
-            <a:solidFill>
-              <a:schemeClr val="bg1"/>
-            </a:solidFill>
-            <a:headEnd type="none"/>
-            <a:tailEnd type="none" w="lg" len="lg"/>
-          </a:ln>
-        </p:spPr>
-        <p:style>
-          <a:lnRef idx="1">
-            <a:schemeClr val="accent1"/>
-          </a:lnRef>
-          <a:fillRef idx="0">
-            <a:schemeClr val="accent1"/>
-          </a:fillRef>
-          <a:effectRef idx="0">
-            <a:schemeClr val="accent1"/>
-          </a:effectRef>
-          <a:fontRef idx="minor">
-            <a:schemeClr val="tx1"/>
-          </a:fontRef>
-        </p:style>
-      </p:cxnSp>
     </p:spTree>
     <p:extLst>
       <p:ext uri="{BB962C8B-B14F-4D97-AF65-F5344CB8AC3E}">
@@ -12633,6 +12439,37 @@
           <a:chExt cx="0" cy="0"/>
         </a:xfrm>
       </p:grpSpPr>
+      <p:pic>
+        <p:nvPicPr>
+          <p:cNvPr id="2" name="Picture 1">
+            <a:extLst>
+              <a:ext uri="{FF2B5EF4-FFF2-40B4-BE49-F238E27FC236}">
+                <a16:creationId xmlns:a16="http://schemas.microsoft.com/office/drawing/2014/main" id="{E98B42B3-AEE7-CDD0-B3E6-67A542780F0A}"/>
+              </a:ext>
+            </a:extLst>
+          </p:cNvPr>
+          <p:cNvPicPr>
+            <a:picLocks noChangeAspect="1"/>
+          </p:cNvPicPr>
+          <p:nvPr/>
+        </p:nvPicPr>
+        <p:blipFill rotWithShape="1">
+          <a:blip r:embed="rId2"/>
+          <a:srcRect l="16164" t="15827" r="10466" b="11152"/>
+          <a:stretch>
+            <a:fillRect/>
+          </a:stretch>
+        </p:blipFill>
+        <p:spPr>
+          <a:xfrm>
+            <a:off x="223579" y="5772792"/>
+            <a:ext cx="9838255" cy="9365818"/>
+          </a:xfrm>
+          <a:prstGeom prst="rect">
+            <a:avLst/>
+          </a:prstGeom>
+        </p:spPr>
+      </p:pic>
       <p:sp>
         <p:nvSpPr>
           <p:cNvPr id="4" name="TextBox 3">
@@ -12647,8 +12484,8 @@
         </p:nvSpPr>
         <p:spPr>
           <a:xfrm>
-            <a:off x="223306" y="4780516"/>
-            <a:ext cx="9838800" cy="1107996"/>
+            <a:off x="223306" y="4547763"/>
+            <a:ext cx="9838800" cy="1162332"/>
           </a:xfrm>
           <a:prstGeom prst="rect">
             <a:avLst/>
@@ -12670,8 +12507,8 @@
           </a:fontRef>
         </p:style>
         <p:txBody>
-          <a:bodyPr wrap="square" rtlCol="0">
-            <a:spAutoFit/>
+          <a:bodyPr wrap="square" rtlCol="0" anchor="ctr" anchorCtr="0">
+            <a:noAutofit/>
             <a:scene3d>
               <a:camera prst="orthographicFront"/>
               <a:lightRig rig="harsh" dir="t"/>
@@ -12689,7 +12526,39 @@
           <a:p>
             <a:pPr algn="ctr"/>
             <a:r>
-              <a:rPr lang="en-GB" sz="6600" b="1" dirty="0">
+              <a:rPr lang="en-GB" sz="5400" dirty="0" err="1">
+                <a:ln w="0"/>
+                <a:solidFill>
+                  <a:schemeClr val="tx1"/>
+                </a:solidFill>
+                <a:effectLst>
+                  <a:outerShdw blurRad="38100" dist="19050" dir="2700000" algn="tl" rotWithShape="0">
+                    <a:schemeClr val="dk1">
+                      <a:alpha val="40000"/>
+                    </a:schemeClr>
+                  </a:outerShdw>
+                </a:effectLst>
+              </a:rPr>
+              <a:t>Object.freeze</a:t>
+            </a:r>
+            <a:r>
+              <a:rPr lang="en-GB" sz="5400" dirty="0">
+                <a:ln w="0"/>
+                <a:solidFill>
+                  <a:schemeClr val="tx1"/>
+                </a:solidFill>
+                <a:effectLst>
+                  <a:outerShdw blurRad="38100" dist="19050" dir="2700000" algn="tl" rotWithShape="0">
+                    <a:schemeClr val="dk1">
+                      <a:alpha val="40000"/>
+                    </a:schemeClr>
+                  </a:outerShdw>
+                </a:effectLst>
+              </a:rPr>
+              <a:t>()</a:t>
+            </a:r>
+            <a:r>
+              <a:rPr lang="en-GB" sz="5400" b="1" dirty="0">
                 <a:ln/>
                 <a:pattFill prst="dkUpDiag">
                   <a:fgClr>
@@ -12713,9 +12582,89 @@
                   </a:outerShdw>
                 </a:effectLst>
               </a:rPr>
-              <a:t>Zip function</a:t>
-            </a:r>
-            <a:endParaRPr lang="en-GB" b="1" dirty="0">
+              <a:t> </a:t>
+            </a:r>
+            <a:r>
+              <a:rPr lang="en-GB" sz="5400" b="1" dirty="0">
+                <a:ln w="9525">
+                  <a:solidFill>
+                    <a:schemeClr val="bg1"/>
+                  </a:solidFill>
+                  <a:prstDash val="solid"/>
+                </a:ln>
+                <a:solidFill>
+                  <a:schemeClr val="tx1"/>
+                </a:solidFill>
+                <a:effectLst>
+                  <a:outerShdw blurRad="12700" dist="38100" dir="2700000" algn="tl" rotWithShape="0">
+                    <a:schemeClr val="bg1">
+                      <a:lumMod val="50000"/>
+                    </a:schemeClr>
+                  </a:outerShdw>
+                </a:effectLst>
+              </a:rPr>
+              <a:t>vs</a:t>
+            </a:r>
+            <a:r>
+              <a:rPr lang="en-GB" sz="5400" b="1" dirty="0">
+                <a:ln/>
+                <a:pattFill prst="dkUpDiag">
+                  <a:fgClr>
+                    <a:schemeClr val="bg1">
+                      <a:lumMod val="50000"/>
+                    </a:schemeClr>
+                  </a:fgClr>
+                  <a:bgClr>
+                    <a:schemeClr val="tx1">
+                      <a:lumMod val="75000"/>
+                      <a:lumOff val="25000"/>
+                    </a:schemeClr>
+                  </a:bgClr>
+                </a:pattFill>
+                <a:effectLst>
+                  <a:outerShdw blurRad="38100" dist="19050" dir="2700000" algn="tl" rotWithShape="0">
+                    <a:schemeClr val="dk1">
+                      <a:lumMod val="50000"/>
+                      <a:alpha val="40000"/>
+                    </a:schemeClr>
+                  </a:outerShdw>
+                </a:effectLst>
+              </a:rPr>
+              <a:t> </a:t>
+            </a:r>
+            <a:r>
+              <a:rPr lang="en-GB" sz="5400" dirty="0">
+                <a:ln w="0"/>
+                <a:solidFill>
+                  <a:schemeClr val="tx1"/>
+                </a:solidFill>
+                <a:effectLst>
+                  <a:outerShdw blurRad="38100" dist="19050" dir="2700000" algn="tl" rotWithShape="0">
+                    <a:schemeClr val="dk1">
+                      <a:alpha val="40000"/>
+                    </a:schemeClr>
+                  </a:outerShdw>
+                </a:effectLst>
+              </a:rPr>
+              <a:t>as </a:t>
+            </a:r>
+            <a:r>
+              <a:rPr lang="en-GB" sz="5400" dirty="0" err="1">
+                <a:ln w="0"/>
+                <a:solidFill>
+                  <a:schemeClr val="tx1"/>
+                </a:solidFill>
+                <a:effectLst>
+                  <a:outerShdw blurRad="38100" dist="19050" dir="2700000" algn="tl" rotWithShape="0">
+                    <a:schemeClr val="dk1">
+                      <a:alpha val="40000"/>
+                    </a:schemeClr>
+                  </a:outerShdw>
+                </a:effectLst>
+              </a:rPr>
+              <a:t>const</a:t>
+            </a:r>
+            <a:endParaRPr lang="en-GB" sz="1400" b="1" dirty="0">
               <a:ln/>
               <a:pattFill prst="dkUpDiag">
                 <a:fgClr>
@@ -12743,42 +12692,12 @@
           </a:p>
         </p:txBody>
       </p:sp>
-      <p:pic>
-        <p:nvPicPr>
-          <p:cNvPr id="5" name="Picture 4">
-            <a:extLst>
-              <a:ext uri="{FF2B5EF4-FFF2-40B4-BE49-F238E27FC236}">
-                <a16:creationId xmlns:a16="http://schemas.microsoft.com/office/drawing/2014/main" id="{0F2CAF92-9DDC-DFC3-FF81-8A5C6F4225A0}"/>
-              </a:ext>
-            </a:extLst>
-          </p:cNvPr>
-          <p:cNvPicPr>
-            <a:picLocks noChangeAspect="1"/>
-          </p:cNvPicPr>
-          <p:nvPr/>
-        </p:nvPicPr>
-        <p:blipFill>
-          <a:blip r:embed="rId2"/>
-          <a:stretch>
-            <a:fillRect/>
-          </a:stretch>
-        </p:blipFill>
-        <p:spPr>
-          <a:xfrm>
-            <a:off x="264001" y="4814421"/>
-            <a:ext cx="1063167" cy="1063167"/>
-          </a:xfrm>
-          <a:prstGeom prst="rect">
-            <a:avLst/>
-          </a:prstGeom>
-        </p:spPr>
-      </p:pic>
       <p:sp>
         <p:nvSpPr>
-          <p:cNvPr id="7" name="TextBox 6">
+          <p:cNvPr id="13" name="TextBox 12">
             <a:extLst>
               <a:ext uri="{FF2B5EF4-FFF2-40B4-BE49-F238E27FC236}">
-                <a16:creationId xmlns:a16="http://schemas.microsoft.com/office/drawing/2014/main" id="{69BBD432-F653-9467-301C-A4F29799E896}"/>
+                <a16:creationId xmlns:a16="http://schemas.microsoft.com/office/drawing/2014/main" id="{2DC93386-7003-550B-8361-770B236BA91B}"/>
               </a:ext>
             </a:extLst>
           </p:cNvPr>
@@ -12787,48 +12706,8 @@
         </p:nvSpPr>
         <p:spPr>
           <a:xfrm>
-            <a:off x="111653" y="12884024"/>
-            <a:ext cx="2176301" cy="707886"/>
-          </a:xfrm>
-          <a:prstGeom prst="rect">
-            <a:avLst/>
-          </a:prstGeom>
-          <a:noFill/>
-        </p:spPr>
-        <p:txBody>
-          <a:bodyPr wrap="none" rtlCol="0">
-            <a:spAutoFit/>
-          </a:bodyPr>
-          <a:lstStyle/>
-          <a:p>
-            <a:r>
-              <a:rPr lang="en-GB" sz="4000" b="1" dirty="0"/>
-              <a:t>Efficient:</a:t>
-            </a:r>
-            <a:r>
-              <a:rPr lang="en-GB" sz="4000" dirty="0"/>
-              <a:t> </a:t>
-            </a:r>
-            <a:endParaRPr lang="en-DE" sz="4000" dirty="0"/>
-          </a:p>
-        </p:txBody>
-      </p:sp>
-      <p:sp>
-        <p:nvSpPr>
-          <p:cNvPr id="11" name="TextBox 10">
-            <a:extLst>
-              <a:ext uri="{FF2B5EF4-FFF2-40B4-BE49-F238E27FC236}">
-                <a16:creationId xmlns:a16="http://schemas.microsoft.com/office/drawing/2014/main" id="{0F29FF69-10AD-2D7D-57DB-432C9733AE0A}"/>
-              </a:ext>
-            </a:extLst>
-          </p:cNvPr>
-          <p:cNvSpPr txBox="1"/>
-          <p:nvPr/>
-        </p:nvSpPr>
-        <p:spPr>
-          <a:xfrm>
-            <a:off x="2258341" y="12884024"/>
-            <a:ext cx="7680579" cy="707886"/>
+            <a:off x="223306" y="15170618"/>
+            <a:ext cx="9838800" cy="1569660"/>
           </a:xfrm>
           <a:prstGeom prst="rect">
             <a:avLst/>
@@ -12841,179 +12720,107 @@
           </a:bodyPr>
           <a:lstStyle/>
           <a:p>
-            <a:r>
-              <a:rPr lang="en-GB" sz="4000" dirty="0">
+            <a:pPr algn="ctr"/>
+            <a:r>
+              <a:rPr lang="en-GB" sz="4800" dirty="0" err="1">
+                <a:ln w="0"/>
+                <a:solidFill>
+                  <a:schemeClr val="accent1"/>
+                </a:solidFill>
+                <a:effectLst>
+                  <a:outerShdw blurRad="38100" dist="25400" dir="5400000" algn="ctr" rotWithShape="0">
+                    <a:srgbClr val="6E747A">
+                      <a:alpha val="43000"/>
+                    </a:srgbClr>
+                  </a:outerShdw>
+                </a:effectLst>
                 <a:latin typeface="Patrick Hand" pitchFamily="2" charset="77"/>
               </a:rPr>
-              <a:t>Loops through multiple </a:t>
-            </a:r>
-            <a:r>
-              <a:rPr lang="en-GB" sz="4000" dirty="0" err="1">
+              <a:t>Object.freeze</a:t>
+            </a:r>
+            <a:r>
+              <a:rPr lang="en-GB" sz="4800" dirty="0">
+                <a:ln w="0"/>
+                <a:solidFill>
+                  <a:schemeClr val="accent1"/>
+                </a:solidFill>
+                <a:effectLst>
+                  <a:outerShdw blurRad="38100" dist="25400" dir="5400000" algn="ctr" rotWithShape="0">
+                    <a:srgbClr val="6E747A">
+                      <a:alpha val="43000"/>
+                    </a:srgbClr>
+                  </a:outerShdw>
+                </a:effectLst>
                 <a:latin typeface="Patrick Hand" pitchFamily="2" charset="77"/>
               </a:rPr>
-              <a:t>iterables</a:t>
-            </a:r>
-            <a:r>
-              <a:rPr lang="en-GB" sz="4000" dirty="0">
+              <a:t>()</a:t>
+            </a:r>
+            <a:r>
+              <a:rPr lang="en-GB" sz="4800" b="1" dirty="0">
                 <a:latin typeface="Patrick Hand" pitchFamily="2" charset="77"/>
               </a:rPr>
-              <a:t> at once</a:t>
-            </a:r>
-            <a:endParaRPr lang="en-DE" sz="4000" dirty="0">
-              <a:latin typeface="Patrick Hand" pitchFamily="2" charset="77"/>
-            </a:endParaRPr>
-          </a:p>
-        </p:txBody>
-      </p:sp>
-      <p:sp>
-        <p:nvSpPr>
-          <p:cNvPr id="8" name="TextBox 7">
-            <a:extLst>
-              <a:ext uri="{FF2B5EF4-FFF2-40B4-BE49-F238E27FC236}">
-                <a16:creationId xmlns:a16="http://schemas.microsoft.com/office/drawing/2014/main" id="{0868B171-25AA-CACD-A094-E0B38D31F23D}"/>
-              </a:ext>
-            </a:extLst>
-          </p:cNvPr>
-          <p:cNvSpPr txBox="1"/>
-          <p:nvPr/>
-        </p:nvSpPr>
-        <p:spPr>
-          <a:xfrm>
-            <a:off x="111653" y="13967123"/>
-            <a:ext cx="2310120" cy="707886"/>
-          </a:xfrm>
-          <a:prstGeom prst="rect">
-            <a:avLst/>
-          </a:prstGeom>
-          <a:noFill/>
-        </p:spPr>
-        <p:txBody>
-          <a:bodyPr wrap="none" rtlCol="0">
-            <a:spAutoFit/>
-          </a:bodyPr>
-          <a:lstStyle/>
-          <a:p>
-            <a:r>
-              <a:rPr lang="en-GB" sz="4000" b="1" dirty="0"/>
-              <a:t>Pythonic: </a:t>
-            </a:r>
-            <a:endParaRPr lang="en-DE" sz="4000" b="1" dirty="0"/>
-          </a:p>
-        </p:txBody>
-      </p:sp>
-      <p:sp>
-        <p:nvSpPr>
-          <p:cNvPr id="12" name="TextBox 11">
-            <a:extLst>
-              <a:ext uri="{FF2B5EF4-FFF2-40B4-BE49-F238E27FC236}">
-                <a16:creationId xmlns:a16="http://schemas.microsoft.com/office/drawing/2014/main" id="{115BBC69-7564-146A-362D-6284651CA860}"/>
-              </a:ext>
-            </a:extLst>
-          </p:cNvPr>
-          <p:cNvSpPr txBox="1"/>
-          <p:nvPr/>
-        </p:nvSpPr>
-        <p:spPr>
-          <a:xfrm>
-            <a:off x="2258341" y="13957647"/>
-            <a:ext cx="7915419" cy="707886"/>
-          </a:xfrm>
-          <a:prstGeom prst="rect">
-            <a:avLst/>
-          </a:prstGeom>
-          <a:noFill/>
-        </p:spPr>
-        <p:txBody>
-          <a:bodyPr wrap="square" rtlCol="0">
-            <a:spAutoFit/>
-          </a:bodyPr>
-          <a:lstStyle/>
-          <a:p>
-            <a:r>
-              <a:rPr lang="en-GB" sz="4000" dirty="0">
+              <a:t> → Runtime protection</a:t>
+            </a:r>
+          </a:p>
+          <a:p>
+            <a:pPr algn="ctr"/>
+            <a:r>
+              <a:rPr lang="en-GB" sz="4800" dirty="0">
+                <a:ln w="0"/>
+                <a:solidFill>
+                  <a:schemeClr val="accent1"/>
+                </a:solidFill>
+                <a:effectLst>
+                  <a:outerShdw blurRad="38100" dist="25400" dir="5400000" algn="ctr" rotWithShape="0">
+                    <a:srgbClr val="6E747A">
+                      <a:alpha val="43000"/>
+                    </a:srgbClr>
+                  </a:outerShdw>
+                </a:effectLst>
                 <a:latin typeface="Patrick Hand" pitchFamily="2" charset="77"/>
               </a:rPr>
-              <a:t>Eliminates the need for manual indexing</a:t>
-            </a:r>
-            <a:endParaRPr lang="en-DE" sz="4000" dirty="0">
-              <a:latin typeface="Patrick Hand" pitchFamily="2" charset="77"/>
-            </a:endParaRPr>
-          </a:p>
-        </p:txBody>
-      </p:sp>
-      <p:sp>
-        <p:nvSpPr>
-          <p:cNvPr id="9" name="TextBox 8">
-            <a:extLst>
-              <a:ext uri="{FF2B5EF4-FFF2-40B4-BE49-F238E27FC236}">
-                <a16:creationId xmlns:a16="http://schemas.microsoft.com/office/drawing/2014/main" id="{19005E2A-72FF-9431-1DDA-030C01BAAB6B}"/>
-              </a:ext>
-            </a:extLst>
-          </p:cNvPr>
-          <p:cNvSpPr txBox="1"/>
-          <p:nvPr/>
-        </p:nvSpPr>
-        <p:spPr>
-          <a:xfrm>
-            <a:off x="111653" y="15050222"/>
-            <a:ext cx="1887055" cy="707886"/>
-          </a:xfrm>
-          <a:prstGeom prst="rect">
-            <a:avLst/>
-          </a:prstGeom>
-          <a:noFill/>
-        </p:spPr>
-        <p:txBody>
-          <a:bodyPr wrap="none" rtlCol="0">
-            <a:spAutoFit/>
-          </a:bodyPr>
-          <a:lstStyle/>
-          <a:p>
-            <a:r>
-              <a:rPr lang="en-GB" sz="4000" b="1" dirty="0"/>
-              <a:t>Simple: </a:t>
-            </a:r>
-            <a:endParaRPr lang="en-DE" sz="4000" b="1" dirty="0"/>
-          </a:p>
-        </p:txBody>
-      </p:sp>
-      <p:sp>
-        <p:nvSpPr>
-          <p:cNvPr id="13" name="TextBox 12">
-            <a:extLst>
-              <a:ext uri="{FF2B5EF4-FFF2-40B4-BE49-F238E27FC236}">
-                <a16:creationId xmlns:a16="http://schemas.microsoft.com/office/drawing/2014/main" id="{2DC93386-7003-550B-8361-770B236BA91B}"/>
-              </a:ext>
-            </a:extLst>
-          </p:cNvPr>
-          <p:cNvSpPr txBox="1"/>
-          <p:nvPr/>
-        </p:nvSpPr>
-        <p:spPr>
-          <a:xfrm>
-            <a:off x="2258341" y="15031271"/>
-            <a:ext cx="7543309" cy="707886"/>
-          </a:xfrm>
-          <a:prstGeom prst="rect">
-            <a:avLst/>
-          </a:prstGeom>
-          <a:noFill/>
-        </p:spPr>
-        <p:txBody>
-          <a:bodyPr wrap="square" rtlCol="0">
-            <a:spAutoFit/>
-          </a:bodyPr>
-          <a:lstStyle/>
-          <a:p>
-            <a:r>
-              <a:rPr lang="en-GB" sz="4000" dirty="0">
+              <a:t>as </a:t>
+            </a:r>
+            <a:r>
+              <a:rPr lang="en-GB" sz="4800" dirty="0" err="1">
+                <a:ln w="0"/>
+                <a:solidFill>
+                  <a:schemeClr val="accent1"/>
+                </a:solidFill>
+                <a:effectLst>
+                  <a:outerShdw blurRad="38100" dist="25400" dir="5400000" algn="ctr" rotWithShape="0">
+                    <a:srgbClr val="6E747A">
+                      <a:alpha val="43000"/>
+                    </a:srgbClr>
+                  </a:outerShdw>
+                </a:effectLst>
                 <a:latin typeface="Patrick Hand" pitchFamily="2" charset="77"/>
               </a:rPr>
-              <a:t>Makes your loops cleaner and shorter</a:t>
-            </a:r>
-            <a:endParaRPr lang="en-DE" sz="4000" dirty="0">
-              <a:latin typeface="Patrick Hand" pitchFamily="2" charset="77"/>
-            </a:endParaRPr>
+              <a:t>const</a:t>
+            </a:r>
+            <a:r>
+              <a:rPr lang="en-GB" sz="4800" dirty="0">
+                <a:ln w="0"/>
+                <a:solidFill>
+                  <a:schemeClr val="accent1"/>
+                </a:solidFill>
+                <a:effectLst>
+                  <a:outerShdw blurRad="38100" dist="25400" dir="5400000" algn="ctr" rotWithShape="0">
+                    <a:srgbClr val="6E747A">
+                      <a:alpha val="43000"/>
+                    </a:srgbClr>
+                  </a:outerShdw>
+                </a:effectLst>
+                <a:latin typeface="Patrick Hand" pitchFamily="2" charset="77"/>
+              </a:rPr>
+              <a:t> </a:t>
+            </a:r>
+            <a:r>
+              <a:rPr lang="en-GB" sz="4800" b="1" dirty="0">
+                <a:latin typeface="Patrick Hand" pitchFamily="2" charset="77"/>
+              </a:rPr>
+              <a:t>→ Compile-time type safety</a:t>
+            </a:r>
           </a:p>
         </p:txBody>
       </p:sp>
@@ -13033,7 +12840,7 @@
         </p:nvCxnSpPr>
         <p:spPr>
           <a:xfrm>
-            <a:off x="223579" y="10319305"/>
+            <a:off x="223579" y="11300203"/>
             <a:ext cx="9838255" cy="0"/>
           </a:xfrm>
           <a:prstGeom prst="line">
@@ -13064,10 +12871,10 @@
       </p:cxnSp>
       <p:pic>
         <p:nvPicPr>
-          <p:cNvPr id="18" name="Graphic 17" descr="Shield Tick with solid fill">
+          <p:cNvPr id="3" name="Picture 2">
             <a:extLst>
               <a:ext uri="{FF2B5EF4-FFF2-40B4-BE49-F238E27FC236}">
-                <a16:creationId xmlns:a16="http://schemas.microsoft.com/office/drawing/2014/main" id="{D3791C2A-331F-9DF3-9F0C-661BDA710972}"/>
+                <a16:creationId xmlns:a16="http://schemas.microsoft.com/office/drawing/2014/main" id="{5B841D4F-CF30-69DD-7E03-B10CAE07F447}"/>
               </a:ext>
             </a:extLst>
           </p:cNvPr>
@@ -13077,63 +12884,74 @@
           <p:nvPr/>
         </p:nvPicPr>
         <p:blipFill>
-          <a:blip r:embed="rId3">
-            <a:extLst>
-              <a:ext uri="{96DAC541-7B7A-43D3-8B79-37D633B846F1}">
-                <asvg:svgBlip xmlns:asvg="http://schemas.microsoft.com/office/drawing/2016/SVG/main" r:embed="rId4"/>
-              </a:ext>
-            </a:extLst>
-          </a:blip>
+          <a:blip r:embed="rId3"/>
           <a:stretch>
             <a:fillRect/>
           </a:stretch>
         </p:blipFill>
         <p:spPr>
           <a:xfrm>
-            <a:off x="7700733" y="11395343"/>
-            <a:ext cx="914400" cy="914400"/>
+            <a:off x="289806" y="4597929"/>
+            <a:ext cx="1062000" cy="1062000"/>
           </a:xfrm>
           <a:prstGeom prst="rect">
             <a:avLst/>
           </a:prstGeom>
         </p:spPr>
       </p:pic>
-      <p:pic>
-        <p:nvPicPr>
-          <p:cNvPr id="19" name="Graphic 18" descr="Close with solid fill">
+      <p:sp>
+        <p:nvSpPr>
+          <p:cNvPr id="5" name="TextBox 4">
             <a:extLst>
               <a:ext uri="{FF2B5EF4-FFF2-40B4-BE49-F238E27FC236}">
-                <a16:creationId xmlns:a16="http://schemas.microsoft.com/office/drawing/2014/main" id="{0F6E4447-33BF-BCE5-BC44-10826ACC2BA9}"/>
+                <a16:creationId xmlns:a16="http://schemas.microsoft.com/office/drawing/2014/main" id="{491C621B-78F8-D424-1DC8-2760E06DA7A2}"/>
               </a:ext>
             </a:extLst>
           </p:cNvPr>
-          <p:cNvPicPr>
-            <a:picLocks noChangeAspect="1"/>
-          </p:cNvPicPr>
+          <p:cNvSpPr txBox="1"/>
           <p:nvPr/>
-        </p:nvPicPr>
-        <p:blipFill>
-          <a:blip r:embed="rId5">
-            <a:extLst>
-              <a:ext uri="{96DAC541-7B7A-43D3-8B79-37D633B846F1}">
-                <asvg:svgBlip xmlns:asvg="http://schemas.microsoft.com/office/drawing/2016/SVG/main" r:embed="rId6"/>
-              </a:ext>
-            </a:extLst>
-          </a:blip>
-          <a:stretch>
-            <a:fillRect/>
-          </a:stretch>
-        </p:blipFill>
-        <p:spPr>
-          <a:xfrm>
-            <a:off x="7700733" y="9040444"/>
-            <a:ext cx="914400" cy="914400"/>
+        </p:nvSpPr>
+        <p:spPr>
+          <a:xfrm>
+            <a:off x="-8476735" y="3880022"/>
+            <a:ext cx="7103227" cy="707886"/>
           </a:xfrm>
           <a:prstGeom prst="rect">
             <a:avLst/>
           </a:prstGeom>
         </p:spPr>
-      </p:pic>
+        <p:style>
+          <a:lnRef idx="1">
+            <a:schemeClr val="accent6"/>
+          </a:lnRef>
+          <a:fillRef idx="2">
+            <a:schemeClr val="accent6"/>
+          </a:fillRef>
+          <a:effectRef idx="1">
+            <a:schemeClr val="accent6"/>
+          </a:effectRef>
+          <a:fontRef idx="minor">
+            <a:schemeClr val="dk1"/>
+          </a:fontRef>
+        </p:style>
+        <p:txBody>
+          <a:bodyPr wrap="none" rtlCol="0">
+            <a:spAutoFit/>
+          </a:bodyPr>
+          <a:lstStyle/>
+          <a:p>
+            <a:r>
+              <a:rPr lang="en-GB" sz="4000" dirty="0">
+                <a:latin typeface="Patrick Hand" pitchFamily="2" charset="77"/>
+              </a:rPr>
+              <a:t>ts_001_object_freeze_vs_as_const</a:t>
+            </a:r>
+            <a:endParaRPr lang="en-DE" sz="4000" dirty="0">
+              <a:latin typeface="Patrick Hand" pitchFamily="2" charset="77"/>
+            </a:endParaRPr>
+          </a:p>
+        </p:txBody>
+      </p:sp>
     </p:spTree>
     <p:extLst>
       <p:ext uri="{BB962C8B-B14F-4D97-AF65-F5344CB8AC3E}">

</xml_diff>

<commit_message>
feat: added new contents
</commit_message>
<xml_diff>
--- a/assets/images.pptx
+++ b/assets/images.pptx
@@ -7,6 +7,9 @@
   <p:notesMasterIdLst>
     <p:notesMasterId r:id="rId27"/>
   </p:notesMasterIdLst>
+  <p:handoutMasterIdLst>
+    <p:handoutMasterId r:id="rId28"/>
+  </p:handoutMasterIdLst>
   <p:sldIdLst>
     <p:sldId id="278" r:id="rId2"/>
     <p:sldId id="279" r:id="rId3"/>
@@ -145,6 +148,9 @@
           </p15:clr>
         </p15:guide>
       </p15:sldGuideLst>
+    </p:ext>
+    <p:ext uri="{2D200454-40CA-4A62-9FC3-DE9A4176ACB9}">
+      <p15:notesGuideLst xmlns:p15="http://schemas.microsoft.com/office/powerpoint/2012/main"/>
     </p:ext>
   </p:extLst>
 </p:presentation>
@@ -469,6 +475,195 @@
 </p188:cmLst>
 </file>
 
+<file path=ppt/handoutMasters/handoutMaster1.xml><?xml version="1.0" encoding="utf-8"?>
+<p:handoutMaster xmlns:a="http://schemas.openxmlformats.org/drawingml/2006/main" xmlns:r="http://schemas.openxmlformats.org/officeDocument/2006/relationships" xmlns:p="http://schemas.openxmlformats.org/presentationml/2006/main">
+  <p:cSld>
+    <p:bg>
+      <p:bgRef idx="1001">
+        <a:schemeClr val="bg1"/>
+      </p:bgRef>
+    </p:bg>
+    <p:spTree>
+      <p:nvGrpSpPr>
+        <p:cNvPr id="1" name=""/>
+        <p:cNvGrpSpPr/>
+        <p:nvPr/>
+      </p:nvGrpSpPr>
+      <p:grpSpPr>
+        <a:xfrm>
+          <a:off x="0" y="0"/>
+          <a:ext cx="0" cy="0"/>
+          <a:chOff x="0" y="0"/>
+          <a:chExt cx="0" cy="0"/>
+        </a:xfrm>
+      </p:grpSpPr>
+      <p:sp>
+        <p:nvSpPr>
+          <p:cNvPr id="2" name="Header Placeholder 1">
+            <a:extLst>
+              <a:ext uri="{FF2B5EF4-FFF2-40B4-BE49-F238E27FC236}">
+                <a16:creationId xmlns:a16="http://schemas.microsoft.com/office/drawing/2014/main" id="{64FBA138-3D39-3B30-0B84-FAA5665F8EA0}"/>
+              </a:ext>
+            </a:extLst>
+          </p:cNvPr>
+          <p:cNvSpPr>
+            <a:spLocks noGrp="1"/>
+          </p:cNvSpPr>
+          <p:nvPr>
+            <p:ph type="hdr" sz="quarter"/>
+          </p:nvPr>
+        </p:nvSpPr>
+        <p:spPr>
+          <a:xfrm>
+            <a:off x="0" y="0"/>
+            <a:ext cx="2971800" cy="458788"/>
+          </a:xfrm>
+          <a:prstGeom prst="rect">
+            <a:avLst/>
+          </a:prstGeom>
+        </p:spPr>
+        <p:txBody>
+          <a:bodyPr vert="horz" lIns="91440" tIns="45720" rIns="91440" bIns="45720" rtlCol="0"/>
+          <a:lstStyle>
+            <a:lvl1pPr algn="l">
+              <a:defRPr sz="1200"/>
+            </a:lvl1pPr>
+          </a:lstStyle>
+          <a:p>
+            <a:endParaRPr lang="en-DE"/>
+          </a:p>
+        </p:txBody>
+      </p:sp>
+      <p:sp>
+        <p:nvSpPr>
+          <p:cNvPr id="3" name="Date Placeholder 2">
+            <a:extLst>
+              <a:ext uri="{FF2B5EF4-FFF2-40B4-BE49-F238E27FC236}">
+                <a16:creationId xmlns:a16="http://schemas.microsoft.com/office/drawing/2014/main" id="{6F92B506-9A65-D569-B170-CDF1433B9C05}"/>
+              </a:ext>
+            </a:extLst>
+          </p:cNvPr>
+          <p:cNvSpPr>
+            <a:spLocks noGrp="1"/>
+          </p:cNvSpPr>
+          <p:nvPr>
+            <p:ph type="dt" sz="quarter" idx="1"/>
+          </p:nvPr>
+        </p:nvSpPr>
+        <p:spPr>
+          <a:xfrm>
+            <a:off x="3884613" y="0"/>
+            <a:ext cx="2971800" cy="458788"/>
+          </a:xfrm>
+          <a:prstGeom prst="rect">
+            <a:avLst/>
+          </a:prstGeom>
+        </p:spPr>
+        <p:txBody>
+          <a:bodyPr vert="horz" lIns="91440" tIns="45720" rIns="91440" bIns="45720" rtlCol="0"/>
+          <a:lstStyle>
+            <a:lvl1pPr algn="r">
+              <a:defRPr sz="1200"/>
+            </a:lvl1pPr>
+          </a:lstStyle>
+          <a:p>
+            <a:fld id="{0559BA52-1DBC-1C4E-9ABF-5B2EAE6EADF0}" type="datetimeFigureOut">
+              <a:rPr lang="en-DE" smtClean="0"/>
+              <a:t>08.02.26</a:t>
+            </a:fld>
+            <a:endParaRPr lang="en-DE"/>
+          </a:p>
+        </p:txBody>
+      </p:sp>
+      <p:sp>
+        <p:nvSpPr>
+          <p:cNvPr id="4" name="Footer Placeholder 3">
+            <a:extLst>
+              <a:ext uri="{FF2B5EF4-FFF2-40B4-BE49-F238E27FC236}">
+                <a16:creationId xmlns:a16="http://schemas.microsoft.com/office/drawing/2014/main" id="{5EA30CE9-E183-7FD9-8EC8-49815C303517}"/>
+              </a:ext>
+            </a:extLst>
+          </p:cNvPr>
+          <p:cNvSpPr>
+            <a:spLocks noGrp="1"/>
+          </p:cNvSpPr>
+          <p:nvPr>
+            <p:ph type="ftr" sz="quarter" idx="2"/>
+          </p:nvPr>
+        </p:nvSpPr>
+        <p:spPr>
+          <a:xfrm>
+            <a:off x="0" y="8685213"/>
+            <a:ext cx="2971800" cy="458787"/>
+          </a:xfrm>
+          <a:prstGeom prst="rect">
+            <a:avLst/>
+          </a:prstGeom>
+        </p:spPr>
+        <p:txBody>
+          <a:bodyPr vert="horz" lIns="91440" tIns="45720" rIns="91440" bIns="45720" rtlCol="0" anchor="b"/>
+          <a:lstStyle>
+            <a:lvl1pPr algn="l">
+              <a:defRPr sz="1200"/>
+            </a:lvl1pPr>
+          </a:lstStyle>
+          <a:p>
+            <a:endParaRPr lang="en-DE"/>
+          </a:p>
+        </p:txBody>
+      </p:sp>
+      <p:sp>
+        <p:nvSpPr>
+          <p:cNvPr id="5" name="Slide Number Placeholder 4">
+            <a:extLst>
+              <a:ext uri="{FF2B5EF4-FFF2-40B4-BE49-F238E27FC236}">
+                <a16:creationId xmlns:a16="http://schemas.microsoft.com/office/drawing/2014/main" id="{95A5A13E-4492-6DBF-56B6-056C8FAE849D}"/>
+              </a:ext>
+            </a:extLst>
+          </p:cNvPr>
+          <p:cNvSpPr>
+            <a:spLocks noGrp="1"/>
+          </p:cNvSpPr>
+          <p:nvPr>
+            <p:ph type="sldNum" sz="quarter" idx="3"/>
+          </p:nvPr>
+        </p:nvSpPr>
+        <p:spPr>
+          <a:xfrm>
+            <a:off x="3884613" y="8685213"/>
+            <a:ext cx="2971800" cy="458787"/>
+          </a:xfrm>
+          <a:prstGeom prst="rect">
+            <a:avLst/>
+          </a:prstGeom>
+        </p:spPr>
+        <p:txBody>
+          <a:bodyPr vert="horz" lIns="91440" tIns="45720" rIns="91440" bIns="45720" rtlCol="0" anchor="b"/>
+          <a:lstStyle>
+            <a:lvl1pPr algn="r">
+              <a:defRPr sz="1200"/>
+            </a:lvl1pPr>
+          </a:lstStyle>
+          <a:p>
+            <a:fld id="{C2B1CD73-A6E1-4043-855A-1C917EBFABEB}" type="slidenum">
+              <a:rPr lang="en-DE" smtClean="0"/>
+              <a:t>‹#›</a:t>
+            </a:fld>
+            <a:endParaRPr lang="en-DE"/>
+          </a:p>
+        </p:txBody>
+      </p:sp>
+    </p:spTree>
+    <p:extLst>
+      <p:ext uri="{BB962C8B-B14F-4D97-AF65-F5344CB8AC3E}">
+        <p14:creationId xmlns:p14="http://schemas.microsoft.com/office/powerpoint/2010/main" val="1377001107"/>
+      </p:ext>
+    </p:extLst>
+  </p:cSld>
+  <p:clrMap bg1="lt1" tx1="dk1" bg2="lt2" tx2="dk2" accent1="accent1" accent2="accent2" accent3="accent3" accent4="accent4" accent5="accent5" accent6="accent6" hlink="hlink" folHlink="folHlink"/>
+</p:handoutMaster>
+</file>
+
 <file path=ppt/notesMasters/notesMaster1.xml><?xml version="1.0" encoding="utf-8"?>
 <p:notesMaster xmlns:a="http://schemas.openxmlformats.org/drawingml/2006/main" xmlns:r="http://schemas.openxmlformats.org/officeDocument/2006/relationships" xmlns:p="http://schemas.openxmlformats.org/presentationml/2006/main">
   <p:cSld>
@@ -551,7 +746,7 @@
           <a:p>
             <a:fld id="{CEF57384-5D6E-7E42-90C4-560B39EF53DD}" type="datetimeFigureOut">
               <a:rPr lang="en-DE" smtClean="0"/>
-              <a:t>01.02.26</a:t>
+              <a:t>08.02.26</a:t>
             </a:fld>
             <a:endParaRPr lang="en-DE"/>
           </a:p>
@@ -1181,7 +1376,7 @@
             <a:fld id="{48A87A34-81AB-432B-8DAE-1953F412C126}" type="datetimeFigureOut">
               <a:rPr lang="en-US" smtClean="0"/>
               <a:pPr/>
-              <a:t>2/1/26</a:t>
+              <a:t>2/8/26</a:t>
             </a:fld>
             <a:endParaRPr lang="en-US" dirty="0"/>
           </a:p>
@@ -1351,7 +1546,7 @@
           <a:p>
             <a:fld id="{48A87A34-81AB-432B-8DAE-1953F412C126}" type="datetimeFigureOut">
               <a:rPr lang="en-US" smtClean="0"/>
-              <a:t>2/1/26</a:t>
+              <a:t>2/8/26</a:t>
             </a:fld>
             <a:endParaRPr lang="en-US" dirty="0"/>
           </a:p>
@@ -1531,7 +1726,7 @@
           <a:p>
             <a:fld id="{48A87A34-81AB-432B-8DAE-1953F412C126}" type="datetimeFigureOut">
               <a:rPr lang="en-US" smtClean="0"/>
-              <a:t>2/1/26</a:t>
+              <a:t>2/8/26</a:t>
             </a:fld>
             <a:endParaRPr lang="en-US" dirty="0"/>
           </a:p>
@@ -1623,7 +1818,7 @@
         </p:nvSpPr>
         <p:spPr>
           <a:xfrm>
-            <a:off x="2170229" y="3797265"/>
+            <a:off x="2170229" y="2296714"/>
             <a:ext cx="5944954" cy="923330"/>
           </a:xfrm>
           <a:prstGeom prst="rect">
@@ -1673,7 +1868,7 @@
         </p:nvGrpSpPr>
         <p:grpSpPr>
           <a:xfrm>
-            <a:off x="4153139" y="2366480"/>
+            <a:off x="4153139" y="1475527"/>
             <a:ext cx="1979135" cy="925200"/>
             <a:chOff x="4315976" y="15244200"/>
             <a:chExt cx="1979135" cy="925200"/>
@@ -1764,7 +1959,7 @@
             <a:fld id="{48A87A34-81AB-432B-8DAE-1953F412C126}" type="datetimeFigureOut">
               <a:rPr lang="en-US" smtClean="0"/>
               <a:pPr/>
-              <a:t>2/1/26</a:t>
+              <a:t>2/8/26</a:t>
             </a:fld>
             <a:endParaRPr lang="en-US" dirty="0"/>
           </a:p>
@@ -2037,7 +2232,7 @@
           <a:p>
             <a:fld id="{48A87A34-81AB-432B-8DAE-1953F412C126}" type="datetimeFigureOut">
               <a:rPr lang="en-US" smtClean="0"/>
-              <a:t>2/1/26</a:t>
+              <a:t>2/8/26</a:t>
             </a:fld>
             <a:endParaRPr lang="en-US" dirty="0"/>
           </a:p>
@@ -2269,7 +2464,7 @@
           <a:p>
             <a:fld id="{48A87A34-81AB-432B-8DAE-1953F412C126}" type="datetimeFigureOut">
               <a:rPr lang="en-US" smtClean="0"/>
-              <a:t>2/1/26</a:t>
+              <a:t>2/8/26</a:t>
             </a:fld>
             <a:endParaRPr lang="en-US" dirty="0"/>
           </a:p>
@@ -2636,7 +2831,7 @@
           <a:p>
             <a:fld id="{48A87A34-81AB-432B-8DAE-1953F412C126}" type="datetimeFigureOut">
               <a:rPr lang="en-US" smtClean="0"/>
-              <a:t>2/1/26</a:t>
+              <a:t>2/8/26</a:t>
             </a:fld>
             <a:endParaRPr lang="en-US" dirty="0"/>
           </a:p>
@@ -2754,7 +2949,7 @@
           <a:p>
             <a:fld id="{48A87A34-81AB-432B-8DAE-1953F412C126}" type="datetimeFigureOut">
               <a:rPr lang="en-US" smtClean="0"/>
-              <a:t>2/1/26</a:t>
+              <a:t>2/8/26</a:t>
             </a:fld>
             <a:endParaRPr lang="en-US" dirty="0"/>
           </a:p>
@@ -2849,7 +3044,7 @@
           <a:p>
             <a:fld id="{48A87A34-81AB-432B-8DAE-1953F412C126}" type="datetimeFigureOut">
               <a:rPr lang="en-US" smtClean="0"/>
-              <a:t>2/1/26</a:t>
+              <a:t>2/8/26</a:t>
             </a:fld>
             <a:endParaRPr lang="en-US" dirty="0"/>
           </a:p>
@@ -3126,7 +3321,7 @@
           <a:p>
             <a:fld id="{48A87A34-81AB-432B-8DAE-1953F412C126}" type="datetimeFigureOut">
               <a:rPr lang="en-US" smtClean="0"/>
-              <a:t>2/1/26</a:t>
+              <a:t>2/8/26</a:t>
             </a:fld>
             <a:endParaRPr lang="en-US" dirty="0"/>
           </a:p>
@@ -3383,7 +3578,7 @@
           <a:p>
             <a:fld id="{48A87A34-81AB-432B-8DAE-1953F412C126}" type="datetimeFigureOut">
               <a:rPr lang="en-US" smtClean="0"/>
-              <a:t>2/1/26</a:t>
+              <a:t>2/8/26</a:t>
             </a:fld>
             <a:endParaRPr lang="en-US" dirty="0"/>
           </a:p>
@@ -3597,7 +3792,7 @@
             <a:fld id="{48A87A34-81AB-432B-8DAE-1953F412C126}" type="datetimeFigureOut">
               <a:rPr lang="en-US" smtClean="0"/>
               <a:pPr/>
-              <a:t>2/1/26</a:t>
+              <a:t>2/8/26</a:t>
             </a:fld>
             <a:endParaRPr lang="en-US" dirty="0"/>
           </a:p>
@@ -4721,7 +4916,7 @@
         </p:nvGrpSpPr>
         <p:grpSpPr>
           <a:xfrm>
-            <a:off x="223307" y="5019052"/>
+            <a:off x="223307" y="3175262"/>
             <a:ext cx="9838799" cy="1219682"/>
             <a:chOff x="223307" y="2872200"/>
             <a:chExt cx="9838799" cy="1219682"/>
@@ -4771,7 +4966,7 @@
             </a:bodyPr>
             <a:lstStyle/>
             <a:p>
-              <a:pPr marL="0" algn="ctr" defTabSz="457200" rtl="0" eaLnBrk="1" latinLnBrk="0" hangingPunct="1"/>
+              <a:pPr algn="ctr"/>
               <a:r>
                 <a:rPr lang="en-US" sz="7200" b="1" dirty="0">
                   <a:ln w="10160">
@@ -4792,7 +4987,7 @@
                   </a:effectLst>
                   <a:latin typeface="Patrick Hand" pitchFamily="2" charset="77"/>
                 </a:rPr>
-                <a:t>Multiple Return Value</a:t>
+                <a:t>is not None</a:t>
               </a:r>
               <a:endParaRPr lang="en-GB" sz="2000" b="1" dirty="0">
                 <a:ln w="10160">
@@ -4838,7 +5033,7 @@
           </p:blipFill>
           <p:spPr>
             <a:xfrm>
-              <a:off x="304696" y="2978294"/>
+              <a:off x="304696" y="2948314"/>
               <a:ext cx="1063167" cy="1063167"/>
             </a:xfrm>
             <a:prstGeom prst="rect">
@@ -4854,10 +5049,10 @@
       </p:grpSp>
       <p:sp>
         <p:nvSpPr>
-          <p:cNvPr id="8" name="TextBox 7">
-            <a:extLst>
-              <a:ext uri="{FF2B5EF4-FFF2-40B4-BE49-F238E27FC236}">
-                <a16:creationId xmlns:a16="http://schemas.microsoft.com/office/drawing/2014/main" id="{AEE03D9B-1535-30F4-8FCF-17698FBE3FB4}"/>
+          <p:cNvPr id="13" name="TextBox 12">
+            <a:extLst>
+              <a:ext uri="{FF2B5EF4-FFF2-40B4-BE49-F238E27FC236}">
+                <a16:creationId xmlns:a16="http://schemas.microsoft.com/office/drawing/2014/main" id="{D7D543BA-0420-574A-E215-D1B9F98B2DBB}"/>
               </a:ext>
             </a:extLst>
           </p:cNvPr>
@@ -4866,44 +5061,8 @@
         </p:nvSpPr>
         <p:spPr>
           <a:xfrm>
-            <a:off x="2203568" y="11856891"/>
-            <a:ext cx="5878276" cy="923330"/>
-          </a:xfrm>
-          <a:prstGeom prst="rect">
-            <a:avLst/>
-          </a:prstGeom>
-          <a:noFill/>
-        </p:spPr>
-        <p:txBody>
-          <a:bodyPr wrap="none" rtlCol="0">
-            <a:spAutoFit/>
-          </a:bodyPr>
-          <a:lstStyle/>
-          <a:p>
-            <a:r>
-              <a:rPr lang="en-GB" sz="5400" b="1" dirty="0"/>
-              <a:t>Simple &amp; Powerful: </a:t>
-            </a:r>
-            <a:endParaRPr lang="en-DE" sz="5400" b="1" dirty="0"/>
-          </a:p>
-        </p:txBody>
-      </p:sp>
-      <p:sp>
-        <p:nvSpPr>
-          <p:cNvPr id="13" name="TextBox 12">
-            <a:extLst>
-              <a:ext uri="{FF2B5EF4-FFF2-40B4-BE49-F238E27FC236}">
-                <a16:creationId xmlns:a16="http://schemas.microsoft.com/office/drawing/2014/main" id="{D7D543BA-0420-574A-E215-D1B9F98B2DBB}"/>
-              </a:ext>
-            </a:extLst>
-          </p:cNvPr>
-          <p:cNvSpPr txBox="1"/>
-          <p:nvPr/>
-        </p:nvSpPr>
-        <p:spPr>
-          <a:xfrm>
-            <a:off x="318055" y="12921039"/>
-            <a:ext cx="9649302" cy="1938992"/>
+            <a:off x="318055" y="11404891"/>
+            <a:ext cx="9649302" cy="2862322"/>
           </a:xfrm>
           <a:prstGeom prst="rect">
             <a:avLst/>
@@ -4918,17 +5077,179 @@
           <a:p>
             <a:pPr algn="ctr"/>
             <a:r>
-              <a:rPr lang="en-GB" sz="6000" dirty="0">
-                <a:latin typeface="Patrick Hand" pitchFamily="2" charset="77"/>
-              </a:rPr>
-              <a:t>Return and unpack multiple results in one line</a:t>
-            </a:r>
-            <a:endParaRPr lang="en-DE" sz="6000" dirty="0">
+              <a:rPr lang="en-GB" sz="6000" b="1" dirty="0"/>
+              <a:t>Stop using 'not is None' </a:t>
+            </a:r>
+            <a:r>
+              <a:rPr lang="en-DE" sz="6000" b="1" dirty="0"/>
+              <a:t>❌ </a:t>
+            </a:r>
+            <a:r>
+              <a:rPr lang="en-GB" sz="6000" b="1" dirty="0"/>
+              <a:t>Python wants 'is not None' </a:t>
+            </a:r>
+            <a:r>
+              <a:rPr lang="en-DE" sz="6000" b="1" dirty="0"/>
+              <a:t>✅ #</a:t>
+            </a:r>
+            <a:r>
+              <a:rPr lang="en-GB" sz="6000" b="1" dirty="0" err="1"/>
+              <a:t>pythontips</a:t>
+            </a:r>
+            <a:endParaRPr lang="en-DE" sz="23900" dirty="0">
               <a:latin typeface="Patrick Hand" pitchFamily="2" charset="77"/>
             </a:endParaRPr>
           </a:p>
         </p:txBody>
       </p:sp>
+      <p:pic>
+        <p:nvPicPr>
+          <p:cNvPr id="10" name="Picture 9">
+            <a:extLst>
+              <a:ext uri="{FF2B5EF4-FFF2-40B4-BE49-F238E27FC236}">
+                <a16:creationId xmlns:a16="http://schemas.microsoft.com/office/drawing/2014/main" id="{2CDB1CAB-44FB-1BCB-DE8C-D0BC29E87F76}"/>
+              </a:ext>
+            </a:extLst>
+          </p:cNvPr>
+          <p:cNvPicPr>
+            <a:picLocks noChangeAspect="1"/>
+          </p:cNvPicPr>
+          <p:nvPr/>
+        </p:nvPicPr>
+        <p:blipFill rotWithShape="1">
+          <a:blip r:embed="rId4"/>
+          <a:srcRect l="17862" t="24155" r="12757" b="15159"/>
+          <a:stretch>
+            <a:fillRect/>
+          </a:stretch>
+        </p:blipFill>
+        <p:spPr>
+          <a:xfrm>
+            <a:off x="241483" y="4471058"/>
+            <a:ext cx="9802447" cy="6411801"/>
+          </a:xfrm>
+          <a:prstGeom prst="rect">
+            <a:avLst/>
+          </a:prstGeom>
+        </p:spPr>
+      </p:pic>
+      <p:cxnSp>
+        <p:nvCxnSpPr>
+          <p:cNvPr id="12" name="Straight Connector 11">
+            <a:extLst>
+              <a:ext uri="{FF2B5EF4-FFF2-40B4-BE49-F238E27FC236}">
+                <a16:creationId xmlns:a16="http://schemas.microsoft.com/office/drawing/2014/main" id="{26C1930A-9DD9-0861-9D22-2EB6C114CC45}"/>
+              </a:ext>
+            </a:extLst>
+          </p:cNvPr>
+          <p:cNvCxnSpPr>
+            <a:cxnSpLocks/>
+          </p:cNvCxnSpPr>
+          <p:nvPr/>
+        </p:nvCxnSpPr>
+        <p:spPr>
+          <a:xfrm>
+            <a:off x="223579" y="8240887"/>
+            <a:ext cx="9838255" cy="0"/>
+          </a:xfrm>
+          <a:prstGeom prst="line">
+            <a:avLst/>
+          </a:prstGeom>
+          <a:ln w="38100">
+            <a:solidFill>
+              <a:schemeClr val="bg1"/>
+            </a:solidFill>
+            <a:headEnd type="none"/>
+            <a:tailEnd type="none" w="lg" len="lg"/>
+          </a:ln>
+        </p:spPr>
+        <p:style>
+          <a:lnRef idx="1">
+            <a:schemeClr val="accent1"/>
+          </a:lnRef>
+          <a:fillRef idx="0">
+            <a:schemeClr val="accent1"/>
+          </a:fillRef>
+          <a:effectRef idx="0">
+            <a:schemeClr val="accent1"/>
+          </a:effectRef>
+          <a:fontRef idx="minor">
+            <a:schemeClr val="tx1"/>
+          </a:fontRef>
+        </p:style>
+      </p:cxnSp>
+      <p:pic>
+        <p:nvPicPr>
+          <p:cNvPr id="14" name="Graphic 13" descr="Shield Tick with solid fill">
+            <a:extLst>
+              <a:ext uri="{FF2B5EF4-FFF2-40B4-BE49-F238E27FC236}">
+                <a16:creationId xmlns:a16="http://schemas.microsoft.com/office/drawing/2014/main" id="{4AB6922E-51A1-4F9B-B3FB-0190AAFD0CFE}"/>
+              </a:ext>
+            </a:extLst>
+          </p:cNvPr>
+          <p:cNvPicPr>
+            <a:picLocks noChangeAspect="1"/>
+          </p:cNvPicPr>
+          <p:nvPr/>
+        </p:nvPicPr>
+        <p:blipFill>
+          <a:blip r:embed="rId5">
+            <a:extLst>
+              <a:ext uri="{96DAC541-7B7A-43D3-8B79-37D633B846F1}">
+                <asvg:svgBlip xmlns:asvg="http://schemas.microsoft.com/office/drawing/2016/SVG/main" r:embed="rId6"/>
+              </a:ext>
+            </a:extLst>
+          </a:blip>
+          <a:stretch>
+            <a:fillRect/>
+          </a:stretch>
+        </p:blipFill>
+        <p:spPr>
+          <a:xfrm>
+            <a:off x="7632967" y="9646139"/>
+            <a:ext cx="914400" cy="914400"/>
+          </a:xfrm>
+          <a:prstGeom prst="rect">
+            <a:avLst/>
+          </a:prstGeom>
+        </p:spPr>
+      </p:pic>
+      <p:pic>
+        <p:nvPicPr>
+          <p:cNvPr id="15" name="Graphic 14" descr="Close with solid fill">
+            <a:extLst>
+              <a:ext uri="{FF2B5EF4-FFF2-40B4-BE49-F238E27FC236}">
+                <a16:creationId xmlns:a16="http://schemas.microsoft.com/office/drawing/2014/main" id="{3ABE61AC-0D6F-7FE4-F16E-F95916AA32D9}"/>
+              </a:ext>
+            </a:extLst>
+          </p:cNvPr>
+          <p:cNvPicPr>
+            <a:picLocks noChangeAspect="1"/>
+          </p:cNvPicPr>
+          <p:nvPr/>
+        </p:nvPicPr>
+        <p:blipFill>
+          <a:blip r:embed="rId7">
+            <a:extLst>
+              <a:ext uri="{96DAC541-7B7A-43D3-8B79-37D633B846F1}">
+                <asvg:svgBlip xmlns:asvg="http://schemas.microsoft.com/office/drawing/2016/SVG/main" r:embed="rId8"/>
+              </a:ext>
+            </a:extLst>
+          </a:blip>
+          <a:stretch>
+            <a:fillRect/>
+          </a:stretch>
+        </p:blipFill>
+        <p:spPr>
+          <a:xfrm>
+            <a:off x="7632967" y="6992100"/>
+            <a:ext cx="914400" cy="914400"/>
+          </a:xfrm>
+          <a:prstGeom prst="rect">
+            <a:avLst/>
+          </a:prstGeom>
+        </p:spPr>
+      </p:pic>
     </p:spTree>
     <p:extLst>
       <p:ext uri="{BB962C8B-B14F-4D97-AF65-F5344CB8AC3E}">
@@ -6051,6 +6372,37 @@
           <a:chExt cx="0" cy="0"/>
         </a:xfrm>
       </p:grpSpPr>
+      <p:pic>
+        <p:nvPicPr>
+          <p:cNvPr id="68" name="Picture 67">
+            <a:extLst>
+              <a:ext uri="{FF2B5EF4-FFF2-40B4-BE49-F238E27FC236}">
+                <a16:creationId xmlns:a16="http://schemas.microsoft.com/office/drawing/2014/main" id="{F3CE120D-ACBB-D3F1-0486-DEADB0753081}"/>
+              </a:ext>
+            </a:extLst>
+          </p:cNvPr>
+          <p:cNvPicPr>
+            <a:picLocks noChangeAspect="1"/>
+          </p:cNvPicPr>
+          <p:nvPr/>
+        </p:nvPicPr>
+        <p:blipFill rotWithShape="1">
+          <a:blip r:embed="rId4"/>
+          <a:srcRect l="14078" t="16802" r="9945" b="11314"/>
+          <a:stretch>
+            <a:fillRect/>
+          </a:stretch>
+        </p:blipFill>
+        <p:spPr>
+          <a:xfrm>
+            <a:off x="223306" y="4511386"/>
+            <a:ext cx="9838800" cy="7131479"/>
+          </a:xfrm>
+          <a:prstGeom prst="rect">
+            <a:avLst/>
+          </a:prstGeom>
+        </p:spPr>
+      </p:pic>
       <p:sp>
         <p:nvSpPr>
           <p:cNvPr id="4" name="TextBox 3">
@@ -6065,7 +6417,7 @@
         </p:nvSpPr>
         <p:spPr>
           <a:xfrm>
-            <a:off x="223306" y="4711150"/>
+            <a:off x="223306" y="3178906"/>
             <a:ext cx="9838800" cy="1236996"/>
           </a:xfrm>
           <a:prstGeom prst="rect">
@@ -6092,12 +6444,29 @@
           </a:fontRef>
         </p:style>
         <p:txBody>
-          <a:bodyPr wrap="square" rtlCol="0">
+          <a:bodyPr wrap="square" rtlCol="0" anchor="ctr" anchorCtr="0">
             <a:noAutofit/>
           </a:bodyPr>
           <a:lstStyle/>
           <a:p>
             <a:pPr algn="ctr"/>
+            <a:r>
+              <a:rPr lang="en-GB" sz="6600" dirty="0" err="1">
+                <a:ln w="0"/>
+                <a:solidFill>
+                  <a:schemeClr val="tx1"/>
+                </a:solidFill>
+                <a:effectLst>
+                  <a:outerShdw blurRad="38100" dist="19050" dir="2700000" algn="tl" rotWithShape="0">
+                    <a:schemeClr val="dk1">
+                      <a:alpha val="40000"/>
+                    </a:schemeClr>
+                  </a:outerShdw>
+                </a:effectLst>
+                <a:latin typeface="+mj-lt"/>
+              </a:rPr>
+              <a:t>enum</a:t>
+            </a:r>
             <a:r>
               <a:rPr lang="en-GB" sz="6600" dirty="0">
                 <a:ln w="0"/>
@@ -6111,9 +6480,77 @@
                     </a:schemeClr>
                   </a:outerShdw>
                 </a:effectLst>
-                <a:latin typeface="Patrick Hand" pitchFamily="2" charset="77"/>
+                <a:latin typeface="+mj-lt"/>
               </a:rPr>
-              <a:t>Proper Default Values</a:t>
+              <a:t> </a:t>
+            </a:r>
+            <a:r>
+              <a:rPr lang="en-GB" sz="6600" dirty="0">
+                <a:ln w="0"/>
+                <a:solidFill>
+                  <a:srgbClr val="FF0000"/>
+                </a:solidFill>
+                <a:effectLst>
+                  <a:outerShdw blurRad="38100" dist="19050" dir="2700000" algn="tl" rotWithShape="0">
+                    <a:schemeClr val="dk1">
+                      <a:alpha val="40000"/>
+                    </a:schemeClr>
+                  </a:outerShdw>
+                </a:effectLst>
+                <a:latin typeface="+mj-lt"/>
+              </a:rPr>
+              <a:t>vs</a:t>
+            </a:r>
+            <a:r>
+              <a:rPr lang="en-GB" sz="6600" dirty="0">
+                <a:ln w="0"/>
+                <a:solidFill>
+                  <a:schemeClr val="tx1"/>
+                </a:solidFill>
+                <a:effectLst>
+                  <a:outerShdw blurRad="38100" dist="19050" dir="2700000" algn="tl" rotWithShape="0">
+                    <a:schemeClr val="dk1">
+                      <a:alpha val="40000"/>
+                    </a:schemeClr>
+                  </a:outerShdw>
+                </a:effectLst>
+                <a:latin typeface="+mj-lt"/>
+              </a:rPr>
+              <a:t> </a:t>
+            </a:r>
+            <a:r>
+              <a:rPr lang="en-GB" sz="6600" dirty="0" err="1">
+                <a:ln w="0"/>
+                <a:solidFill>
+                  <a:schemeClr val="tx1"/>
+                </a:solidFill>
+                <a:effectLst>
+                  <a:outerShdw blurRad="38100" dist="19050" dir="2700000" algn="tl" rotWithShape="0">
+                    <a:schemeClr val="dk1">
+                      <a:alpha val="40000"/>
+                    </a:schemeClr>
+                  </a:outerShdw>
+                </a:effectLst>
+                <a:latin typeface="+mj-lt"/>
+              </a:rPr>
+              <a:t>const</a:t>
+            </a:r>
+            <a:r>
+              <a:rPr lang="en-GB" sz="6600" dirty="0">
+                <a:ln w="0"/>
+                <a:solidFill>
+                  <a:schemeClr val="tx1"/>
+                </a:solidFill>
+                <a:effectLst>
+                  <a:outerShdw blurRad="38100" dist="19050" dir="2700000" algn="tl" rotWithShape="0">
+                    <a:schemeClr val="dk1">
+                      <a:alpha val="40000"/>
+                    </a:schemeClr>
+                  </a:outerShdw>
+                </a:effectLst>
+                <a:latin typeface="+mj-lt"/>
+              </a:rPr>
+              <a:t> object</a:t>
             </a:r>
             <a:endParaRPr lang="en-GB" dirty="0">
               <a:ln w="0"/>
@@ -6127,17 +6564,17 @@
                   </a:schemeClr>
                 </a:outerShdw>
               </a:effectLst>
-              <a:latin typeface="Patrick Hand" pitchFamily="2" charset="77"/>
+              <a:latin typeface="+mj-lt"/>
             </a:endParaRPr>
           </a:p>
         </p:txBody>
       </p:sp>
       <p:sp>
         <p:nvSpPr>
-          <p:cNvPr id="8" name="TextBox 7">
-            <a:extLst>
-              <a:ext uri="{FF2B5EF4-FFF2-40B4-BE49-F238E27FC236}">
-                <a16:creationId xmlns:a16="http://schemas.microsoft.com/office/drawing/2014/main" id="{0FB6466C-E2D3-5BB5-C081-E0B032E8D95E}"/>
+          <p:cNvPr id="13" name="TextBox 12">
+            <a:extLst>
+              <a:ext uri="{FF2B5EF4-FFF2-40B4-BE49-F238E27FC236}">
+                <a16:creationId xmlns:a16="http://schemas.microsoft.com/office/drawing/2014/main" id="{F3BD1735-8985-8256-67B3-05BD77A49ADA}"/>
               </a:ext>
             </a:extLst>
           </p:cNvPr>
@@ -6146,8 +6583,8 @@
         </p:nvSpPr>
         <p:spPr>
           <a:xfrm>
-            <a:off x="1994761" y="13143279"/>
-            <a:ext cx="6295891" cy="1015663"/>
+            <a:off x="103506" y="11899238"/>
+            <a:ext cx="10078400" cy="1200329"/>
           </a:xfrm>
           <a:prstGeom prst="rect">
             <a:avLst/>
@@ -6161,48 +6598,24 @@
           <a:lstStyle/>
           <a:p>
             <a:r>
-              <a:rPr lang="en-GB" sz="6000" b="1" dirty="0"/>
-              <a:t>Precision Defaults: </a:t>
-            </a:r>
-            <a:endParaRPr lang="en-DE" sz="6000" b="1" dirty="0"/>
-          </a:p>
-        </p:txBody>
-      </p:sp>
-      <p:sp>
-        <p:nvSpPr>
-          <p:cNvPr id="13" name="TextBox 12">
-            <a:extLst>
-              <a:ext uri="{FF2B5EF4-FFF2-40B4-BE49-F238E27FC236}">
-                <a16:creationId xmlns:a16="http://schemas.microsoft.com/office/drawing/2014/main" id="{F3BD1735-8985-8256-67B3-05BD77A49ADA}"/>
-              </a:ext>
-            </a:extLst>
-          </p:cNvPr>
-          <p:cNvSpPr txBox="1"/>
-          <p:nvPr/>
-        </p:nvSpPr>
-        <p:spPr>
-          <a:xfrm>
-            <a:off x="158008" y="14148182"/>
-            <a:ext cx="9969396" cy="1015663"/>
-          </a:xfrm>
-          <a:prstGeom prst="rect">
-            <a:avLst/>
-          </a:prstGeom>
-          <a:noFill/>
-        </p:spPr>
-        <p:txBody>
-          <a:bodyPr wrap="none" rtlCol="0">
-            <a:spAutoFit/>
-          </a:bodyPr>
-          <a:lstStyle/>
-          <a:p>
-            <a:r>
-              <a:rPr lang="en-GB" sz="6000" dirty="0">
+              <a:rPr lang="en-GB" sz="7200" dirty="0">
                 <a:latin typeface="Patrick Hand" pitchFamily="2" charset="77"/>
               </a:rPr>
-              <a:t>Use ?? To handle null and undefined</a:t>
-            </a:r>
-            <a:endParaRPr lang="en-DE" sz="6000" dirty="0">
+              <a:t>Stop using TypeScript </a:t>
+            </a:r>
+            <a:r>
+              <a:rPr lang="en-GB" sz="7200" dirty="0" err="1">
+                <a:latin typeface="Patrick Hand" pitchFamily="2" charset="77"/>
+              </a:rPr>
+              <a:t>enums</a:t>
+            </a:r>
+            <a:r>
+              <a:rPr lang="en-GB" sz="7200" dirty="0">
+                <a:latin typeface="Patrick Hand" pitchFamily="2" charset="77"/>
+              </a:rPr>
+              <a:t> </a:t>
+            </a:r>
+            <a:endParaRPr lang="en-DE" sz="7200" dirty="0">
               <a:latin typeface="Patrick Hand" pitchFamily="2" charset="77"/>
             </a:endParaRPr>
           </a:p>
@@ -6210,10 +6623,10 @@
       </p:sp>
       <p:pic>
         <p:nvPicPr>
-          <p:cNvPr id="18" name="Graphic 17" descr="Shield Tick with solid fill">
-            <a:extLst>
-              <a:ext uri="{FF2B5EF4-FFF2-40B4-BE49-F238E27FC236}">
-                <a16:creationId xmlns:a16="http://schemas.microsoft.com/office/drawing/2014/main" id="{8CA46C9F-5635-B18F-C0D5-486A750B4AC1}"/>
+          <p:cNvPr id="3" name="Picture 2">
+            <a:extLst>
+              <a:ext uri="{FF2B5EF4-FFF2-40B4-BE49-F238E27FC236}">
+                <a16:creationId xmlns:a16="http://schemas.microsoft.com/office/drawing/2014/main" id="{265DA11A-38F0-02D1-8A40-0EC8D8F1B8C0}"/>
               </a:ext>
             </a:extLst>
           </p:cNvPr>
@@ -6223,86 +6636,14 @@
           <p:nvPr/>
         </p:nvPicPr>
         <p:blipFill>
-          <a:blip r:embed="rId4">
-            <a:extLst>
-              <a:ext uri="{96DAC541-7B7A-43D3-8B79-37D633B846F1}">
-                <asvg:svgBlip xmlns:asvg="http://schemas.microsoft.com/office/drawing/2016/SVG/main" r:embed="rId5"/>
-              </a:ext>
-            </a:extLst>
-          </a:blip>
+          <a:blip r:embed="rId5"/>
           <a:stretch>
             <a:fillRect/>
           </a:stretch>
         </p:blipFill>
         <p:spPr>
           <a:xfrm>
-            <a:off x="3154048" y="9759930"/>
-            <a:ext cx="914400" cy="914400"/>
-          </a:xfrm>
-          <a:prstGeom prst="rect">
-            <a:avLst/>
-          </a:prstGeom>
-        </p:spPr>
-      </p:pic>
-      <p:pic>
-        <p:nvPicPr>
-          <p:cNvPr id="19" name="Graphic 18" descr="Close with solid fill">
-            <a:extLst>
-              <a:ext uri="{FF2B5EF4-FFF2-40B4-BE49-F238E27FC236}">
-                <a16:creationId xmlns:a16="http://schemas.microsoft.com/office/drawing/2014/main" id="{E78D45BA-2387-8D65-95CD-92DA3F514E24}"/>
-              </a:ext>
-            </a:extLst>
-          </p:cNvPr>
-          <p:cNvPicPr>
-            <a:picLocks noChangeAspect="1"/>
-          </p:cNvPicPr>
-          <p:nvPr/>
-        </p:nvPicPr>
-        <p:blipFill>
-          <a:blip r:embed="rId6">
-            <a:extLst>
-              <a:ext uri="{96DAC541-7B7A-43D3-8B79-37D633B846F1}">
-                <asvg:svgBlip xmlns:asvg="http://schemas.microsoft.com/office/drawing/2016/SVG/main" r:embed="rId7"/>
-              </a:ext>
-            </a:extLst>
-          </a:blip>
-          <a:stretch>
-            <a:fillRect/>
-          </a:stretch>
-        </p:blipFill>
-        <p:spPr>
-          <a:xfrm>
-            <a:off x="6216966" y="9623125"/>
-            <a:ext cx="914400" cy="914400"/>
-          </a:xfrm>
-          <a:prstGeom prst="rect">
-            <a:avLst/>
-          </a:prstGeom>
-        </p:spPr>
-      </p:pic>
-      <p:pic>
-        <p:nvPicPr>
-          <p:cNvPr id="3" name="Picture 2">
-            <a:extLst>
-              <a:ext uri="{FF2B5EF4-FFF2-40B4-BE49-F238E27FC236}">
-                <a16:creationId xmlns:a16="http://schemas.microsoft.com/office/drawing/2014/main" id="{265DA11A-38F0-02D1-8A40-0EC8D8F1B8C0}"/>
-              </a:ext>
-            </a:extLst>
-          </p:cNvPr>
-          <p:cNvPicPr>
-            <a:picLocks noChangeAspect="1"/>
-          </p:cNvPicPr>
-          <p:nvPr/>
-        </p:nvPicPr>
-        <p:blipFill>
-          <a:blip r:embed="rId8"/>
-          <a:stretch>
-            <a:fillRect/>
-          </a:stretch>
-        </p:blipFill>
-        <p:spPr>
-          <a:xfrm>
-            <a:off x="295124" y="4806634"/>
+            <a:off x="295124" y="3274390"/>
             <a:ext cx="1062000" cy="1062000"/>
           </a:xfrm>
           <a:prstGeom prst="rect">
@@ -6326,7 +6667,7 @@
         </p:nvCxnSpPr>
         <p:spPr>
           <a:xfrm>
-            <a:off x="216954" y="9223788"/>
+            <a:off x="216954" y="7740971"/>
             <a:ext cx="9838255" cy="0"/>
           </a:xfrm>
           <a:prstGeom prst="line">
@@ -6406,6 +6747,37 @@
           <a:chExt cx="0" cy="0"/>
         </a:xfrm>
       </p:grpSpPr>
+      <p:pic>
+        <p:nvPicPr>
+          <p:cNvPr id="2" name="Picture 1">
+            <a:extLst>
+              <a:ext uri="{FF2B5EF4-FFF2-40B4-BE49-F238E27FC236}">
+                <a16:creationId xmlns:a16="http://schemas.microsoft.com/office/drawing/2014/main" id="{0F1DA6CD-952E-9986-B832-F85293F720C5}"/>
+              </a:ext>
+            </a:extLst>
+          </p:cNvPr>
+          <p:cNvPicPr>
+            <a:picLocks noChangeAspect="1"/>
+          </p:cNvPicPr>
+          <p:nvPr/>
+        </p:nvPicPr>
+        <p:blipFill rotWithShape="1">
+          <a:blip r:embed="rId4"/>
+          <a:srcRect l="18832" t="19224" r="11084" b="11724"/>
+          <a:stretch>
+            <a:fillRect/>
+          </a:stretch>
+        </p:blipFill>
+        <p:spPr>
+          <a:xfrm>
+            <a:off x="460906" y="4437787"/>
+            <a:ext cx="9363600" cy="8491006"/>
+          </a:xfrm>
+          <a:prstGeom prst="rect">
+            <a:avLst/>
+          </a:prstGeom>
+        </p:spPr>
+      </p:pic>
       <p:sp>
         <p:nvSpPr>
           <p:cNvPr id="4" name="TextBox 3">
@@ -6420,8 +6792,8 @@
         </p:nvSpPr>
         <p:spPr>
           <a:xfrm>
-            <a:off x="223306" y="4810542"/>
-            <a:ext cx="9838800" cy="1236996"/>
+            <a:off x="462706" y="3105307"/>
+            <a:ext cx="9360000" cy="1236996"/>
           </a:xfrm>
           <a:prstGeom prst="rect">
             <a:avLst/>
@@ -6473,9 +6845,9 @@
           </a:bodyPr>
           <a:lstStyle/>
           <a:p>
-            <a:pPr marL="0" algn="r" defTabSz="457200" rtl="0" eaLnBrk="1" latinLnBrk="0" hangingPunct="1"/>
-            <a:r>
-              <a:rPr lang="en-US" sz="5400" b="1" dirty="0">
+            <a:pPr marL="0" algn="ctr" defTabSz="457200" rtl="0" eaLnBrk="1" latinLnBrk="0" hangingPunct="1"/>
+            <a:r>
+              <a:rPr lang="en-US" sz="8000" b="1" dirty="0">
                 <a:ln w="0"/>
                 <a:solidFill>
                   <a:schemeClr val="tx1"/>
@@ -6489,10 +6861,10 @@
                 </a:effectLst>
                 <a:latin typeface="+mj-lt"/>
               </a:rPr>
-              <a:t>Interface: Open </a:t>
-            </a:r>
-            <a:r>
-              <a:rPr lang="en-US" sz="5400" b="1" dirty="0">
+              <a:t>as </a:t>
+            </a:r>
+            <a:r>
+              <a:rPr lang="en-US" sz="8000" b="1" dirty="0">
                 <a:ln w="12700">
                   <a:solidFill>
                     <a:schemeClr val="accent1"/>
@@ -6517,10 +6889,10 @@
                 </a:effectLst>
                 <a:latin typeface="+mj-lt"/>
               </a:rPr>
-              <a:t>vs</a:t>
-            </a:r>
-            <a:r>
-              <a:rPr lang="en-US" sz="5400" dirty="0">
+              <a:t>vs </a:t>
+            </a:r>
+            <a:r>
+              <a:rPr lang="en-US" sz="8000" b="1" dirty="0">
                 <a:ln w="0"/>
                 <a:solidFill>
                   <a:schemeClr val="tx1"/>
@@ -6534,26 +6906,9 @@
                 </a:effectLst>
                 <a:latin typeface="+mj-lt"/>
               </a:rPr>
-              <a:t> </a:t>
-            </a:r>
-            <a:r>
-              <a:rPr lang="en-US" sz="5400" b="1" dirty="0">
-                <a:ln w="0"/>
-                <a:solidFill>
-                  <a:schemeClr val="tx1"/>
-                </a:solidFill>
-                <a:effectLst>
-                  <a:outerShdw blurRad="38100" dist="19050" dir="2700000" algn="tl" rotWithShape="0">
-                    <a:schemeClr val="dk1">
-                      <a:alpha val="40000"/>
-                    </a:schemeClr>
-                  </a:outerShdw>
-                </a:effectLst>
-                <a:latin typeface="+mj-lt"/>
-              </a:rPr>
-              <a:t>Type: Closed</a:t>
-            </a:r>
-            <a:endParaRPr lang="en-GB" sz="4800" b="1" dirty="0">
+              <a:t>satisfies</a:t>
+            </a:r>
+            <a:endParaRPr lang="en-GB" sz="7200" b="1" dirty="0">
               <a:ln w="0"/>
               <a:solidFill>
                 <a:schemeClr val="tx1"/>
@@ -6584,8 +6939,8 @@
         </p:nvSpPr>
         <p:spPr>
           <a:xfrm>
-            <a:off x="223306" y="12057329"/>
-            <a:ext cx="9838256" cy="1966526"/>
+            <a:off x="374789" y="13317722"/>
+            <a:ext cx="9535835" cy="1236995"/>
           </a:xfrm>
           <a:prstGeom prst="rect">
             <a:avLst/>
@@ -6600,30 +6955,12 @@
           <a:p>
             <a:pPr algn="ctr"/>
             <a:r>
-              <a:rPr lang="en-GB" sz="6000" u="sng" dirty="0">
+              <a:rPr lang="en-GB" sz="6000" b="1" dirty="0">
                 <a:latin typeface="Patrick Hand" pitchFamily="2" charset="77"/>
               </a:rPr>
-              <a:t>Interfaces</a:t>
-            </a:r>
-            <a:r>
-              <a:rPr lang="en-GB" sz="6000" dirty="0">
-                <a:latin typeface="Patrick Hand" pitchFamily="2" charset="77"/>
-              </a:rPr>
-              <a:t> are open to expansion, </a:t>
-            </a:r>
-            <a:r>
-              <a:rPr lang="en-GB" sz="6000" u="sng" dirty="0">
-                <a:latin typeface="Patrick Hand" pitchFamily="2" charset="77"/>
-              </a:rPr>
-              <a:t>Types</a:t>
-            </a:r>
-            <a:r>
-              <a:rPr lang="en-GB" sz="6000" dirty="0">
-                <a:latin typeface="Patrick Hand" pitchFamily="2" charset="77"/>
-              </a:rPr>
-              <a:t> are closed.</a:t>
-            </a:r>
-            <a:endParaRPr lang="en-DE" sz="6000" dirty="0">
+              <a:t>Stop lying to TypeScript with as</a:t>
+            </a:r>
+            <a:endParaRPr lang="en-DE" sz="6000" b="1" dirty="0">
               <a:latin typeface="Patrick Hand" pitchFamily="2" charset="77"/>
             </a:endParaRPr>
           </a:p>
@@ -6645,8 +6982,8 @@
         </p:nvCxnSpPr>
         <p:spPr>
           <a:xfrm>
-            <a:off x="223307" y="9132826"/>
-            <a:ext cx="9838255" cy="0"/>
+            <a:off x="460906" y="9222471"/>
+            <a:ext cx="9361800" cy="0"/>
           </a:xfrm>
           <a:prstGeom prst="line">
             <a:avLst/>
@@ -6689,14 +7026,14 @@
           <p:nvPr/>
         </p:nvPicPr>
         <p:blipFill>
-          <a:blip r:embed="rId4"/>
+          <a:blip r:embed="rId5"/>
           <a:stretch>
             <a:fillRect/>
           </a:stretch>
         </p:blipFill>
         <p:spPr>
           <a:xfrm>
-            <a:off x="232778" y="4906026"/>
+            <a:off x="603482" y="3183206"/>
             <a:ext cx="1062000" cy="1062000"/>
           </a:xfrm>
           <a:prstGeom prst="rect">
@@ -6758,6 +7095,37 @@
           <a:chExt cx="0" cy="0"/>
         </a:xfrm>
       </p:grpSpPr>
+      <p:pic>
+        <p:nvPicPr>
+          <p:cNvPr id="2" name="Picture 1">
+            <a:extLst>
+              <a:ext uri="{FF2B5EF4-FFF2-40B4-BE49-F238E27FC236}">
+                <a16:creationId xmlns:a16="http://schemas.microsoft.com/office/drawing/2014/main" id="{7BAE6144-CFA8-2390-5E64-4F0F624805D5}"/>
+              </a:ext>
+            </a:extLst>
+          </p:cNvPr>
+          <p:cNvPicPr>
+            <a:picLocks noChangeAspect="1"/>
+          </p:cNvPicPr>
+          <p:nvPr/>
+        </p:nvPicPr>
+        <p:blipFill rotWithShape="1">
+          <a:blip r:embed="rId3"/>
+          <a:srcRect l="20250" t="17146" r="17442" b="14853"/>
+          <a:stretch>
+            <a:fillRect/>
+          </a:stretch>
+        </p:blipFill>
+        <p:spPr>
+          <a:xfrm>
+            <a:off x="462706" y="4392260"/>
+            <a:ext cx="9360000" cy="12190693"/>
+          </a:xfrm>
+          <a:prstGeom prst="rect">
+            <a:avLst/>
+          </a:prstGeom>
+        </p:spPr>
+      </p:pic>
       <p:sp>
         <p:nvSpPr>
           <p:cNvPr id="4" name="TextBox 3">
@@ -6772,8 +7140,8 @@
         </p:nvSpPr>
         <p:spPr>
           <a:xfrm>
-            <a:off x="223306" y="4673426"/>
-            <a:ext cx="9838800" cy="1236996"/>
+            <a:off x="462706" y="3113568"/>
+            <a:ext cx="9360000" cy="1236996"/>
           </a:xfrm>
           <a:prstGeom prst="rect">
             <a:avLst/>
@@ -6820,7 +7188,29 @@
                 </a:effectLst>
                 <a:latin typeface="+mj-lt"/>
               </a:rPr>
-              <a:t>Union Types</a:t>
+              <a:t>Stop using </a:t>
+            </a:r>
+            <a:r>
+              <a:rPr lang="en-US" sz="7200" b="1" dirty="0">
+                <a:ln w="10160">
+                  <a:solidFill>
+                    <a:schemeClr val="accent5"/>
+                  </a:solidFill>
+                  <a:prstDash val="solid"/>
+                </a:ln>
+                <a:solidFill>
+                  <a:srgbClr val="FFFFFF"/>
+                </a:solidFill>
+                <a:effectLst>
+                  <a:outerShdw blurRad="38100" dist="22860" dir="5400000" algn="tl" rotWithShape="0">
+                    <a:srgbClr val="000000">
+                      <a:alpha val="30000"/>
+                    </a:srgbClr>
+                  </a:outerShdw>
+                </a:effectLst>
+                <a:latin typeface="+mj-lt"/>
+              </a:rPr>
+              <a:t>any</a:t>
             </a:r>
             <a:endParaRPr lang="en-GB" sz="6600" b="1" dirty="0">
               <a:ln w="0"/>
@@ -6839,73 +7229,6 @@
           </a:p>
         </p:txBody>
       </p:sp>
-      <p:sp>
-        <p:nvSpPr>
-          <p:cNvPr id="13" name="TextBox 12">
-            <a:extLst>
-              <a:ext uri="{FF2B5EF4-FFF2-40B4-BE49-F238E27FC236}">
-                <a16:creationId xmlns:a16="http://schemas.microsoft.com/office/drawing/2014/main" id="{5DB19DD8-CAE1-EED2-641D-73C2315F0895}"/>
-              </a:ext>
-            </a:extLst>
-          </p:cNvPr>
-          <p:cNvSpPr txBox="1"/>
-          <p:nvPr/>
-        </p:nvSpPr>
-        <p:spPr>
-          <a:xfrm>
-            <a:off x="451219" y="11080552"/>
-            <a:ext cx="9610887" cy="1966526"/>
-          </a:xfrm>
-          <a:prstGeom prst="rect">
-            <a:avLst/>
-          </a:prstGeom>
-          <a:noFill/>
-        </p:spPr>
-        <p:txBody>
-          <a:bodyPr wrap="square" rtlCol="0">
-            <a:noAutofit/>
-          </a:bodyPr>
-          <a:lstStyle/>
-          <a:p>
-            <a:pPr algn="ctr"/>
-            <a:r>
-              <a:rPr lang="en-GB" sz="6000" b="1" dirty="0">
-                <a:ln w="9525">
-                  <a:solidFill>
-                    <a:schemeClr val="bg1"/>
-                  </a:solidFill>
-                  <a:prstDash val="solid"/>
-                </a:ln>
-                <a:effectLst>
-                  <a:outerShdw blurRad="12700" dist="38100" dir="2700000" algn="tl" rotWithShape="0">
-                    <a:schemeClr val="bg1">
-                      <a:lumMod val="50000"/>
-                    </a:schemeClr>
-                  </a:outerShdw>
-                </a:effectLst>
-                <a:latin typeface="Patrick Hand" pitchFamily="2" charset="77"/>
-              </a:rPr>
-              <a:t>Restrict a variable to only specific allowed values</a:t>
-            </a:r>
-            <a:endParaRPr lang="en-DE" sz="6000" b="1" dirty="0">
-              <a:ln w="9525">
-                <a:solidFill>
-                  <a:schemeClr val="bg1"/>
-                </a:solidFill>
-                <a:prstDash val="solid"/>
-              </a:ln>
-              <a:effectLst>
-                <a:outerShdw blurRad="12700" dist="38100" dir="2700000" algn="tl" rotWithShape="0">
-                  <a:schemeClr val="bg1">
-                    <a:lumMod val="50000"/>
-                  </a:schemeClr>
-                </a:outerShdw>
-              </a:effectLst>
-              <a:latin typeface="Patrick Hand" pitchFamily="2" charset="77"/>
-            </a:endParaRPr>
-          </a:p>
-        </p:txBody>
-      </p:sp>
       <p:pic>
         <p:nvPicPr>
           <p:cNvPr id="3" name="Picture 2">
@@ -6921,14 +7244,14 @@
           <p:nvPr/>
         </p:nvPicPr>
         <p:blipFill>
-          <a:blip r:embed="rId3"/>
+          <a:blip r:embed="rId4"/>
           <a:stretch>
             <a:fillRect/>
           </a:stretch>
         </p:blipFill>
         <p:spPr>
           <a:xfrm>
-            <a:off x="321693" y="4768910"/>
+            <a:off x="572703" y="3209052"/>
             <a:ext cx="1062000" cy="1062000"/>
           </a:xfrm>
           <a:prstGeom prst="rect">
@@ -6936,6 +7259,96 @@
           </a:prstGeom>
         </p:spPr>
       </p:pic>
+      <p:cxnSp>
+        <p:nvCxnSpPr>
+          <p:cNvPr id="5" name="Straight Connector 4">
+            <a:extLst>
+              <a:ext uri="{FF2B5EF4-FFF2-40B4-BE49-F238E27FC236}">
+                <a16:creationId xmlns:a16="http://schemas.microsoft.com/office/drawing/2014/main" id="{6A1CE049-F0C9-01B6-F3C3-B00EEDA1A696}"/>
+              </a:ext>
+            </a:extLst>
+          </p:cNvPr>
+          <p:cNvCxnSpPr>
+            <a:cxnSpLocks/>
+          </p:cNvCxnSpPr>
+          <p:nvPr/>
+        </p:nvCxnSpPr>
+        <p:spPr>
+          <a:xfrm>
+            <a:off x="460906" y="6999232"/>
+            <a:ext cx="9361800" cy="0"/>
+          </a:xfrm>
+          <a:prstGeom prst="line">
+            <a:avLst/>
+          </a:prstGeom>
+          <a:ln w="38100">
+            <a:solidFill>
+              <a:schemeClr val="bg1"/>
+            </a:solidFill>
+            <a:headEnd type="none"/>
+            <a:tailEnd type="none" w="lg" len="lg"/>
+          </a:ln>
+        </p:spPr>
+        <p:style>
+          <a:lnRef idx="1">
+            <a:schemeClr val="accent1"/>
+          </a:lnRef>
+          <a:fillRef idx="0">
+            <a:schemeClr val="accent1"/>
+          </a:fillRef>
+          <a:effectRef idx="0">
+            <a:schemeClr val="accent1"/>
+          </a:effectRef>
+          <a:fontRef idx="minor">
+            <a:schemeClr val="tx1"/>
+          </a:fontRef>
+        </p:style>
+      </p:cxnSp>
+      <p:cxnSp>
+        <p:nvCxnSpPr>
+          <p:cNvPr id="6" name="Straight Connector 5">
+            <a:extLst>
+              <a:ext uri="{FF2B5EF4-FFF2-40B4-BE49-F238E27FC236}">
+                <a16:creationId xmlns:a16="http://schemas.microsoft.com/office/drawing/2014/main" id="{9F50EFF4-7510-AFD2-0DB0-3B661E2C773B}"/>
+              </a:ext>
+            </a:extLst>
+          </p:cNvPr>
+          <p:cNvCxnSpPr>
+            <a:cxnSpLocks/>
+          </p:cNvCxnSpPr>
+          <p:nvPr/>
+        </p:nvCxnSpPr>
+        <p:spPr>
+          <a:xfrm>
+            <a:off x="469872" y="10845088"/>
+            <a:ext cx="9361800" cy="0"/>
+          </a:xfrm>
+          <a:prstGeom prst="line">
+            <a:avLst/>
+          </a:prstGeom>
+          <a:ln w="38100">
+            <a:solidFill>
+              <a:schemeClr val="bg1"/>
+            </a:solidFill>
+            <a:headEnd type="none"/>
+            <a:tailEnd type="none" w="lg" len="lg"/>
+          </a:ln>
+        </p:spPr>
+        <p:style>
+          <a:lnRef idx="1">
+            <a:schemeClr val="accent1"/>
+          </a:lnRef>
+          <a:fillRef idx="0">
+            <a:schemeClr val="accent1"/>
+          </a:fillRef>
+          <a:effectRef idx="0">
+            <a:schemeClr val="accent1"/>
+          </a:effectRef>
+          <a:fontRef idx="minor">
+            <a:schemeClr val="tx1"/>
+          </a:fontRef>
+        </p:style>
+      </p:cxnSp>
     </p:spTree>
     <p:extLst>
       <p:ext uri="{BB962C8B-B14F-4D97-AF65-F5344CB8AC3E}">
@@ -7026,8 +7439,8 @@
         </p:nvSpPr>
         <p:spPr>
           <a:xfrm>
-            <a:off x="223306" y="4752938"/>
-            <a:ext cx="9838800" cy="1236996"/>
+            <a:off x="282706" y="3171267"/>
+            <a:ext cx="9720000" cy="1236996"/>
           </a:xfrm>
           <a:prstGeom prst="rect">
             <a:avLst/>
@@ -7053,12 +7466,12 @@
           </a:fontRef>
         </p:style>
         <p:txBody>
-          <a:bodyPr wrap="square" rtlCol="0" anchor="ctr" anchorCtr="0">
+          <a:bodyPr wrap="square" lIns="90000" rtlCol="0" anchor="ctr" anchorCtr="0">
             <a:noAutofit/>
           </a:bodyPr>
           <a:lstStyle/>
           <a:p>
-            <a:pPr marL="0" algn="r" defTabSz="457200" rtl="0" eaLnBrk="1" latinLnBrk="0" hangingPunct="1"/>
+            <a:pPr algn="r"/>
             <a:r>
               <a:rPr lang="en-US" sz="5400" b="1" dirty="0">
                 <a:ln w="0"/>
@@ -7074,24 +7487,7 @@
                 </a:effectLst>
                 <a:latin typeface="+mj-lt"/>
               </a:rPr>
-              <a:t>Lock your Data With </a:t>
-            </a:r>
-            <a:r>
-              <a:rPr lang="en-US" sz="5400" b="1" u="sng" dirty="0" err="1">
-                <a:ln w="0"/>
-                <a:solidFill>
-                  <a:schemeClr val="tx1"/>
-                </a:solidFill>
-                <a:effectLst>
-                  <a:outerShdw blurRad="38100" dist="19050" dir="2700000" algn="tl" rotWithShape="0">
-                    <a:schemeClr val="dk1">
-                      <a:alpha val="40000"/>
-                    </a:schemeClr>
-                  </a:outerShdw>
-                </a:effectLst>
-                <a:latin typeface="+mj-lt"/>
-              </a:rPr>
-              <a:t>readonly</a:t>
+              <a:t>Don't Use Capitalized Types</a:t>
             </a:r>
             <a:endParaRPr lang="en-GB" sz="4800" b="1" u="sng" dirty="0">
               <a:ln w="0"/>
@@ -7124,8 +7520,8 @@
         </p:nvSpPr>
         <p:spPr>
           <a:xfrm>
-            <a:off x="0" y="11240794"/>
-            <a:ext cx="9610887" cy="1966526"/>
+            <a:off x="0" y="11614283"/>
+            <a:ext cx="10285413" cy="1966526"/>
           </a:xfrm>
           <a:prstGeom prst="rect">
             <a:avLst/>
@@ -7160,7 +7556,7 @@
                 </a:effectLst>
                 <a:latin typeface="Patrick Hand" pitchFamily="2" charset="77"/>
               </a:rPr>
-              <a:t>Prevent accidental changes to critical object properties</a:t>
+              <a:t>Stop Using Number, String, Boolean in TypeScript</a:t>
             </a:r>
             <a:endParaRPr lang="en-DE" sz="6000" b="1" dirty="0">
               <a:ln w="13462">
@@ -7207,8 +7603,156 @@
         </p:blipFill>
         <p:spPr>
           <a:xfrm>
-            <a:off x="321693" y="4848422"/>
+            <a:off x="402973" y="3266751"/>
             <a:ext cx="1062000" cy="1062000"/>
+          </a:xfrm>
+          <a:prstGeom prst="rect">
+            <a:avLst/>
+          </a:prstGeom>
+        </p:spPr>
+      </p:pic>
+      <p:pic>
+        <p:nvPicPr>
+          <p:cNvPr id="2" name="Picture 1">
+            <a:extLst>
+              <a:ext uri="{FF2B5EF4-FFF2-40B4-BE49-F238E27FC236}">
+                <a16:creationId xmlns:a16="http://schemas.microsoft.com/office/drawing/2014/main" id="{06A170A4-987A-F9E9-A678-72EFCE37BD9C}"/>
+              </a:ext>
+            </a:extLst>
+          </p:cNvPr>
+          <p:cNvPicPr>
+            <a:picLocks noChangeAspect="1"/>
+          </p:cNvPicPr>
+          <p:nvPr/>
+        </p:nvPicPr>
+        <p:blipFill rotWithShape="1">
+          <a:blip r:embed="rId3"/>
+          <a:srcRect l="16211" t="19975" r="11426" b="15940"/>
+          <a:stretch>
+            <a:fillRect/>
+          </a:stretch>
+        </p:blipFill>
+        <p:spPr>
+          <a:xfrm>
+            <a:off x="282706" y="4503746"/>
+            <a:ext cx="9720000" cy="7022503"/>
+          </a:xfrm>
+          <a:prstGeom prst="rect">
+            <a:avLst/>
+          </a:prstGeom>
+        </p:spPr>
+      </p:pic>
+      <p:cxnSp>
+        <p:nvCxnSpPr>
+          <p:cNvPr id="5" name="Straight Connector 4">
+            <a:extLst>
+              <a:ext uri="{FF2B5EF4-FFF2-40B4-BE49-F238E27FC236}">
+                <a16:creationId xmlns:a16="http://schemas.microsoft.com/office/drawing/2014/main" id="{B8D733A5-C210-3AA7-06D2-38C10B9A8729}"/>
+              </a:ext>
+            </a:extLst>
+          </p:cNvPr>
+          <p:cNvCxnSpPr>
+            <a:cxnSpLocks/>
+          </p:cNvCxnSpPr>
+          <p:nvPr/>
+        </p:nvCxnSpPr>
+        <p:spPr>
+          <a:xfrm>
+            <a:off x="248296" y="7928622"/>
+            <a:ext cx="9739979" cy="0"/>
+          </a:xfrm>
+          <a:prstGeom prst="line">
+            <a:avLst/>
+          </a:prstGeom>
+          <a:ln w="38100">
+            <a:solidFill>
+              <a:schemeClr val="bg1"/>
+            </a:solidFill>
+            <a:headEnd type="none"/>
+            <a:tailEnd type="none" w="lg" len="lg"/>
+          </a:ln>
+        </p:spPr>
+        <p:style>
+          <a:lnRef idx="1">
+            <a:schemeClr val="accent1"/>
+          </a:lnRef>
+          <a:fillRef idx="0">
+            <a:schemeClr val="accent1"/>
+          </a:fillRef>
+          <a:effectRef idx="0">
+            <a:schemeClr val="accent1"/>
+          </a:effectRef>
+          <a:fontRef idx="minor">
+            <a:schemeClr val="tx1"/>
+          </a:fontRef>
+        </p:style>
+      </p:cxnSp>
+      <p:pic>
+        <p:nvPicPr>
+          <p:cNvPr id="7" name="Graphic 6" descr="Shield Tick with solid fill">
+            <a:extLst>
+              <a:ext uri="{FF2B5EF4-FFF2-40B4-BE49-F238E27FC236}">
+                <a16:creationId xmlns:a16="http://schemas.microsoft.com/office/drawing/2014/main" id="{DB9234E6-4D75-B78D-1305-094B82ABD24E}"/>
+              </a:ext>
+            </a:extLst>
+          </p:cNvPr>
+          <p:cNvPicPr>
+            <a:picLocks noChangeAspect="1"/>
+          </p:cNvPicPr>
+          <p:nvPr/>
+        </p:nvPicPr>
+        <p:blipFill>
+          <a:blip r:embed="rId4">
+            <a:extLst>
+              <a:ext uri="{96DAC541-7B7A-43D3-8B79-37D633B846F1}">
+                <asvg:svgBlip xmlns:asvg="http://schemas.microsoft.com/office/drawing/2016/SVG/main" r:embed="rId5"/>
+              </a:ext>
+            </a:extLst>
+          </a:blip>
+          <a:stretch>
+            <a:fillRect/>
+          </a:stretch>
+        </p:blipFill>
+        <p:spPr>
+          <a:xfrm>
+            <a:off x="5425763" y="9707437"/>
+            <a:ext cx="914400" cy="914400"/>
+          </a:xfrm>
+          <a:prstGeom prst="rect">
+            <a:avLst/>
+          </a:prstGeom>
+        </p:spPr>
+      </p:pic>
+      <p:pic>
+        <p:nvPicPr>
+          <p:cNvPr id="8" name="Graphic 7" descr="Close with solid fill">
+            <a:extLst>
+              <a:ext uri="{FF2B5EF4-FFF2-40B4-BE49-F238E27FC236}">
+                <a16:creationId xmlns:a16="http://schemas.microsoft.com/office/drawing/2014/main" id="{42B697DC-9187-FF81-1FA5-55AE6E44412A}"/>
+              </a:ext>
+            </a:extLst>
+          </p:cNvPr>
+          <p:cNvPicPr>
+            <a:picLocks noChangeAspect="1"/>
+          </p:cNvPicPr>
+          <p:nvPr/>
+        </p:nvPicPr>
+        <p:blipFill>
+          <a:blip r:embed="rId6">
+            <a:extLst>
+              <a:ext uri="{96DAC541-7B7A-43D3-8B79-37D633B846F1}">
+                <asvg:svgBlip xmlns:asvg="http://schemas.microsoft.com/office/drawing/2016/SVG/main" r:embed="rId7"/>
+              </a:ext>
+            </a:extLst>
+          </a:blip>
+          <a:stretch>
+            <a:fillRect/>
+          </a:stretch>
+        </p:blipFill>
+        <p:spPr>
+          <a:xfrm>
+            <a:off x="5425763" y="6050587"/>
+            <a:ext cx="914400" cy="914400"/>
           </a:xfrm>
           <a:prstGeom prst="rect">
             <a:avLst/>
@@ -7278,7 +7822,7 @@
         </p:nvSpPr>
         <p:spPr>
           <a:xfrm>
-            <a:off x="223306" y="5408921"/>
+            <a:off x="223306" y="3295311"/>
             <a:ext cx="9838800" cy="1236996"/>
           </a:xfrm>
           <a:prstGeom prst="rect">
@@ -7306,7 +7850,7 @@
           </a:bodyPr>
           <a:lstStyle/>
           <a:p>
-            <a:pPr marL="0" algn="ctr" defTabSz="457200" rtl="0" eaLnBrk="1" latinLnBrk="0" hangingPunct="1"/>
+            <a:pPr algn="ctr"/>
             <a:r>
               <a:rPr lang="en-US" sz="5400" b="1" dirty="0">
                 <a:ln w="0"/>
@@ -7322,7 +7866,7 @@
                 </a:effectLst>
                 <a:latin typeface="+mj-lt"/>
               </a:rPr>
-              <a:t>The Power of Partial&lt;T&gt;</a:t>
+              <a:t>Callback Types: any vs void</a:t>
             </a:r>
             <a:endParaRPr lang="en-GB" sz="4800" b="1" u="sng" dirty="0">
               <a:ln w="0"/>
@@ -7355,7 +7899,7 @@
         </p:nvSpPr>
         <p:spPr>
           <a:xfrm>
-            <a:off x="0" y="10609432"/>
+            <a:off x="337263" y="9248929"/>
             <a:ext cx="9610887" cy="1966526"/>
           </a:xfrm>
           <a:prstGeom prst="rect">
@@ -7371,36 +7915,34 @@
           <a:p>
             <a:pPr algn="ctr"/>
             <a:r>
-              <a:rPr lang="en-GB" sz="7200" b="1" dirty="0">
-                <a:ln w="22225">
-                  <a:solidFill>
-                    <a:schemeClr val="accent2"/>
-                  </a:solidFill>
-                  <a:prstDash val="solid"/>
-                </a:ln>
+              <a:rPr lang="en-GB" sz="7200" dirty="0">
+                <a:ln w="0"/>
                 <a:solidFill>
-                  <a:schemeClr val="accent2">
-                    <a:lumMod val="40000"/>
-                    <a:lumOff val="60000"/>
-                  </a:schemeClr>
+                  <a:srgbClr val="C00000"/>
                 </a:solidFill>
+                <a:effectLst>
+                  <a:outerShdw blurRad="38100" dist="25400" dir="5400000" algn="ctr" rotWithShape="0">
+                    <a:srgbClr val="6E747A">
+                      <a:alpha val="43000"/>
+                    </a:srgbClr>
+                  </a:outerShdw>
+                </a:effectLst>
                 <a:latin typeface="Patrick Hand" pitchFamily="2" charset="77"/>
               </a:rPr>
-              <a:t>Make all properties in an interface optional</a:t>
-            </a:r>
-            <a:endParaRPr lang="en-DE" sz="7200" b="1" dirty="0">
-              <a:ln w="22225">
-                <a:solidFill>
-                  <a:schemeClr val="accent2"/>
-                </a:solidFill>
-                <a:prstDash val="solid"/>
-              </a:ln>
+              <a:t>Stop Using 'any' in TypeScript Callbacks</a:t>
+            </a:r>
+            <a:endParaRPr lang="en-DE" sz="7200" dirty="0">
+              <a:ln w="0"/>
               <a:solidFill>
-                <a:schemeClr val="accent2">
-                  <a:lumMod val="40000"/>
-                  <a:lumOff val="60000"/>
-                </a:schemeClr>
+                <a:srgbClr val="C00000"/>
               </a:solidFill>
+              <a:effectLst>
+                <a:outerShdw blurRad="38100" dist="25400" dir="5400000" algn="ctr" rotWithShape="0">
+                  <a:srgbClr val="6E747A">
+                    <a:alpha val="43000"/>
+                  </a:srgbClr>
+                </a:outerShdw>
+              </a:effectLst>
               <a:latin typeface="Patrick Hand" pitchFamily="2" charset="77"/>
             </a:endParaRPr>
           </a:p>
@@ -7428,8 +7970,156 @@
         </p:blipFill>
         <p:spPr>
           <a:xfrm>
-            <a:off x="321693" y="5504405"/>
+            <a:off x="321693" y="3390795"/>
             <a:ext cx="1062000" cy="1062000"/>
+          </a:xfrm>
+          <a:prstGeom prst="rect">
+            <a:avLst/>
+          </a:prstGeom>
+        </p:spPr>
+      </p:pic>
+      <p:pic>
+        <p:nvPicPr>
+          <p:cNvPr id="2" name="Picture 1">
+            <a:extLst>
+              <a:ext uri="{FF2B5EF4-FFF2-40B4-BE49-F238E27FC236}">
+                <a16:creationId xmlns:a16="http://schemas.microsoft.com/office/drawing/2014/main" id="{51CE5434-848C-FCE7-0A7E-C0BC9651101C}"/>
+              </a:ext>
+            </a:extLst>
+          </p:cNvPr>
+          <p:cNvPicPr>
+            <a:picLocks noChangeAspect="1"/>
+          </p:cNvPicPr>
+          <p:nvPr/>
+        </p:nvPicPr>
+        <p:blipFill rotWithShape="1">
+          <a:blip r:embed="rId5"/>
+          <a:srcRect l="15128" t="25694" r="10494" b="19880"/>
+          <a:stretch>
+            <a:fillRect/>
+          </a:stretch>
+        </p:blipFill>
+        <p:spPr>
+          <a:xfrm>
+            <a:off x="228168" y="4627790"/>
+            <a:ext cx="9829077" cy="4366305"/>
+          </a:xfrm>
+          <a:prstGeom prst="rect">
+            <a:avLst/>
+          </a:prstGeom>
+        </p:spPr>
+      </p:pic>
+      <p:cxnSp>
+        <p:nvCxnSpPr>
+          <p:cNvPr id="5" name="Straight Connector 4">
+            <a:extLst>
+              <a:ext uri="{FF2B5EF4-FFF2-40B4-BE49-F238E27FC236}">
+                <a16:creationId xmlns:a16="http://schemas.microsoft.com/office/drawing/2014/main" id="{D30B8567-5C2F-BF22-C5C5-549CF6D17AE3}"/>
+              </a:ext>
+            </a:extLst>
+          </p:cNvPr>
+          <p:cNvCxnSpPr>
+            <a:cxnSpLocks/>
+          </p:cNvCxnSpPr>
+          <p:nvPr/>
+        </p:nvCxnSpPr>
+        <p:spPr>
+          <a:xfrm>
+            <a:off x="248296" y="6789375"/>
+            <a:ext cx="9739979" cy="0"/>
+          </a:xfrm>
+          <a:prstGeom prst="line">
+            <a:avLst/>
+          </a:prstGeom>
+          <a:ln w="38100">
+            <a:solidFill>
+              <a:schemeClr val="bg1"/>
+            </a:solidFill>
+            <a:headEnd type="none"/>
+            <a:tailEnd type="none" w="lg" len="lg"/>
+          </a:ln>
+        </p:spPr>
+        <p:style>
+          <a:lnRef idx="1">
+            <a:schemeClr val="accent1"/>
+          </a:lnRef>
+          <a:fillRef idx="0">
+            <a:schemeClr val="accent1"/>
+          </a:fillRef>
+          <a:effectRef idx="0">
+            <a:schemeClr val="accent1"/>
+          </a:effectRef>
+          <a:fontRef idx="minor">
+            <a:schemeClr val="tx1"/>
+          </a:fontRef>
+        </p:style>
+      </p:cxnSp>
+      <p:pic>
+        <p:nvPicPr>
+          <p:cNvPr id="6" name="Graphic 5" descr="Shield Tick with solid fill">
+            <a:extLst>
+              <a:ext uri="{FF2B5EF4-FFF2-40B4-BE49-F238E27FC236}">
+                <a16:creationId xmlns:a16="http://schemas.microsoft.com/office/drawing/2014/main" id="{CED034E5-55F1-723E-D426-963F1E6FFFD3}"/>
+              </a:ext>
+            </a:extLst>
+          </p:cNvPr>
+          <p:cNvPicPr>
+            <a:picLocks noChangeAspect="1"/>
+          </p:cNvPicPr>
+          <p:nvPr/>
+        </p:nvPicPr>
+        <p:blipFill>
+          <a:blip r:embed="rId6">
+            <a:extLst>
+              <a:ext uri="{96DAC541-7B7A-43D3-8B79-37D633B846F1}">
+                <asvg:svgBlip xmlns:asvg="http://schemas.microsoft.com/office/drawing/2016/SVG/main" r:embed="rId7"/>
+              </a:ext>
+            </a:extLst>
+          </a:blip>
+          <a:stretch>
+            <a:fillRect/>
+          </a:stretch>
+        </p:blipFill>
+        <p:spPr>
+          <a:xfrm>
+            <a:off x="5425763" y="7878644"/>
+            <a:ext cx="914400" cy="914400"/>
+          </a:xfrm>
+          <a:prstGeom prst="rect">
+            <a:avLst/>
+          </a:prstGeom>
+        </p:spPr>
+      </p:pic>
+      <p:pic>
+        <p:nvPicPr>
+          <p:cNvPr id="7" name="Graphic 6" descr="Close with solid fill">
+            <a:extLst>
+              <a:ext uri="{FF2B5EF4-FFF2-40B4-BE49-F238E27FC236}">
+                <a16:creationId xmlns:a16="http://schemas.microsoft.com/office/drawing/2014/main" id="{9610F1C5-2BFF-BA90-5ED2-600E6423D288}"/>
+              </a:ext>
+            </a:extLst>
+          </p:cNvPr>
+          <p:cNvPicPr>
+            <a:picLocks noChangeAspect="1"/>
+          </p:cNvPicPr>
+          <p:nvPr/>
+        </p:nvPicPr>
+        <p:blipFill>
+          <a:blip r:embed="rId8">
+            <a:extLst>
+              <a:ext uri="{96DAC541-7B7A-43D3-8B79-37D633B846F1}">
+                <asvg:svgBlip xmlns:asvg="http://schemas.microsoft.com/office/drawing/2016/SVG/main" r:embed="rId9"/>
+              </a:ext>
+            </a:extLst>
+          </a:blip>
+          <a:stretch>
+            <a:fillRect/>
+          </a:stretch>
+        </p:blipFill>
+        <p:spPr>
+          <a:xfrm>
+            <a:off x="5425763" y="5720806"/>
+            <a:ext cx="914400" cy="914400"/>
           </a:xfrm>
           <a:prstGeom prst="rect">
             <a:avLst/>
@@ -13988,6 +14678,321 @@
 </a:theme>
 </file>
 
+<file path=ppt/theme/theme3.xml><?xml version="1.0" encoding="utf-8"?>
+<a:theme xmlns:a="http://schemas.openxmlformats.org/drawingml/2006/main" name="Office Theme">
+  <a:themeElements>
+    <a:clrScheme name="Office">
+      <a:dk1>
+        <a:sysClr val="windowText" lastClr="000000"/>
+      </a:dk1>
+      <a:lt1>
+        <a:sysClr val="window" lastClr="FFFFFF"/>
+      </a:lt1>
+      <a:dk2>
+        <a:srgbClr val="0E2841"/>
+      </a:dk2>
+      <a:lt2>
+        <a:srgbClr val="E8E8E8"/>
+      </a:lt2>
+      <a:accent1>
+        <a:srgbClr val="156082"/>
+      </a:accent1>
+      <a:accent2>
+        <a:srgbClr val="E97132"/>
+      </a:accent2>
+      <a:accent3>
+        <a:srgbClr val="196B24"/>
+      </a:accent3>
+      <a:accent4>
+        <a:srgbClr val="0F9ED5"/>
+      </a:accent4>
+      <a:accent5>
+        <a:srgbClr val="A02B93"/>
+      </a:accent5>
+      <a:accent6>
+        <a:srgbClr val="4EA72E"/>
+      </a:accent6>
+      <a:hlink>
+        <a:srgbClr val="467886"/>
+      </a:hlink>
+      <a:folHlink>
+        <a:srgbClr val="96607D"/>
+      </a:folHlink>
+    </a:clrScheme>
+    <a:fontScheme name="Office">
+      <a:majorFont>
+        <a:latin typeface="Aptos Display" panose="02110004020202020204"/>
+        <a:ea typeface=""/>
+        <a:cs typeface=""/>
+        <a:font script="Jpan" typeface="游ゴシック Light"/>
+        <a:font script="Hang" typeface="맑은 고딕"/>
+        <a:font script="Hans" typeface="等线 Light"/>
+        <a:font script="Hant" typeface="新細明體"/>
+        <a:font script="Arab" typeface="Times New Roman"/>
+        <a:font script="Hebr" typeface="Times New Roman"/>
+        <a:font script="Thai" typeface="Angsana New"/>
+        <a:font script="Ethi" typeface="Nyala"/>
+        <a:font script="Beng" typeface="Vrinda"/>
+        <a:font script="Gujr" typeface="Shruti"/>
+        <a:font script="Khmr" typeface="MoolBoran"/>
+        <a:font script="Knda" typeface="Tunga"/>
+        <a:font script="Guru" typeface="Raavi"/>
+        <a:font script="Cans" typeface="Euphemia"/>
+        <a:font script="Cher" typeface="Plantagenet Cherokee"/>
+        <a:font script="Yiii" typeface="Microsoft Yi Baiti"/>
+        <a:font script="Tibt" typeface="Microsoft Himalaya"/>
+        <a:font script="Thaa" typeface="MV Boli"/>
+        <a:font script="Deva" typeface="Mangal"/>
+        <a:font script="Telu" typeface="Gautami"/>
+        <a:font script="Taml" typeface="Latha"/>
+        <a:font script="Syrc" typeface="Estrangelo Edessa"/>
+        <a:font script="Orya" typeface="Kalinga"/>
+        <a:font script="Mlym" typeface="Kartika"/>
+        <a:font script="Laoo" typeface="DokChampa"/>
+        <a:font script="Sinh" typeface="Iskoola Pota"/>
+        <a:font script="Mong" typeface="Mongolian Baiti"/>
+        <a:font script="Viet" typeface="Times New Roman"/>
+        <a:font script="Uigh" typeface="Microsoft Uighur"/>
+        <a:font script="Geor" typeface="Sylfaen"/>
+        <a:font script="Armn" typeface="Arial"/>
+        <a:font script="Bugi" typeface="Leelawadee UI"/>
+        <a:font script="Bopo" typeface="Microsoft JhengHei"/>
+        <a:font script="Java" typeface="Javanese Text"/>
+        <a:font script="Lisu" typeface="Segoe UI"/>
+        <a:font script="Mymr" typeface="Myanmar Text"/>
+        <a:font script="Nkoo" typeface="Ebrima"/>
+        <a:font script="Olck" typeface="Nirmala UI"/>
+        <a:font script="Osma" typeface="Ebrima"/>
+        <a:font script="Phag" typeface="Phagspa"/>
+        <a:font script="Syrn" typeface="Estrangelo Edessa"/>
+        <a:font script="Syrj" typeface="Estrangelo Edessa"/>
+        <a:font script="Syre" typeface="Estrangelo Edessa"/>
+        <a:font script="Sora" typeface="Nirmala UI"/>
+        <a:font script="Tale" typeface="Microsoft Tai Le"/>
+        <a:font script="Talu" typeface="Microsoft New Tai Lue"/>
+        <a:font script="Tfng" typeface="Ebrima"/>
+      </a:majorFont>
+      <a:minorFont>
+        <a:latin typeface="Aptos" panose="02110004020202020204"/>
+        <a:ea typeface=""/>
+        <a:cs typeface=""/>
+        <a:font script="Jpan" typeface="游ゴシック"/>
+        <a:font script="Hang" typeface="맑은 고딕"/>
+        <a:font script="Hans" typeface="等线"/>
+        <a:font script="Hant" typeface="新細明體"/>
+        <a:font script="Arab" typeface="Arial"/>
+        <a:font script="Hebr" typeface="Arial"/>
+        <a:font script="Thai" typeface="Cordia New"/>
+        <a:font script="Ethi" typeface="Nyala"/>
+        <a:font script="Beng" typeface="Vrinda"/>
+        <a:font script="Gujr" typeface="Shruti"/>
+        <a:font script="Khmr" typeface="DaunPenh"/>
+        <a:font script="Knda" typeface="Tunga"/>
+        <a:font script="Guru" typeface="Raavi"/>
+        <a:font script="Cans" typeface="Euphemia"/>
+        <a:font script="Cher" typeface="Plantagenet Cherokee"/>
+        <a:font script="Yiii" typeface="Microsoft Yi Baiti"/>
+        <a:font script="Tibt" typeface="Microsoft Himalaya"/>
+        <a:font script="Thaa" typeface="MV Boli"/>
+        <a:font script="Deva" typeface="Mangal"/>
+        <a:font script="Telu" typeface="Gautami"/>
+        <a:font script="Taml" typeface="Latha"/>
+        <a:font script="Syrc" typeface="Estrangelo Edessa"/>
+        <a:font script="Orya" typeface="Kalinga"/>
+        <a:font script="Mlym" typeface="Kartika"/>
+        <a:font script="Laoo" typeface="DokChampa"/>
+        <a:font script="Sinh" typeface="Iskoola Pota"/>
+        <a:font script="Mong" typeface="Mongolian Baiti"/>
+        <a:font script="Viet" typeface="Arial"/>
+        <a:font script="Uigh" typeface="Microsoft Uighur"/>
+        <a:font script="Geor" typeface="Sylfaen"/>
+        <a:font script="Armn" typeface="Arial"/>
+        <a:font script="Bugi" typeface="Leelawadee UI"/>
+        <a:font script="Bopo" typeface="Microsoft JhengHei"/>
+        <a:font script="Java" typeface="Javanese Text"/>
+        <a:font script="Lisu" typeface="Segoe UI"/>
+        <a:font script="Mymr" typeface="Myanmar Text"/>
+        <a:font script="Nkoo" typeface="Ebrima"/>
+        <a:font script="Olck" typeface="Nirmala UI"/>
+        <a:font script="Osma" typeface="Ebrima"/>
+        <a:font script="Phag" typeface="Phagspa"/>
+        <a:font script="Syrn" typeface="Estrangelo Edessa"/>
+        <a:font script="Syrj" typeface="Estrangelo Edessa"/>
+        <a:font script="Syre" typeface="Estrangelo Edessa"/>
+        <a:font script="Sora" typeface="Nirmala UI"/>
+        <a:font script="Tale" typeface="Microsoft Tai Le"/>
+        <a:font script="Talu" typeface="Microsoft New Tai Lue"/>
+        <a:font script="Tfng" typeface="Ebrima"/>
+      </a:minorFont>
+    </a:fontScheme>
+    <a:fmtScheme name="Office">
+      <a:fillStyleLst>
+        <a:solidFill>
+          <a:schemeClr val="phClr"/>
+        </a:solidFill>
+        <a:gradFill rotWithShape="1">
+          <a:gsLst>
+            <a:gs pos="0">
+              <a:schemeClr val="phClr">
+                <a:lumMod val="110000"/>
+                <a:satMod val="105000"/>
+                <a:tint val="67000"/>
+              </a:schemeClr>
+            </a:gs>
+            <a:gs pos="50000">
+              <a:schemeClr val="phClr">
+                <a:lumMod val="105000"/>
+                <a:satMod val="103000"/>
+                <a:tint val="73000"/>
+              </a:schemeClr>
+            </a:gs>
+            <a:gs pos="100000">
+              <a:schemeClr val="phClr">
+                <a:lumMod val="105000"/>
+                <a:satMod val="109000"/>
+                <a:tint val="81000"/>
+              </a:schemeClr>
+            </a:gs>
+          </a:gsLst>
+          <a:lin ang="5400000" scaled="0"/>
+        </a:gradFill>
+        <a:gradFill rotWithShape="1">
+          <a:gsLst>
+            <a:gs pos="0">
+              <a:schemeClr val="phClr">
+                <a:satMod val="103000"/>
+                <a:lumMod val="102000"/>
+                <a:tint val="94000"/>
+              </a:schemeClr>
+            </a:gs>
+            <a:gs pos="50000">
+              <a:schemeClr val="phClr">
+                <a:satMod val="110000"/>
+                <a:lumMod val="100000"/>
+                <a:shade val="100000"/>
+              </a:schemeClr>
+            </a:gs>
+            <a:gs pos="100000">
+              <a:schemeClr val="phClr">
+                <a:lumMod val="99000"/>
+                <a:satMod val="120000"/>
+                <a:shade val="78000"/>
+              </a:schemeClr>
+            </a:gs>
+          </a:gsLst>
+          <a:lin ang="5400000" scaled="0"/>
+        </a:gradFill>
+      </a:fillStyleLst>
+      <a:lnStyleLst>
+        <a:ln w="12700" cap="flat" cmpd="sng" algn="ctr">
+          <a:solidFill>
+            <a:schemeClr val="phClr"/>
+          </a:solidFill>
+          <a:prstDash val="solid"/>
+          <a:miter lim="800000"/>
+        </a:ln>
+        <a:ln w="19050" cap="flat" cmpd="sng" algn="ctr">
+          <a:solidFill>
+            <a:schemeClr val="phClr"/>
+          </a:solidFill>
+          <a:prstDash val="solid"/>
+          <a:miter lim="800000"/>
+        </a:ln>
+        <a:ln w="25400" cap="flat" cmpd="sng" algn="ctr">
+          <a:solidFill>
+            <a:schemeClr val="phClr"/>
+          </a:solidFill>
+          <a:prstDash val="solid"/>
+          <a:miter lim="800000"/>
+        </a:ln>
+      </a:lnStyleLst>
+      <a:effectStyleLst>
+        <a:effectStyle>
+          <a:effectLst/>
+        </a:effectStyle>
+        <a:effectStyle>
+          <a:effectLst/>
+        </a:effectStyle>
+        <a:effectStyle>
+          <a:effectLst>
+            <a:outerShdw blurRad="57150" dist="19050" dir="5400000" algn="ctr" rotWithShape="0">
+              <a:srgbClr val="000000">
+                <a:alpha val="63000"/>
+              </a:srgbClr>
+            </a:outerShdw>
+          </a:effectLst>
+        </a:effectStyle>
+      </a:effectStyleLst>
+      <a:bgFillStyleLst>
+        <a:solidFill>
+          <a:schemeClr val="phClr"/>
+        </a:solidFill>
+        <a:solidFill>
+          <a:schemeClr val="phClr">
+            <a:tint val="95000"/>
+            <a:satMod val="170000"/>
+          </a:schemeClr>
+        </a:solidFill>
+        <a:gradFill rotWithShape="1">
+          <a:gsLst>
+            <a:gs pos="0">
+              <a:schemeClr val="phClr">
+                <a:tint val="93000"/>
+                <a:satMod val="150000"/>
+                <a:shade val="98000"/>
+                <a:lumMod val="102000"/>
+              </a:schemeClr>
+            </a:gs>
+            <a:gs pos="50000">
+              <a:schemeClr val="phClr">
+                <a:tint val="98000"/>
+                <a:satMod val="130000"/>
+                <a:shade val="90000"/>
+                <a:lumMod val="103000"/>
+              </a:schemeClr>
+            </a:gs>
+            <a:gs pos="100000">
+              <a:schemeClr val="phClr">
+                <a:shade val="63000"/>
+                <a:satMod val="120000"/>
+              </a:schemeClr>
+            </a:gs>
+          </a:gsLst>
+          <a:lin ang="5400000" scaled="0"/>
+        </a:gradFill>
+      </a:bgFillStyleLst>
+    </a:fmtScheme>
+  </a:themeElements>
+  <a:objectDefaults>
+    <a:lnDef>
+      <a:spPr/>
+      <a:bodyPr/>
+      <a:lstStyle/>
+      <a:style>
+        <a:lnRef idx="2">
+          <a:schemeClr val="accent1"/>
+        </a:lnRef>
+        <a:fillRef idx="0">
+          <a:schemeClr val="accent1"/>
+        </a:fillRef>
+        <a:effectRef idx="1">
+          <a:schemeClr val="accent1"/>
+        </a:effectRef>
+        <a:fontRef idx="minor">
+          <a:schemeClr val="tx1"/>
+        </a:fontRef>
+      </a:style>
+    </a:lnDef>
+  </a:objectDefaults>
+  <a:extraClrSchemeLst/>
+  <a:extLst>
+    <a:ext uri="{05A4C25C-085E-4340-85A3-A5531E510DB2}">
+      <thm15:themeFamily xmlns:thm15="http://schemas.microsoft.com/office/thememl/2012/main" name="Office Theme" id="{2E142A2C-CD16-42D6-873A-C26D2A0506FA}" vid="{1BDDFF52-6CD6-40A5-AB3C-68EB2F1E4D0A}"/>
+    </a:ext>
+  </a:extLst>
+</a:theme>
+</file>
+
 <file path=docMetadata/LabelInfo.xml><?xml version="1.0" encoding="utf-8"?>
 <clbl:labelList xmlns:clbl="http://schemas.microsoft.com/office/2020/mipLabelMetadata">
   <clbl:label id="{b1c9b508-7c6e-42bd-bedf-808292653d6c}" enabled="1" method="Standard" siteId="{2882be50-2012-4d88-ac86-544124e120c8}" contentBits="3" removed="0"/>

</xml_diff>

<commit_message>
feat: created items 008, 009 and 011
</commit_message>
<xml_diff>
--- a/assets/images.pptx
+++ b/assets/images.pptx
@@ -5318,8 +5318,8 @@
         </p:nvSpPr>
         <p:spPr>
           <a:xfrm>
-            <a:off x="223306" y="4740755"/>
-            <a:ext cx="9838800" cy="1433029"/>
+            <a:off x="223306" y="3136810"/>
+            <a:ext cx="9838800" cy="1277088"/>
           </a:xfrm>
           <a:prstGeom prst="rect">
             <a:avLst/>
@@ -5366,64 +5366,17 @@
           </a:fontRef>
         </p:style>
         <p:txBody>
-          <a:bodyPr wrap="square" rtlCol="0">
+          <a:bodyPr wrap="square" rtlCol="0" anchor="ctr">
             <a:noAutofit/>
           </a:bodyPr>
           <a:lstStyle/>
           <a:p>
-            <a:pPr marL="0" algn="ctr" defTabSz="457200" rtl="0" eaLnBrk="1" latinLnBrk="0" hangingPunct="1"/>
-            <a:r>
-              <a:rPr lang="en-US" sz="6600" b="1" spc="50" dirty="0">
-                <a:ln w="0"/>
-                <a:solidFill>
-                  <a:schemeClr val="bg2"/>
-                </a:solidFill>
-                <a:effectLst>
-                  <a:innerShdw blurRad="63500" dist="50800" dir="13500000">
-                    <a:srgbClr val="000000">
-                      <a:alpha val="50000"/>
-                    </a:srgbClr>
-                  </a:innerShdw>
-                </a:effectLst>
-                <a:latin typeface="Patrick Hand" pitchFamily="2" charset="77"/>
-              </a:rPr>
-              <a:t>Avoid </a:t>
-            </a:r>
-            <a:r>
-              <a:rPr lang="en-US" sz="6600" b="1" spc="50" dirty="0" err="1">
-                <a:ln w="0"/>
-                <a:solidFill>
-                  <a:schemeClr val="bg2"/>
-                </a:solidFill>
-                <a:effectLst>
-                  <a:innerShdw blurRad="63500" dist="50800" dir="13500000">
-                    <a:srgbClr val="000000">
-                      <a:alpha val="50000"/>
-                    </a:srgbClr>
-                  </a:innerShdw>
-                </a:effectLst>
-                <a:latin typeface="Patrick Hand" pitchFamily="2" charset="77"/>
-              </a:rPr>
-              <a:t>KeyError</a:t>
-            </a:r>
-            <a:r>
-              <a:rPr lang="en-US" sz="6600" b="1" spc="50" dirty="0">
-                <a:ln w="0"/>
-                <a:solidFill>
-                  <a:schemeClr val="bg2"/>
-                </a:solidFill>
-                <a:effectLst>
-                  <a:innerShdw blurRad="63500" dist="50800" dir="13500000">
-                    <a:srgbClr val="000000">
-                      <a:alpha val="50000"/>
-                    </a:srgbClr>
-                  </a:innerShdw>
-                </a:effectLst>
-                <a:latin typeface="Patrick Hand" pitchFamily="2" charset="77"/>
-              </a:rPr>
-              <a:t> with .get</a:t>
-            </a:r>
-            <a:endParaRPr lang="en-GB" b="1" spc="50" dirty="0">
+            <a:pPr algn="r"/>
+            <a:r>
+              <a:rPr lang="en-GB" sz="6000" b="1" dirty="0"/>
+              <a:t>PEP 8: Better line breaks</a:t>
+            </a:r>
+            <a:endParaRPr lang="en-GB" sz="6000" b="1" spc="50" dirty="0">
               <a:ln w="0"/>
               <a:solidFill>
                 <a:schemeClr val="bg2"/>
@@ -5462,8 +5415,39 @@
         </p:blipFill>
         <p:spPr>
           <a:xfrm>
-            <a:off x="264001" y="4894976"/>
+            <a:off x="383921" y="3246060"/>
             <a:ext cx="1063167" cy="1063167"/>
+          </a:xfrm>
+          <a:prstGeom prst="rect">
+            <a:avLst/>
+          </a:prstGeom>
+        </p:spPr>
+      </p:pic>
+      <p:pic>
+        <p:nvPicPr>
+          <p:cNvPr id="3" name="Picture 2">
+            <a:extLst>
+              <a:ext uri="{FF2B5EF4-FFF2-40B4-BE49-F238E27FC236}">
+                <a16:creationId xmlns:a16="http://schemas.microsoft.com/office/drawing/2014/main" id="{3F9C6260-3B40-C4E2-D0FA-74F575E25827}"/>
+              </a:ext>
+            </a:extLst>
+          </p:cNvPr>
+          <p:cNvPicPr>
+            <a:picLocks noChangeAspect="1"/>
+          </p:cNvPicPr>
+          <p:nvPr/>
+        </p:nvPicPr>
+        <p:blipFill rotWithShape="1">
+          <a:blip r:embed="rId4"/>
+          <a:srcRect l="15206" t="22792" r="10439" b="21438"/>
+          <a:stretch>
+            <a:fillRect/>
+          </a:stretch>
+        </p:blipFill>
+        <p:spPr>
+          <a:xfrm>
+            <a:off x="223579" y="4439164"/>
+            <a:ext cx="9838255" cy="5708618"/>
           </a:xfrm>
           <a:prstGeom prst="rect">
             <a:avLst/>
@@ -5472,10 +5456,10 @@
       </p:pic>
       <p:sp>
         <p:nvSpPr>
-          <p:cNvPr id="9" name="TextBox 8">
-            <a:extLst>
-              <a:ext uri="{FF2B5EF4-FFF2-40B4-BE49-F238E27FC236}">
-                <a16:creationId xmlns:a16="http://schemas.microsoft.com/office/drawing/2014/main" id="{0A7AC106-07E4-D068-1578-18FAC0C9E102}"/>
+          <p:cNvPr id="13" name="TextBox 12">
+            <a:extLst>
+              <a:ext uri="{FF2B5EF4-FFF2-40B4-BE49-F238E27FC236}">
+                <a16:creationId xmlns:a16="http://schemas.microsoft.com/office/drawing/2014/main" id="{9FD6638E-EA6F-32B1-4BFA-0CBD50D4D970}"/>
               </a:ext>
             </a:extLst>
           </p:cNvPr>
@@ -5484,44 +5468,8 @@
         </p:nvSpPr>
         <p:spPr>
           <a:xfrm>
-            <a:off x="3238114" y="13874103"/>
-            <a:ext cx="3809184" cy="923330"/>
-          </a:xfrm>
-          <a:prstGeom prst="rect">
-            <a:avLst/>
-          </a:prstGeom>
-          <a:noFill/>
-        </p:spPr>
-        <p:txBody>
-          <a:bodyPr wrap="none" rtlCol="0">
-            <a:spAutoFit/>
-          </a:bodyPr>
-          <a:lstStyle/>
-          <a:p>
-            <a:r>
-              <a:rPr lang="en-GB" sz="5400" b="1" dirty="0"/>
-              <a:t>Safe Access: </a:t>
-            </a:r>
-            <a:endParaRPr lang="en-DE" sz="5400" b="1" dirty="0"/>
-          </a:p>
-        </p:txBody>
-      </p:sp>
-      <p:sp>
-        <p:nvSpPr>
-          <p:cNvPr id="13" name="TextBox 12">
-            <a:extLst>
-              <a:ext uri="{FF2B5EF4-FFF2-40B4-BE49-F238E27FC236}">
-                <a16:creationId xmlns:a16="http://schemas.microsoft.com/office/drawing/2014/main" id="{9FD6638E-EA6F-32B1-4BFA-0CBD50D4D970}"/>
-              </a:ext>
-            </a:extLst>
-          </p:cNvPr>
-          <p:cNvSpPr txBox="1"/>
-          <p:nvPr/>
-        </p:nvSpPr>
-        <p:spPr>
-          <a:xfrm>
-            <a:off x="1371052" y="15015453"/>
-            <a:ext cx="7543309" cy="1938992"/>
+            <a:off x="223306" y="10276331"/>
+            <a:ext cx="9838800" cy="2308324"/>
           </a:xfrm>
           <a:prstGeom prst="rect">
             <a:avLst/>
@@ -5536,12 +5484,12 @@
           <a:p>
             <a:pPr algn="ctr"/>
             <a:r>
-              <a:rPr lang="en-GB" sz="6000" dirty="0">
+              <a:rPr lang="en-GB" sz="7200" dirty="0">
                 <a:latin typeface="Patrick Hand" pitchFamily="2" charset="77"/>
               </a:rPr>
-              <a:t>Provide a default value if the key doesn’t exist</a:t>
-            </a:r>
-            <a:endParaRPr lang="en-DE" sz="6000" dirty="0">
+              <a:t>Stop breaking lines like this in Python</a:t>
+            </a:r>
+            <a:endParaRPr lang="en-DE" sz="7200" dirty="0">
               <a:latin typeface="Patrick Hand" pitchFamily="2" charset="77"/>
             </a:endParaRPr>
           </a:p>
@@ -5563,7 +5511,7 @@
         </p:nvCxnSpPr>
         <p:spPr>
           <a:xfrm>
-            <a:off x="223579" y="10279545"/>
+            <a:off x="223579" y="7386445"/>
             <a:ext cx="9838255" cy="0"/>
           </a:xfrm>
           <a:prstGeom prst="line">
@@ -5607,10 +5555,10 @@
           <p:nvPr/>
         </p:nvPicPr>
         <p:blipFill>
-          <a:blip r:embed="rId4">
+          <a:blip r:embed="rId5">
             <a:extLst>
               <a:ext uri="{96DAC541-7B7A-43D3-8B79-37D633B846F1}">
-                <asvg:svgBlip xmlns:asvg="http://schemas.microsoft.com/office/drawing/2016/SVG/main" r:embed="rId5"/>
+                <asvg:svgBlip xmlns:asvg="http://schemas.microsoft.com/office/drawing/2016/SVG/main" r:embed="rId6"/>
               </a:ext>
             </a:extLst>
           </a:blip>
@@ -5620,7 +5568,7 @@
         </p:blipFill>
         <p:spPr>
           <a:xfrm>
-            <a:off x="7018372" y="11444957"/>
+            <a:off x="5399439" y="8761723"/>
             <a:ext cx="914400" cy="914400"/>
           </a:xfrm>
           <a:prstGeom prst="rect">
@@ -5643,10 +5591,10 @@
           <p:nvPr/>
         </p:nvPicPr>
         <p:blipFill>
-          <a:blip r:embed="rId6">
+          <a:blip r:embed="rId7">
             <a:extLst>
               <a:ext uri="{96DAC541-7B7A-43D3-8B79-37D633B846F1}">
-                <asvg:svgBlip xmlns:asvg="http://schemas.microsoft.com/office/drawing/2016/SVG/main" r:embed="rId7"/>
+                <asvg:svgBlip xmlns:asvg="http://schemas.microsoft.com/office/drawing/2016/SVG/main" r:embed="rId8"/>
               </a:ext>
             </a:extLst>
           </a:blip>
@@ -5656,7 +5604,7 @@
         </p:blipFill>
         <p:spPr>
           <a:xfrm>
-            <a:off x="7018372" y="9030758"/>
+            <a:off x="5399439" y="5912814"/>
             <a:ext cx="914400" cy="914400"/>
           </a:xfrm>
           <a:prstGeom prst="rect">
@@ -8403,7 +8351,7 @@
         </p:nvSpPr>
         <p:spPr>
           <a:xfrm>
-            <a:off x="223306" y="4693304"/>
+            <a:off x="223306" y="3089361"/>
             <a:ext cx="9838800" cy="1236996"/>
           </a:xfrm>
           <a:prstGeom prst="rect">
@@ -8471,9 +8419,9 @@
           </a:bodyPr>
           <a:lstStyle/>
           <a:p>
-            <a:pPr marL="0" algn="ctr" defTabSz="457200" rtl="0" eaLnBrk="1" latinLnBrk="0" hangingPunct="1"/>
-            <a:r>
-              <a:rPr lang="en-US" sz="5400" b="1" dirty="0">
+            <a:pPr algn="ctr"/>
+            <a:r>
+              <a:rPr lang="en-US" sz="6600" b="1" dirty="0">
                 <a:ln w="12700">
                   <a:solidFill>
                     <a:schemeClr val="bg1"/>
@@ -8492,9 +8440,9 @@
                 </a:effectLst>
                 <a:latin typeface="+mj-lt"/>
               </a:rPr>
-              <a:t>Remove Fields with Omit</a:t>
-            </a:r>
-            <a:endParaRPr lang="en-GB" sz="4800" b="1" dirty="0">
+              <a:t>Callbacks: avoid ?:</a:t>
+            </a:r>
+            <a:endParaRPr lang="en-GB" sz="6000" b="1" dirty="0">
               <a:ln w="12700">
                 <a:solidFill>
                   <a:schemeClr val="bg1"/>
@@ -8530,7 +8478,7 @@
         </p:nvSpPr>
         <p:spPr>
           <a:xfrm>
-            <a:off x="223306" y="10049621"/>
+            <a:off x="403306" y="11698535"/>
             <a:ext cx="9478800" cy="1966526"/>
           </a:xfrm>
           <a:prstGeom prst="rect">
@@ -8561,7 +8509,7 @@
                 </a:solidFill>
                 <a:latin typeface="Patrick Hand" pitchFamily="2" charset="77"/>
               </a:rPr>
-              <a:t>Create new models by excluding specific properties</a:t>
+              <a:t>Stop making callback params optional in TypeScript</a:t>
             </a:r>
             <a:endParaRPr lang="en-DE" sz="6600" b="1" dirty="0">
               <a:ln w="22225">
@@ -8603,8 +8551,156 @@
         </p:blipFill>
         <p:spPr>
           <a:xfrm>
-            <a:off x="321693" y="4788788"/>
+            <a:off x="321693" y="3184845"/>
             <a:ext cx="1062000" cy="1062000"/>
+          </a:xfrm>
+          <a:prstGeom prst="rect">
+            <a:avLst/>
+          </a:prstGeom>
+        </p:spPr>
+      </p:pic>
+      <p:pic>
+        <p:nvPicPr>
+          <p:cNvPr id="2" name="Picture 1">
+            <a:extLst>
+              <a:ext uri="{FF2B5EF4-FFF2-40B4-BE49-F238E27FC236}">
+                <a16:creationId xmlns:a16="http://schemas.microsoft.com/office/drawing/2014/main" id="{3D52B6AB-9DAB-5B3E-861A-F1EF5121A58B}"/>
+              </a:ext>
+            </a:extLst>
+          </p:cNvPr>
+          <p:cNvPicPr>
+            <a:picLocks noChangeAspect="1"/>
+          </p:cNvPicPr>
+          <p:nvPr/>
+        </p:nvPicPr>
+        <p:blipFill rotWithShape="1">
+          <a:blip r:embed="rId4"/>
+          <a:srcRect l="12556" t="15581" r="8949" b="12861"/>
+          <a:stretch>
+            <a:fillRect/>
+          </a:stretch>
+        </p:blipFill>
+        <p:spPr>
+          <a:xfrm>
+            <a:off x="223306" y="4414909"/>
+            <a:ext cx="9838800" cy="7107144"/>
+          </a:xfrm>
+          <a:prstGeom prst="rect">
+            <a:avLst/>
+          </a:prstGeom>
+        </p:spPr>
+      </p:pic>
+      <p:cxnSp>
+        <p:nvCxnSpPr>
+          <p:cNvPr id="5" name="Straight Connector 4">
+            <a:extLst>
+              <a:ext uri="{FF2B5EF4-FFF2-40B4-BE49-F238E27FC236}">
+                <a16:creationId xmlns:a16="http://schemas.microsoft.com/office/drawing/2014/main" id="{ABF597FB-7C4D-10C6-9E0E-1B1037C57E69}"/>
+              </a:ext>
+            </a:extLst>
+          </p:cNvPr>
+          <p:cNvCxnSpPr>
+            <a:cxnSpLocks/>
+          </p:cNvCxnSpPr>
+          <p:nvPr/>
+        </p:nvCxnSpPr>
+        <p:spPr>
+          <a:xfrm>
+            <a:off x="233306" y="8258407"/>
+            <a:ext cx="9813810" cy="0"/>
+          </a:xfrm>
+          <a:prstGeom prst="line">
+            <a:avLst/>
+          </a:prstGeom>
+          <a:ln w="38100">
+            <a:solidFill>
+              <a:schemeClr val="bg1"/>
+            </a:solidFill>
+            <a:headEnd type="none"/>
+            <a:tailEnd type="none" w="lg" len="lg"/>
+          </a:ln>
+        </p:spPr>
+        <p:style>
+          <a:lnRef idx="1">
+            <a:schemeClr val="accent1"/>
+          </a:lnRef>
+          <a:fillRef idx="0">
+            <a:schemeClr val="accent1"/>
+          </a:fillRef>
+          <a:effectRef idx="0">
+            <a:schemeClr val="accent1"/>
+          </a:effectRef>
+          <a:fontRef idx="minor">
+            <a:schemeClr val="tx1"/>
+          </a:fontRef>
+        </p:style>
+      </p:cxnSp>
+      <p:pic>
+        <p:nvPicPr>
+          <p:cNvPr id="6" name="Graphic 5" descr="Shield Tick with solid fill">
+            <a:extLst>
+              <a:ext uri="{FF2B5EF4-FFF2-40B4-BE49-F238E27FC236}">
+                <a16:creationId xmlns:a16="http://schemas.microsoft.com/office/drawing/2014/main" id="{E3E1FC09-DDEB-ADBE-01B1-B9BEE0A103CD}"/>
+              </a:ext>
+            </a:extLst>
+          </p:cNvPr>
+          <p:cNvPicPr>
+            <a:picLocks noChangeAspect="1"/>
+          </p:cNvPicPr>
+          <p:nvPr/>
+        </p:nvPicPr>
+        <p:blipFill>
+          <a:blip r:embed="rId5">
+            <a:extLst>
+              <a:ext uri="{96DAC541-7B7A-43D3-8B79-37D633B846F1}">
+                <asvg:svgBlip xmlns:asvg="http://schemas.microsoft.com/office/drawing/2016/SVG/main" r:embed="rId6"/>
+              </a:ext>
+            </a:extLst>
+          </a:blip>
+          <a:stretch>
+            <a:fillRect/>
+          </a:stretch>
+        </p:blipFill>
+        <p:spPr>
+          <a:xfrm>
+            <a:off x="5425763" y="9407636"/>
+            <a:ext cx="914400" cy="914400"/>
+          </a:xfrm>
+          <a:prstGeom prst="rect">
+            <a:avLst/>
+          </a:prstGeom>
+        </p:spPr>
+      </p:pic>
+      <p:pic>
+        <p:nvPicPr>
+          <p:cNvPr id="7" name="Graphic 6" descr="Close with solid fill">
+            <a:extLst>
+              <a:ext uri="{FF2B5EF4-FFF2-40B4-BE49-F238E27FC236}">
+                <a16:creationId xmlns:a16="http://schemas.microsoft.com/office/drawing/2014/main" id="{01F7B3A8-6536-282D-0ADF-BB7B2FB1AEB4}"/>
+              </a:ext>
+            </a:extLst>
+          </p:cNvPr>
+          <p:cNvPicPr>
+            <a:picLocks noChangeAspect="1"/>
+          </p:cNvPicPr>
+          <p:nvPr/>
+        </p:nvPicPr>
+        <p:blipFill>
+          <a:blip r:embed="rId7">
+            <a:extLst>
+              <a:ext uri="{96DAC541-7B7A-43D3-8B79-37D633B846F1}">
+                <asvg:svgBlip xmlns:asvg="http://schemas.microsoft.com/office/drawing/2016/SVG/main" r:embed="rId8"/>
+              </a:ext>
+            </a:extLst>
+          </a:blip>
+          <a:stretch>
+            <a:fillRect/>
+          </a:stretch>
+        </p:blipFill>
+        <p:spPr>
+          <a:xfrm>
+            <a:off x="5425763" y="6410351"/>
+            <a:ext cx="914400" cy="914400"/>
           </a:xfrm>
           <a:prstGeom prst="rect">
             <a:avLst/>
@@ -8673,8 +8769,8 @@
         </p:nvSpPr>
         <p:spPr>
           <a:xfrm>
-            <a:off x="223306" y="4911964"/>
-            <a:ext cx="9838800" cy="1236996"/>
+            <a:off x="128497" y="3188097"/>
+            <a:ext cx="10028419" cy="1236996"/>
           </a:xfrm>
           <a:prstGeom prst="rect">
             <a:avLst/>
@@ -8743,24 +8839,45 @@
           </a:bodyPr>
           <a:lstStyle/>
           <a:p>
-            <a:pPr marL="0" algn="ctr" defTabSz="457200" rtl="0" eaLnBrk="1" latinLnBrk="0" hangingPunct="1"/>
-            <a:r>
-              <a:rPr lang="en-GB" sz="6600" b="1" dirty="0">
-                <a:ln w="0"/>
+            <a:pPr algn="ctr"/>
+            <a:r>
+              <a:rPr lang="en-GB" sz="6000" b="1" dirty="0">
                 <a:solidFill>
-                  <a:schemeClr val="tx1"/>
+                  <a:srgbClr val="00B050"/>
                 </a:solidFill>
-                <a:effectLst>
-                  <a:outerShdw blurRad="38100" dist="19050" dir="2700000" algn="tl" rotWithShape="0">
-                    <a:schemeClr val="dk1">
-                      <a:alpha val="40000"/>
-                    </a:schemeClr>
-                  </a:outerShdw>
-                </a:effectLst>
-                <a:latin typeface="+mj-lt"/>
               </a:rPr>
-              <a:t>Pick what you need</a:t>
-            </a:r>
+              <a:t>Verbose </a:t>
+            </a:r>
+            <a:r>
+              <a:rPr lang="en-GB" sz="6000" b="1" dirty="0">
+                <a:solidFill>
+                  <a:srgbClr val="C00000"/>
+                </a:solidFill>
+              </a:rPr>
+              <a:t>vs</a:t>
+            </a:r>
+            <a:r>
+              <a:rPr lang="en-GB" sz="6000" b="1" dirty="0">
+                <a:solidFill>
+                  <a:srgbClr val="00B050"/>
+                </a:solidFill>
+              </a:rPr>
+              <a:t> Short Class</a:t>
+            </a:r>
+            <a:endParaRPr lang="en-GB" sz="28700" b="1" dirty="0">
+              <a:ln w="0"/>
+              <a:solidFill>
+                <a:srgbClr val="00B050"/>
+              </a:solidFill>
+              <a:effectLst>
+                <a:outerShdw blurRad="38100" dist="19050" dir="2700000" algn="tl" rotWithShape="0">
+                  <a:schemeClr val="dk1">
+                    <a:alpha val="40000"/>
+                  </a:schemeClr>
+                </a:outerShdw>
+              </a:effectLst>
+              <a:latin typeface="+mj-lt"/>
+            </a:endParaRPr>
           </a:p>
         </p:txBody>
       </p:sp>
@@ -8841,7 +8958,7 @@
         </p:blipFill>
         <p:spPr>
           <a:xfrm>
-            <a:off x="321693" y="5007448"/>
+            <a:off x="201773" y="3283581"/>
             <a:ext cx="1062000" cy="1062000"/>
           </a:xfrm>
           <a:prstGeom prst="rect">
@@ -8849,6 +8966,157 @@
           </a:prstGeom>
         </p:spPr>
       </p:pic>
+      <p:pic>
+        <p:nvPicPr>
+          <p:cNvPr id="2" name="Picture 1">
+            <a:extLst>
+              <a:ext uri="{FF2B5EF4-FFF2-40B4-BE49-F238E27FC236}">
+                <a16:creationId xmlns:a16="http://schemas.microsoft.com/office/drawing/2014/main" id="{25FB4109-0620-2F2D-FEFE-70FEEDC62514}"/>
+              </a:ext>
+            </a:extLst>
+          </p:cNvPr>
+          <p:cNvPicPr>
+            <a:picLocks noChangeAspect="1"/>
+          </p:cNvPicPr>
+          <p:nvPr/>
+        </p:nvPicPr>
+        <p:blipFill rotWithShape="1">
+          <a:blip r:embed="rId4"/>
+          <a:srcRect l="17081" t="17341" r="11312" b="11476"/>
+          <a:stretch>
+            <a:fillRect/>
+          </a:stretch>
+        </p:blipFill>
+        <p:spPr>
+          <a:xfrm>
+            <a:off x="127906" y="4520577"/>
+            <a:ext cx="10029600" cy="9410753"/>
+          </a:xfrm>
+          <a:prstGeom prst="rect">
+            <a:avLst/>
+          </a:prstGeom>
+        </p:spPr>
+      </p:pic>
+      <p:sp>
+        <p:nvSpPr>
+          <p:cNvPr id="5" name="TextBox 4">
+            <a:extLst>
+              <a:ext uri="{FF2B5EF4-FFF2-40B4-BE49-F238E27FC236}">
+                <a16:creationId xmlns:a16="http://schemas.microsoft.com/office/drawing/2014/main" id="{F2E84A01-D94E-DF8E-9132-2584D4857955}"/>
+              </a:ext>
+            </a:extLst>
+          </p:cNvPr>
+          <p:cNvSpPr txBox="1"/>
+          <p:nvPr/>
+        </p:nvSpPr>
+        <p:spPr>
+          <a:xfrm>
+            <a:off x="403306" y="13992025"/>
+            <a:ext cx="9478800" cy="1107878"/>
+          </a:xfrm>
+          <a:prstGeom prst="rect">
+            <a:avLst/>
+          </a:prstGeom>
+          <a:noFill/>
+        </p:spPr>
+        <p:txBody>
+          <a:bodyPr wrap="square" rtlCol="0">
+            <a:noAutofit/>
+          </a:bodyPr>
+          <a:lstStyle/>
+          <a:p>
+            <a:pPr algn="ctr"/>
+            <a:r>
+              <a:rPr lang="en-GB" sz="6600" b="1" dirty="0">
+                <a:ln w="13462">
+                  <a:solidFill>
+                    <a:schemeClr val="bg1"/>
+                  </a:solidFill>
+                  <a:prstDash val="solid"/>
+                </a:ln>
+                <a:solidFill>
+                  <a:schemeClr val="tx1">
+                    <a:lumMod val="85000"/>
+                    <a:lumOff val="15000"/>
+                  </a:schemeClr>
+                </a:solidFill>
+                <a:effectLst>
+                  <a:outerShdw dist="38100" dir="2700000" algn="bl" rotWithShape="0">
+                    <a:schemeClr val="accent5"/>
+                  </a:outerShdw>
+                </a:effectLst>
+                <a:latin typeface="Patrick Hand" pitchFamily="2" charset="77"/>
+              </a:rPr>
+              <a:t>Which approach do you prefer?</a:t>
+            </a:r>
+            <a:endParaRPr lang="en-DE" sz="6600" b="1" dirty="0">
+              <a:ln w="13462">
+                <a:solidFill>
+                  <a:schemeClr val="bg1"/>
+                </a:solidFill>
+                <a:prstDash val="solid"/>
+              </a:ln>
+              <a:solidFill>
+                <a:schemeClr val="tx1">
+                  <a:lumMod val="85000"/>
+                  <a:lumOff val="15000"/>
+                </a:schemeClr>
+              </a:solidFill>
+              <a:effectLst>
+                <a:outerShdw dist="38100" dir="2700000" algn="bl" rotWithShape="0">
+                  <a:schemeClr val="accent5"/>
+                </a:outerShdw>
+              </a:effectLst>
+              <a:latin typeface="Patrick Hand" pitchFamily="2" charset="77"/>
+            </a:endParaRPr>
+          </a:p>
+        </p:txBody>
+      </p:sp>
+      <p:cxnSp>
+        <p:nvCxnSpPr>
+          <p:cNvPr id="6" name="Straight Connector 5">
+            <a:extLst>
+              <a:ext uri="{FF2B5EF4-FFF2-40B4-BE49-F238E27FC236}">
+                <a16:creationId xmlns:a16="http://schemas.microsoft.com/office/drawing/2014/main" id="{58737F9C-22C6-342B-1BF9-5BF8939687AC}"/>
+              </a:ext>
+            </a:extLst>
+          </p:cNvPr>
+          <p:cNvCxnSpPr>
+            <a:cxnSpLocks/>
+          </p:cNvCxnSpPr>
+          <p:nvPr/>
+        </p:nvCxnSpPr>
+        <p:spPr>
+          <a:xfrm>
+            <a:off x="98396" y="9487598"/>
+            <a:ext cx="10058520" cy="0"/>
+          </a:xfrm>
+          <a:prstGeom prst="line">
+            <a:avLst/>
+          </a:prstGeom>
+          <a:ln w="38100">
+            <a:solidFill>
+              <a:schemeClr val="bg1"/>
+            </a:solidFill>
+            <a:headEnd type="none"/>
+            <a:tailEnd type="none" w="lg" len="lg"/>
+          </a:ln>
+        </p:spPr>
+        <p:style>
+          <a:lnRef idx="1">
+            <a:schemeClr val="accent1"/>
+          </a:lnRef>
+          <a:fillRef idx="0">
+            <a:schemeClr val="accent1"/>
+          </a:fillRef>
+          <a:effectRef idx="0">
+            <a:schemeClr val="accent1"/>
+          </a:effectRef>
+          <a:fontRef idx="minor">
+            <a:schemeClr val="tx1"/>
+          </a:fontRef>
+        </p:style>
+      </p:cxnSp>
     </p:spTree>
     <p:extLst>
       <p:ext uri="{BB962C8B-B14F-4D97-AF65-F5344CB8AC3E}">

</xml_diff>